<commit_message>
style: update UI to high-contrast executive white theme
</commit_message>
<xml_diff>
--- a/backend/generated_mtm_report.pptx
+++ b/backend/generated_mtm_report.pptx
@@ -11,6 +11,11 @@
     <p:sldId id="256" r:id="rId2"/>
     <p:sldId id="258" r:id="rId3"/>
     <p:sldId id="260" r:id="rId4"/>
+    <p:sldId id="261" r:id="rId5"/>
+    <p:sldId id="262" r:id="rId6"/>
+    <p:sldId id="263" r:id="rId7"/>
+    <p:sldId id="270" r:id="rId8"/>
+    <p:sldId id="271" r:id="rId9"/>
     <p:sldId id="259" r:id="rId16"/>
   </p:sldIdLst>
   <p:sldSz cx="9144000" cy="5143500" type="screen16x9"/>
@@ -261,6 +266,590 @@
     </p:ext>
   </p:extLst>
 </p:presentation>
+</file>
+
+<file path=ppt/charts/chart1.xml><?xml version="1.0" encoding="utf-8"?>
+<c:chartSpace xmlns:c="http://schemas.openxmlformats.org/drawingml/2006/chart" xmlns:a="http://schemas.openxmlformats.org/drawingml/2006/main" xmlns:r="http://schemas.openxmlformats.org/officeDocument/2006/relationships">
+  <c:date1904 val="0"/>
+  <c:chart>
+    <c:autoTitleDeleted val="0"/>
+    <c:plotArea>
+      <c:barChart>
+        <c:barDir val="col"/>
+        <c:grouping val="clustered"/>
+        <c:ser>
+          <c:idx val="0"/>
+          <c:order val="0"/>
+          <c:tx>
+            <c:strRef>
+              <c:f>Sheet1!$B$1</c:f>
+              <c:strCache>
+                <c:ptCount val="1"/>
+                <c:pt idx="0">
+                  <c:v>SL Kirim (%)</c:v>
+                </c:pt>
+              </c:strCache>
+            </c:strRef>
+          </c:tx>
+          <c:spPr>
+            <a:solidFill>
+              <a:srgbClr val="C00000"/>
+            </a:solidFill>
+          </c:spPr>
+          <c:cat>
+            <c:strRef>
+              <c:f>Sheet1!$A$2:$A$9</c:f>
+              <c:strCache>
+                <c:ptCount val="8"/>
+                <c:pt idx="0">
+                  <c:v>JAN-2026</c:v>
+                </c:pt>
+                <c:pt idx="1">
+                  <c:v>FEB-2026</c:v>
+                </c:pt>
+                <c:pt idx="2">
+                  <c:v>MAR-2026</c:v>
+                </c:pt>
+                <c:pt idx="3">
+                  <c:v>APR-2026</c:v>
+                </c:pt>
+                <c:pt idx="4">
+                  <c:v>MEI-2026</c:v>
+                </c:pt>
+                <c:pt idx="5">
+                  <c:v>JUN-2026</c:v>
+                </c:pt>
+                <c:pt idx="6">
+                  <c:v>JUL-2026</c:v>
+                </c:pt>
+                <c:pt idx="7">
+                  <c:v>AGU-2026</c:v>
+                </c:pt>
+              </c:strCache>
+            </c:strRef>
+          </c:cat>
+          <c:val>
+            <c:numRef>
+              <c:f>Sheet1!$B$2:$B$9</c:f>
+              <c:numCache>
+                <c:formatCode>General</c:formatCode>
+                <c:ptCount val="8"/>
+                <c:pt idx="0">
+                  <c:v>73.2</c:v>
+                </c:pt>
+                <c:pt idx="1">
+                  <c:v>77.1</c:v>
+                </c:pt>
+                <c:pt idx="2">
+                  <c:v>86.1</c:v>
+                </c:pt>
+                <c:pt idx="3">
+                  <c:v>89.0</c:v>
+                </c:pt>
+                <c:pt idx="4">
+                  <c:v>90.7</c:v>
+                </c:pt>
+                <c:pt idx="5">
+                  <c:v>91.2</c:v>
+                </c:pt>
+                <c:pt idx="6">
+                  <c:v>89.7</c:v>
+                </c:pt>
+                <c:pt idx="7">
+                  <c:v>90.2</c:v>
+                </c:pt>
+              </c:numCache>
+            </c:numRef>
+          </c:val>
+        </c:ser>
+        <c:ser>
+          <c:idx val="1"/>
+          <c:order val="1"/>
+          <c:tx>
+            <c:strRef>
+              <c:f>Sheet1!$C$1</c:f>
+              <c:strCache>
+                <c:ptCount val="1"/>
+                <c:pt idx="0">
+                  <c:v>SL Realisasi (%)</c:v>
+                </c:pt>
+              </c:strCache>
+            </c:strRef>
+          </c:tx>
+          <c:spPr>
+            <a:solidFill>
+              <a:srgbClr val="2563EB"/>
+            </a:solidFill>
+          </c:spPr>
+          <c:cat>
+            <c:strRef>
+              <c:f>Sheet1!$A$2:$A$9</c:f>
+              <c:strCache>
+                <c:ptCount val="8"/>
+                <c:pt idx="0">
+                  <c:v>JAN-2026</c:v>
+                </c:pt>
+                <c:pt idx="1">
+                  <c:v>FEB-2026</c:v>
+                </c:pt>
+                <c:pt idx="2">
+                  <c:v>MAR-2026</c:v>
+                </c:pt>
+                <c:pt idx="3">
+                  <c:v>APR-2026</c:v>
+                </c:pt>
+                <c:pt idx="4">
+                  <c:v>MEI-2026</c:v>
+                </c:pt>
+                <c:pt idx="5">
+                  <c:v>JUN-2026</c:v>
+                </c:pt>
+                <c:pt idx="6">
+                  <c:v>JUL-2026</c:v>
+                </c:pt>
+                <c:pt idx="7">
+                  <c:v>AGU-2026</c:v>
+                </c:pt>
+              </c:strCache>
+            </c:strRef>
+          </c:cat>
+          <c:val>
+            <c:numRef>
+              <c:f>Sheet1!$C$2:$C$9</c:f>
+              <c:numCache>
+                <c:formatCode>General</c:formatCode>
+                <c:ptCount val="8"/>
+                <c:pt idx="0">
+                  <c:v>72.4</c:v>
+                </c:pt>
+                <c:pt idx="1">
+                  <c:v>76.2</c:v>
+                </c:pt>
+                <c:pt idx="2">
+                  <c:v>84.5</c:v>
+                </c:pt>
+                <c:pt idx="3">
+                  <c:v>88.1</c:v>
+                </c:pt>
+                <c:pt idx="4">
+                  <c:v>90.1</c:v>
+                </c:pt>
+                <c:pt idx="5">
+                  <c:v>90.5</c:v>
+                </c:pt>
+                <c:pt idx="6">
+                  <c:v>89.0</c:v>
+                </c:pt>
+                <c:pt idx="7">
+                  <c:v>89.5</c:v>
+                </c:pt>
+              </c:numCache>
+            </c:numRef>
+          </c:val>
+        </c:ser>
+        <c:dLbls>
+          <c:numFmt formatCode="0.0&quot;%&quot;" sourceLinked="0"/>
+          <c:txPr>
+            <a:bodyPr/>
+            <a:lstStyle/>
+            <a:p>
+              <a:pPr>
+                <a:defRPr sz="700" b="1">
+                  <a:solidFill>
+                    <a:srgbClr val="0F172A"/>
+                  </a:solidFill>
+                </a:defRPr>
+              </a:pPr>
+            </a:p>
+          </c:txPr>
+          <c:dLblPos val="outEnd"/>
+          <c:showLegendKey val="0"/>
+          <c:showVal val="1"/>
+          <c:showCatName val="0"/>
+          <c:showSerName val="0"/>
+          <c:showPercent val="0"/>
+          <c:showBubbleSize val="0"/>
+          <c:showLeaderLines val="1"/>
+        </c:dLbls>
+        <c:gapWidth val="55"/>
+        <c:overlap val="-10"/>
+        <c:axId val="-2068027336"/>
+        <c:axId val="-2113994440"/>
+      </c:barChart>
+      <c:catAx>
+        <c:axId val="-2068027336"/>
+        <c:scaling>
+          <c:orientation val="minMax"/>
+        </c:scaling>
+        <c:delete val="0"/>
+        <c:axPos val="b"/>
+        <c:majorTickMark val="out"/>
+        <c:minorTickMark val="none"/>
+        <c:tickLblPos val="nextTo"/>
+        <c:txPr>
+          <a:bodyPr/>
+          <a:lstStyle/>
+          <a:p>
+            <a:pPr>
+              <a:defRPr sz="850" b="1">
+                <a:solidFill>
+                  <a:srgbClr val="1E293B"/>
+                </a:solidFill>
+              </a:defRPr>
+            </a:pPr>
+          </a:p>
+        </c:txPr>
+        <c:crossAx val="-2113994440"/>
+        <c:crosses val="autoZero"/>
+        <c:auto val="1"/>
+        <c:lblAlgn val="ctr"/>
+        <c:lblOffset val="100"/>
+        <c:noMultiLvlLbl val="0"/>
+      </c:catAx>
+      <c:valAx>
+        <c:axId val="-2113994440"/>
+        <c:scaling>
+          <c:max val="115.0"/>
+          <c:min val="0.0"/>
+        </c:scaling>
+        <c:delete val="0"/>
+        <c:axPos val="l"/>
+        <c:majorTickMark val="out"/>
+        <c:minorTickMark val="none"/>
+        <c:tickLblPos val="nextTo"/>
+        <c:txPr>
+          <a:bodyPr/>
+          <a:lstStyle/>
+          <a:p>
+            <a:pPr>
+              <a:defRPr sz="800">
+                <a:solidFill>
+                  <a:srgbClr val="64748B"/>
+                </a:solidFill>
+              </a:defRPr>
+            </a:pPr>
+          </a:p>
+        </c:txPr>
+        <c:crossAx val="-2068027336"/>
+        <c:crosses val="autoZero"/>
+        <c:majorUnit val="20.0"/>
+      </c:valAx>
+    </c:plotArea>
+    <c:legend>
+      <c:legendPos val="t"/>
+      <c:overlay val="0"/>
+      <c:txPr>
+        <a:bodyPr/>
+        <a:lstStyle/>
+        <a:p>
+          <a:pPr>
+            <a:defRPr sz="850"/>
+          </a:pPr>
+        </a:p>
+      </c:txPr>
+    </c:legend>
+    <c:dispBlanksAs val="gap"/>
+  </c:chart>
+  <c:txPr>
+    <a:bodyPr/>
+    <a:lstStyle/>
+    <a:p>
+      <a:pPr>
+        <a:defRPr sz="1800"/>
+      </a:pPr>
+      <a:endParaRPr lang="en-US"/>
+    </a:p>
+  </c:txPr>
+  <c:externalData r:id="rId1">
+    <c:autoUpdate val="0"/>
+  </c:externalData>
+</c:chartSpace>
+</file>
+
+<file path=ppt/charts/chart2.xml><?xml version="1.0" encoding="utf-8"?>
+<c:chartSpace xmlns:c="http://schemas.openxmlformats.org/drawingml/2006/chart" xmlns:a="http://schemas.openxmlformats.org/drawingml/2006/main" xmlns:r="http://schemas.openxmlformats.org/officeDocument/2006/relationships">
+  <c:date1904 val="0"/>
+  <c:chart>
+    <c:autoTitleDeleted val="0"/>
+    <c:plotArea>
+      <c:barChart>
+        <c:barDir val="col"/>
+        <c:grouping val="clustered"/>
+        <c:ser>
+          <c:idx val="0"/>
+          <c:order val="0"/>
+          <c:tx>
+            <c:strRef>
+              <c:f>Sheet1!$B$1</c:f>
+              <c:strCache>
+                <c:ptCount val="1"/>
+                <c:pt idx="0">
+                  <c:v>SL Kirim (%)</c:v>
+                </c:pt>
+              </c:strCache>
+            </c:strRef>
+          </c:tx>
+          <c:spPr>
+            <a:solidFill>
+              <a:srgbClr val="C00000"/>
+            </a:solidFill>
+          </c:spPr>
+          <c:cat>
+            <c:strRef>
+              <c:f>Sheet1!$A$2:$A$8</c:f>
+              <c:strCache>
+                <c:ptCount val="7"/>
+                <c:pt idx="0">
+                  <c:v>GB 1</c:v>
+                </c:pt>
+                <c:pt idx="1">
+                  <c:v>GB 2</c:v>
+                </c:pt>
+                <c:pt idx="2">
+                  <c:v>GB 3</c:v>
+                </c:pt>
+                <c:pt idx="3">
+                  <c:v>GB 4</c:v>
+                </c:pt>
+                <c:pt idx="4">
+                  <c:v>GB 5</c:v>
+                </c:pt>
+                <c:pt idx="5">
+                  <c:v>GB 6</c:v>
+                </c:pt>
+                <c:pt idx="6">
+                  <c:v>GB ET</c:v>
+                </c:pt>
+              </c:strCache>
+            </c:strRef>
+          </c:cat>
+          <c:val>
+            <c:numRef>
+              <c:f>Sheet1!$B$2:$B$8</c:f>
+              <c:numCache>
+                <c:formatCode>General</c:formatCode>
+                <c:ptCount val="7"/>
+                <c:pt idx="0">
+                  <c:v>94.6</c:v>
+                </c:pt>
+                <c:pt idx="1">
+                  <c:v>90.4</c:v>
+                </c:pt>
+                <c:pt idx="2">
+                  <c:v>86.5</c:v>
+                </c:pt>
+                <c:pt idx="3">
+                  <c:v>90.7</c:v>
+                </c:pt>
+                <c:pt idx="4">
+                  <c:v>83.0</c:v>
+                </c:pt>
+                <c:pt idx="5">
+                  <c:v>96.8</c:v>
+                </c:pt>
+                <c:pt idx="6">
+                  <c:v>97.2</c:v>
+                </c:pt>
+              </c:numCache>
+            </c:numRef>
+          </c:val>
+        </c:ser>
+        <c:ser>
+          <c:idx val="1"/>
+          <c:order val="1"/>
+          <c:tx>
+            <c:strRef>
+              <c:f>Sheet1!$C$1</c:f>
+              <c:strCache>
+                <c:ptCount val="1"/>
+                <c:pt idx="0">
+                  <c:v>SL Realisasi (%)</c:v>
+                </c:pt>
+              </c:strCache>
+            </c:strRef>
+          </c:tx>
+          <c:spPr>
+            <a:solidFill>
+              <a:srgbClr val="2563EB"/>
+            </a:solidFill>
+          </c:spPr>
+          <c:cat>
+            <c:strRef>
+              <c:f>Sheet1!$A$2:$A$8</c:f>
+              <c:strCache>
+                <c:ptCount val="7"/>
+                <c:pt idx="0">
+                  <c:v>GB 1</c:v>
+                </c:pt>
+                <c:pt idx="1">
+                  <c:v>GB 2</c:v>
+                </c:pt>
+                <c:pt idx="2">
+                  <c:v>GB 3</c:v>
+                </c:pt>
+                <c:pt idx="3">
+                  <c:v>GB 4</c:v>
+                </c:pt>
+                <c:pt idx="4">
+                  <c:v>GB 5</c:v>
+                </c:pt>
+                <c:pt idx="5">
+                  <c:v>GB 6</c:v>
+                </c:pt>
+                <c:pt idx="6">
+                  <c:v>GB ET</c:v>
+                </c:pt>
+              </c:strCache>
+            </c:strRef>
+          </c:cat>
+          <c:val>
+            <c:numRef>
+              <c:f>Sheet1!$C$2:$C$8</c:f>
+              <c:numCache>
+                <c:formatCode>General</c:formatCode>
+                <c:ptCount val="7"/>
+                <c:pt idx="0">
+                  <c:v>94.3</c:v>
+                </c:pt>
+                <c:pt idx="1">
+                  <c:v>89.9</c:v>
+                </c:pt>
+                <c:pt idx="2">
+                  <c:v>85.8</c:v>
+                </c:pt>
+                <c:pt idx="3">
+                  <c:v>90.2</c:v>
+                </c:pt>
+                <c:pt idx="4">
+                  <c:v>82.2</c:v>
+                </c:pt>
+                <c:pt idx="5">
+                  <c:v>96.4</c:v>
+                </c:pt>
+                <c:pt idx="6">
+                  <c:v>84.4</c:v>
+                </c:pt>
+              </c:numCache>
+            </c:numRef>
+          </c:val>
+        </c:ser>
+        <c:dLbls>
+          <c:numFmt formatCode="0.0&quot;%&quot;" sourceLinked="0"/>
+          <c:txPr>
+            <a:bodyPr/>
+            <a:lstStyle/>
+            <a:p>
+              <a:pPr>
+                <a:defRPr sz="650" b="1">
+                  <a:solidFill>
+                    <a:srgbClr val="0F172A"/>
+                  </a:solidFill>
+                </a:defRPr>
+              </a:pPr>
+            </a:p>
+          </c:txPr>
+          <c:dLblPos val="outEnd"/>
+          <c:showLegendKey val="0"/>
+          <c:showVal val="1"/>
+          <c:showCatName val="0"/>
+          <c:showSerName val="0"/>
+          <c:showPercent val="0"/>
+          <c:showBubbleSize val="0"/>
+          <c:showLeaderLines val="1"/>
+        </c:dLbls>
+        <c:gapWidth val="55"/>
+        <c:overlap val="-10"/>
+        <c:axId val="-2068027336"/>
+        <c:axId val="-2113994440"/>
+      </c:barChart>
+      <c:catAx>
+        <c:axId val="-2068027336"/>
+        <c:scaling>
+          <c:orientation val="minMax"/>
+        </c:scaling>
+        <c:delete val="0"/>
+        <c:axPos val="b"/>
+        <c:majorTickMark val="out"/>
+        <c:minorTickMark val="none"/>
+        <c:tickLblPos val="nextTo"/>
+        <c:txPr>
+          <a:bodyPr/>
+          <a:lstStyle/>
+          <a:p>
+            <a:pPr>
+              <a:defRPr sz="750" b="1">
+                <a:solidFill>
+                  <a:srgbClr val="1E293B"/>
+                </a:solidFill>
+              </a:defRPr>
+            </a:pPr>
+          </a:p>
+        </c:txPr>
+        <c:crossAx val="-2113994440"/>
+        <c:crosses val="autoZero"/>
+        <c:auto val="1"/>
+        <c:lblAlgn val="ctr"/>
+        <c:lblOffset val="100"/>
+        <c:noMultiLvlLbl val="0"/>
+      </c:catAx>
+      <c:valAx>
+        <c:axId val="-2113994440"/>
+        <c:scaling>
+          <c:max val="115.0"/>
+          <c:min val="0.0"/>
+        </c:scaling>
+        <c:delete val="0"/>
+        <c:axPos val="l"/>
+        <c:majorTickMark val="out"/>
+        <c:minorTickMark val="none"/>
+        <c:tickLblPos val="nextTo"/>
+        <c:txPr>
+          <a:bodyPr/>
+          <a:lstStyle/>
+          <a:p>
+            <a:pPr>
+              <a:defRPr sz="750">
+                <a:solidFill>
+                  <a:srgbClr val="64748B"/>
+                </a:solidFill>
+              </a:defRPr>
+            </a:pPr>
+          </a:p>
+        </c:txPr>
+        <c:crossAx val="-2068027336"/>
+        <c:crosses val="autoZero"/>
+        <c:majorUnit val="20.0"/>
+      </c:valAx>
+    </c:plotArea>
+    <c:legend>
+      <c:legendPos val="t"/>
+      <c:overlay val="0"/>
+      <c:txPr>
+        <a:bodyPr/>
+        <a:lstStyle/>
+        <a:p>
+          <a:pPr>
+            <a:defRPr sz="800"/>
+          </a:pPr>
+        </a:p>
+      </c:txPr>
+    </c:legend>
+    <c:dispBlanksAs val="gap"/>
+  </c:chart>
+  <c:txPr>
+    <a:bodyPr/>
+    <a:lstStyle/>
+    <a:p>
+      <a:pPr>
+        <a:defRPr sz="1800"/>
+      </a:pPr>
+      <a:endParaRPr lang="en-US"/>
+    </a:p>
+  </c:txPr>
+  <c:externalData r:id="rId1">
+    <c:autoUpdate val="0"/>
+  </c:externalData>
+</c:chartSpace>
 </file>
 
 <file path=ppt/notesMasters/notesMaster1.xml><?xml version="1.0" encoding="utf-8"?>
@@ -1134,6 +1723,641 @@
     <p:extLst>
       <p:ext uri="{BB962C8B-B14F-4D97-AF65-F5344CB8AC3E}">
         <p14:creationId xmlns:p14="http://schemas.microsoft.com/office/powerpoint/2010/main" val="485946182"/>
+      </p:ext>
+    </p:extLst>
+  </p:cSld>
+  <p:clrMapOvr>
+    <a:masterClrMapping/>
+  </p:clrMapOvr>
+</p:notes>
+</file>
+
+<file path=ppt/notesSlides/notesSlide4.xml><?xml version="1.0" encoding="utf-8"?>
+<p:notes xmlns:a="http://schemas.openxmlformats.org/drawingml/2006/main" xmlns:r="http://schemas.openxmlformats.org/officeDocument/2006/relationships" xmlns:p="http://schemas.openxmlformats.org/presentationml/2006/main" showMasterSp="0" showMasterPhAnim="0">
+  <p:cSld>
+    <p:spTree>
+      <p:nvGrpSpPr>
+        <p:cNvPr id="1" name="Shape 62">
+          <a:extLst>
+            <a:ext uri="{FF2B5EF4-FFF2-40B4-BE49-F238E27FC236}">
+              <a16:creationId xmlns:a16="http://schemas.microsoft.com/office/drawing/2014/main" id="{DE284D1A-62E0-DBCC-7234-D5DE501990D0}"/>
+            </a:ext>
+          </a:extLst>
+        </p:cNvPr>
+        <p:cNvGrpSpPr/>
+        <p:nvPr/>
+      </p:nvGrpSpPr>
+      <p:grpSpPr>
+        <a:xfrm>
+          <a:off x="0" y="0"/>
+          <a:ext cx="0" cy="0"/>
+          <a:chOff x="0" y="0"/>
+          <a:chExt cx="0" cy="0"/>
+        </a:xfrm>
+      </p:grpSpPr>
+      <p:sp>
+        <p:nvSpPr>
+          <p:cNvPr id="63" name="Google Shape;63;g359956e13c8_0_5:notes">
+            <a:extLst>
+              <a:ext uri="{FF2B5EF4-FFF2-40B4-BE49-F238E27FC236}">
+                <a16:creationId xmlns:a16="http://schemas.microsoft.com/office/drawing/2014/main" id="{BAB957F0-5225-6791-1413-CB1D2B31DBF8}"/>
+              </a:ext>
+            </a:extLst>
+          </p:cNvPr>
+          <p:cNvSpPr>
+            <a:spLocks noGrp="1" noRot="1" noChangeAspect="1"/>
+          </p:cNvSpPr>
+          <p:nvPr>
+            <p:ph type="sldImg" idx="2"/>
+          </p:nvPr>
+        </p:nvSpPr>
+        <p:spPr>
+          <a:xfrm>
+            <a:off x="381000" y="685800"/>
+            <a:ext cx="6096000" cy="3429000"/>
+          </a:xfrm>
+          <a:custGeom>
+            <a:avLst/>
+            <a:gdLst/>
+            <a:ahLst/>
+            <a:cxnLst/>
+            <a:rect l="l" t="t" r="r" b="b"/>
+            <a:pathLst>
+              <a:path w="120000" h="120000" extrusionOk="0">
+                <a:moveTo>
+                  <a:pt x="0" y="0"/>
+                </a:moveTo>
+                <a:lnTo>
+                  <a:pt x="120000" y="0"/>
+                </a:lnTo>
+                <a:lnTo>
+                  <a:pt x="120000" y="120000"/>
+                </a:lnTo>
+                <a:lnTo>
+                  <a:pt x="0" y="120000"/>
+                </a:lnTo>
+                <a:close/>
+              </a:path>
+            </a:pathLst>
+          </a:custGeom>
+        </p:spPr>
+      </p:sp>
+      <p:sp>
+        <p:nvSpPr>
+          <p:cNvPr id="64" name="Google Shape;64;g359956e13c8_0_5:notes">
+            <a:extLst>
+              <a:ext uri="{FF2B5EF4-FFF2-40B4-BE49-F238E27FC236}">
+                <a16:creationId xmlns:a16="http://schemas.microsoft.com/office/drawing/2014/main" id="{B6AA508C-5278-13DC-895F-894029A6C3C0}"/>
+              </a:ext>
+            </a:extLst>
+          </p:cNvPr>
+          <p:cNvSpPr txBox="1">
+            <a:spLocks noGrp="1"/>
+          </p:cNvSpPr>
+          <p:nvPr>
+            <p:ph type="body" idx="1"/>
+          </p:nvPr>
+        </p:nvSpPr>
+        <p:spPr>
+          <a:xfrm>
+            <a:off x="685800" y="4343400"/>
+            <a:ext cx="5486400" cy="4114800"/>
+          </a:xfrm>
+          <a:prstGeom prst="rect">
+            <a:avLst/>
+          </a:prstGeom>
+        </p:spPr>
+        <p:txBody>
+          <a:bodyPr spcFirstLastPara="1" wrap="square" lIns="91425" tIns="91425" rIns="91425" bIns="91425" anchor="t" anchorCtr="0">
+            <a:noAutofit/>
+          </a:bodyPr>
+          <a:lstStyle/>
+          <a:p>
+            <a:pPr marL="0" lvl="0" indent="0" algn="l" rtl="0">
+              <a:spcBef>
+                <a:spcPts val="0"/>
+              </a:spcBef>
+              <a:spcAft>
+                <a:spcPts val="0"/>
+              </a:spcAft>
+              <a:buNone/>
+            </a:pPr>
+            <a:endParaRPr/>
+          </a:p>
+        </p:txBody>
+      </p:sp>
+    </p:spTree>
+    <p:extLst>
+      <p:ext uri="{BB962C8B-B14F-4D97-AF65-F5344CB8AC3E}">
+        <p14:creationId xmlns:p14="http://schemas.microsoft.com/office/powerpoint/2010/main" val="1943755025"/>
+      </p:ext>
+    </p:extLst>
+  </p:cSld>
+  <p:clrMapOvr>
+    <a:masterClrMapping/>
+  </p:clrMapOvr>
+</p:notes>
+</file>
+
+<file path=ppt/notesSlides/notesSlide5.xml><?xml version="1.0" encoding="utf-8"?>
+<p:notes xmlns:a="http://schemas.openxmlformats.org/drawingml/2006/main" xmlns:r="http://schemas.openxmlformats.org/officeDocument/2006/relationships" xmlns:p="http://schemas.openxmlformats.org/presentationml/2006/main" showMasterSp="0" showMasterPhAnim="0">
+  <p:cSld>
+    <p:spTree>
+      <p:nvGrpSpPr>
+        <p:cNvPr id="1" name="Shape 62">
+          <a:extLst>
+            <a:ext uri="{FF2B5EF4-FFF2-40B4-BE49-F238E27FC236}">
+              <a16:creationId xmlns:a16="http://schemas.microsoft.com/office/drawing/2014/main" id="{8D401C26-99B9-4C57-41F3-1E6315960DAA}"/>
+            </a:ext>
+          </a:extLst>
+        </p:cNvPr>
+        <p:cNvGrpSpPr/>
+        <p:nvPr/>
+      </p:nvGrpSpPr>
+      <p:grpSpPr>
+        <a:xfrm>
+          <a:off x="0" y="0"/>
+          <a:ext cx="0" cy="0"/>
+          <a:chOff x="0" y="0"/>
+          <a:chExt cx="0" cy="0"/>
+        </a:xfrm>
+      </p:grpSpPr>
+      <p:sp>
+        <p:nvSpPr>
+          <p:cNvPr id="63" name="Google Shape;63;g359956e13c8_0_5:notes">
+            <a:extLst>
+              <a:ext uri="{FF2B5EF4-FFF2-40B4-BE49-F238E27FC236}">
+                <a16:creationId xmlns:a16="http://schemas.microsoft.com/office/drawing/2014/main" id="{FCC1B478-498C-1E53-7E62-5EF472F17C60}"/>
+              </a:ext>
+            </a:extLst>
+          </p:cNvPr>
+          <p:cNvSpPr>
+            <a:spLocks noGrp="1" noRot="1" noChangeAspect="1"/>
+          </p:cNvSpPr>
+          <p:nvPr>
+            <p:ph type="sldImg" idx="2"/>
+          </p:nvPr>
+        </p:nvSpPr>
+        <p:spPr>
+          <a:xfrm>
+            <a:off x="381000" y="685800"/>
+            <a:ext cx="6096000" cy="3429000"/>
+          </a:xfrm>
+          <a:custGeom>
+            <a:avLst/>
+            <a:gdLst/>
+            <a:ahLst/>
+            <a:cxnLst/>
+            <a:rect l="l" t="t" r="r" b="b"/>
+            <a:pathLst>
+              <a:path w="120000" h="120000" extrusionOk="0">
+                <a:moveTo>
+                  <a:pt x="0" y="0"/>
+                </a:moveTo>
+                <a:lnTo>
+                  <a:pt x="120000" y="0"/>
+                </a:lnTo>
+                <a:lnTo>
+                  <a:pt x="120000" y="120000"/>
+                </a:lnTo>
+                <a:lnTo>
+                  <a:pt x="0" y="120000"/>
+                </a:lnTo>
+                <a:close/>
+              </a:path>
+            </a:pathLst>
+          </a:custGeom>
+        </p:spPr>
+      </p:sp>
+      <p:sp>
+        <p:nvSpPr>
+          <p:cNvPr id="64" name="Google Shape;64;g359956e13c8_0_5:notes">
+            <a:extLst>
+              <a:ext uri="{FF2B5EF4-FFF2-40B4-BE49-F238E27FC236}">
+                <a16:creationId xmlns:a16="http://schemas.microsoft.com/office/drawing/2014/main" id="{65AF07AE-0081-A9CC-0D25-BFC0286B3259}"/>
+              </a:ext>
+            </a:extLst>
+          </p:cNvPr>
+          <p:cNvSpPr txBox="1">
+            <a:spLocks noGrp="1"/>
+          </p:cNvSpPr>
+          <p:nvPr>
+            <p:ph type="body" idx="1"/>
+          </p:nvPr>
+        </p:nvSpPr>
+        <p:spPr>
+          <a:xfrm>
+            <a:off x="685800" y="4343400"/>
+            <a:ext cx="5486400" cy="4114800"/>
+          </a:xfrm>
+          <a:prstGeom prst="rect">
+            <a:avLst/>
+          </a:prstGeom>
+        </p:spPr>
+        <p:txBody>
+          <a:bodyPr spcFirstLastPara="1" wrap="square" lIns="91425" tIns="91425" rIns="91425" bIns="91425" anchor="t" anchorCtr="0">
+            <a:noAutofit/>
+          </a:bodyPr>
+          <a:lstStyle/>
+          <a:p>
+            <a:pPr marL="0" lvl="0" indent="0" algn="l" rtl="0">
+              <a:spcBef>
+                <a:spcPts val="0"/>
+              </a:spcBef>
+              <a:spcAft>
+                <a:spcPts val="0"/>
+              </a:spcAft>
+              <a:buNone/>
+            </a:pPr>
+            <a:endParaRPr/>
+          </a:p>
+        </p:txBody>
+      </p:sp>
+    </p:spTree>
+    <p:extLst>
+      <p:ext uri="{BB962C8B-B14F-4D97-AF65-F5344CB8AC3E}">
+        <p14:creationId xmlns:p14="http://schemas.microsoft.com/office/powerpoint/2010/main" val="2205316297"/>
+      </p:ext>
+    </p:extLst>
+  </p:cSld>
+  <p:clrMapOvr>
+    <a:masterClrMapping/>
+  </p:clrMapOvr>
+</p:notes>
+</file>
+
+<file path=ppt/notesSlides/notesSlide6.xml><?xml version="1.0" encoding="utf-8"?>
+<p:notes xmlns:a="http://schemas.openxmlformats.org/drawingml/2006/main" xmlns:r="http://schemas.openxmlformats.org/officeDocument/2006/relationships" xmlns:p="http://schemas.openxmlformats.org/presentationml/2006/main" showMasterSp="0" showMasterPhAnim="0">
+  <p:cSld>
+    <p:spTree>
+      <p:nvGrpSpPr>
+        <p:cNvPr id="1" name="Shape 62">
+          <a:extLst>
+            <a:ext uri="{FF2B5EF4-FFF2-40B4-BE49-F238E27FC236}">
+              <a16:creationId xmlns:a16="http://schemas.microsoft.com/office/drawing/2014/main" id="{4B062785-C962-7269-5CC4-37033B826849}"/>
+            </a:ext>
+          </a:extLst>
+        </p:cNvPr>
+        <p:cNvGrpSpPr/>
+        <p:nvPr/>
+      </p:nvGrpSpPr>
+      <p:grpSpPr>
+        <a:xfrm>
+          <a:off x="0" y="0"/>
+          <a:ext cx="0" cy="0"/>
+          <a:chOff x="0" y="0"/>
+          <a:chExt cx="0" cy="0"/>
+        </a:xfrm>
+      </p:grpSpPr>
+      <p:sp>
+        <p:nvSpPr>
+          <p:cNvPr id="63" name="Google Shape;63;g359956e13c8_0_5:notes">
+            <a:extLst>
+              <a:ext uri="{FF2B5EF4-FFF2-40B4-BE49-F238E27FC236}">
+                <a16:creationId xmlns:a16="http://schemas.microsoft.com/office/drawing/2014/main" id="{B766D11F-2A5C-2BF2-AAAB-30C20DB47C6B}"/>
+              </a:ext>
+            </a:extLst>
+          </p:cNvPr>
+          <p:cNvSpPr>
+            <a:spLocks noGrp="1" noRot="1" noChangeAspect="1"/>
+          </p:cNvSpPr>
+          <p:nvPr>
+            <p:ph type="sldImg" idx="2"/>
+          </p:nvPr>
+        </p:nvSpPr>
+        <p:spPr>
+          <a:xfrm>
+            <a:off x="381000" y="685800"/>
+            <a:ext cx="6096000" cy="3429000"/>
+          </a:xfrm>
+          <a:custGeom>
+            <a:avLst/>
+            <a:gdLst/>
+            <a:ahLst/>
+            <a:cxnLst/>
+            <a:rect l="l" t="t" r="r" b="b"/>
+            <a:pathLst>
+              <a:path w="120000" h="120000" extrusionOk="0">
+                <a:moveTo>
+                  <a:pt x="0" y="0"/>
+                </a:moveTo>
+                <a:lnTo>
+                  <a:pt x="120000" y="0"/>
+                </a:lnTo>
+                <a:lnTo>
+                  <a:pt x="120000" y="120000"/>
+                </a:lnTo>
+                <a:lnTo>
+                  <a:pt x="0" y="120000"/>
+                </a:lnTo>
+                <a:close/>
+              </a:path>
+            </a:pathLst>
+          </a:custGeom>
+        </p:spPr>
+      </p:sp>
+      <p:sp>
+        <p:nvSpPr>
+          <p:cNvPr id="64" name="Google Shape;64;g359956e13c8_0_5:notes">
+            <a:extLst>
+              <a:ext uri="{FF2B5EF4-FFF2-40B4-BE49-F238E27FC236}">
+                <a16:creationId xmlns:a16="http://schemas.microsoft.com/office/drawing/2014/main" id="{B2853CED-A04C-A867-5202-ABDF3CD1FEE5}"/>
+              </a:ext>
+            </a:extLst>
+          </p:cNvPr>
+          <p:cNvSpPr txBox="1">
+            <a:spLocks noGrp="1"/>
+          </p:cNvSpPr>
+          <p:nvPr>
+            <p:ph type="body" idx="1"/>
+          </p:nvPr>
+        </p:nvSpPr>
+        <p:spPr>
+          <a:xfrm>
+            <a:off x="685800" y="4343400"/>
+            <a:ext cx="5486400" cy="4114800"/>
+          </a:xfrm>
+          <a:prstGeom prst="rect">
+            <a:avLst/>
+          </a:prstGeom>
+        </p:spPr>
+        <p:txBody>
+          <a:bodyPr spcFirstLastPara="1" wrap="square" lIns="91425" tIns="91425" rIns="91425" bIns="91425" anchor="t" anchorCtr="0">
+            <a:noAutofit/>
+          </a:bodyPr>
+          <a:lstStyle/>
+          <a:p>
+            <a:pPr marL="0" lvl="0" indent="0" algn="l" rtl="0">
+              <a:spcBef>
+                <a:spcPts val="0"/>
+              </a:spcBef>
+              <a:spcAft>
+                <a:spcPts val="0"/>
+              </a:spcAft>
+              <a:buNone/>
+            </a:pPr>
+            <a:endParaRPr/>
+          </a:p>
+        </p:txBody>
+      </p:sp>
+    </p:spTree>
+    <p:extLst>
+      <p:ext uri="{BB962C8B-B14F-4D97-AF65-F5344CB8AC3E}">
+        <p14:creationId xmlns:p14="http://schemas.microsoft.com/office/powerpoint/2010/main" val="1228098733"/>
+      </p:ext>
+    </p:extLst>
+  </p:cSld>
+  <p:clrMapOvr>
+    <a:masterClrMapping/>
+  </p:clrMapOvr>
+</p:notes>
+</file>
+
+<file path=ppt/notesSlides/notesSlide7.xml><?xml version="1.0" encoding="utf-8"?>
+<p:notes xmlns:a="http://schemas.openxmlformats.org/drawingml/2006/main" xmlns:r="http://schemas.openxmlformats.org/officeDocument/2006/relationships" xmlns:p="http://schemas.openxmlformats.org/presentationml/2006/main" showMasterSp="0" showMasterPhAnim="0">
+  <p:cSld>
+    <p:spTree>
+      <p:nvGrpSpPr>
+        <p:cNvPr id="1" name="Shape 62">
+          <a:extLst>
+            <a:ext uri="{FF2B5EF4-FFF2-40B4-BE49-F238E27FC236}">
+              <a16:creationId xmlns:a16="http://schemas.microsoft.com/office/drawing/2014/main" id="{9A8F5C69-DAA9-91CF-271E-0310946CEEBD}"/>
+            </a:ext>
+          </a:extLst>
+        </p:cNvPr>
+        <p:cNvGrpSpPr/>
+        <p:nvPr/>
+      </p:nvGrpSpPr>
+      <p:grpSpPr>
+        <a:xfrm>
+          <a:off x="0" y="0"/>
+          <a:ext cx="0" cy="0"/>
+          <a:chOff x="0" y="0"/>
+          <a:chExt cx="0" cy="0"/>
+        </a:xfrm>
+      </p:grpSpPr>
+      <p:sp>
+        <p:nvSpPr>
+          <p:cNvPr id="63" name="Google Shape;63;g359956e13c8_0_5:notes">
+            <a:extLst>
+              <a:ext uri="{FF2B5EF4-FFF2-40B4-BE49-F238E27FC236}">
+                <a16:creationId xmlns:a16="http://schemas.microsoft.com/office/drawing/2014/main" id="{330F2C87-1344-5573-2B1C-612974C4E750}"/>
+              </a:ext>
+            </a:extLst>
+          </p:cNvPr>
+          <p:cNvSpPr>
+            <a:spLocks noGrp="1" noRot="1" noChangeAspect="1"/>
+          </p:cNvSpPr>
+          <p:nvPr>
+            <p:ph type="sldImg" idx="2"/>
+          </p:nvPr>
+        </p:nvSpPr>
+        <p:spPr>
+          <a:xfrm>
+            <a:off x="381000" y="685800"/>
+            <a:ext cx="6096000" cy="3429000"/>
+          </a:xfrm>
+          <a:custGeom>
+            <a:avLst/>
+            <a:gdLst/>
+            <a:ahLst/>
+            <a:cxnLst/>
+            <a:rect l="l" t="t" r="r" b="b"/>
+            <a:pathLst>
+              <a:path w="120000" h="120000" extrusionOk="0">
+                <a:moveTo>
+                  <a:pt x="0" y="0"/>
+                </a:moveTo>
+                <a:lnTo>
+                  <a:pt x="120000" y="0"/>
+                </a:lnTo>
+                <a:lnTo>
+                  <a:pt x="120000" y="120000"/>
+                </a:lnTo>
+                <a:lnTo>
+                  <a:pt x="0" y="120000"/>
+                </a:lnTo>
+                <a:close/>
+              </a:path>
+            </a:pathLst>
+          </a:custGeom>
+        </p:spPr>
+      </p:sp>
+      <p:sp>
+        <p:nvSpPr>
+          <p:cNvPr id="64" name="Google Shape;64;g359956e13c8_0_5:notes">
+            <a:extLst>
+              <a:ext uri="{FF2B5EF4-FFF2-40B4-BE49-F238E27FC236}">
+                <a16:creationId xmlns:a16="http://schemas.microsoft.com/office/drawing/2014/main" id="{4602D758-9802-2510-2D31-30919C4B2978}"/>
+              </a:ext>
+            </a:extLst>
+          </p:cNvPr>
+          <p:cNvSpPr txBox="1">
+            <a:spLocks noGrp="1"/>
+          </p:cNvSpPr>
+          <p:nvPr>
+            <p:ph type="body" idx="1"/>
+          </p:nvPr>
+        </p:nvSpPr>
+        <p:spPr>
+          <a:xfrm>
+            <a:off x="685800" y="4343400"/>
+            <a:ext cx="5486400" cy="4114800"/>
+          </a:xfrm>
+          <a:prstGeom prst="rect">
+            <a:avLst/>
+          </a:prstGeom>
+        </p:spPr>
+        <p:txBody>
+          <a:bodyPr spcFirstLastPara="1" wrap="square" lIns="91425" tIns="91425" rIns="91425" bIns="91425" anchor="t" anchorCtr="0">
+            <a:noAutofit/>
+          </a:bodyPr>
+          <a:lstStyle/>
+          <a:p>
+            <a:pPr marL="0" lvl="0" indent="0" algn="l" rtl="0">
+              <a:spcBef>
+                <a:spcPts val="0"/>
+              </a:spcBef>
+              <a:spcAft>
+                <a:spcPts val="0"/>
+              </a:spcAft>
+              <a:buNone/>
+            </a:pPr>
+            <a:endParaRPr/>
+          </a:p>
+        </p:txBody>
+      </p:sp>
+    </p:spTree>
+    <p:extLst>
+      <p:ext uri="{BB962C8B-B14F-4D97-AF65-F5344CB8AC3E}">
+        <p14:creationId xmlns:p14="http://schemas.microsoft.com/office/powerpoint/2010/main" val="2542326666"/>
+      </p:ext>
+    </p:extLst>
+  </p:cSld>
+  <p:clrMapOvr>
+    <a:masterClrMapping/>
+  </p:clrMapOvr>
+</p:notes>
+</file>
+
+<file path=ppt/notesSlides/notesSlide8.xml><?xml version="1.0" encoding="utf-8"?>
+<p:notes xmlns:a="http://schemas.openxmlformats.org/drawingml/2006/main" xmlns:r="http://schemas.openxmlformats.org/officeDocument/2006/relationships" xmlns:p="http://schemas.openxmlformats.org/presentationml/2006/main" showMasterSp="0" showMasterPhAnim="0">
+  <p:cSld>
+    <p:spTree>
+      <p:nvGrpSpPr>
+        <p:cNvPr id="1" name="Shape 62">
+          <a:extLst>
+            <a:ext uri="{FF2B5EF4-FFF2-40B4-BE49-F238E27FC236}">
+              <a16:creationId xmlns:a16="http://schemas.microsoft.com/office/drawing/2014/main" id="{853CAC8C-876D-989A-A3DF-A7806CEB289C}"/>
+            </a:ext>
+          </a:extLst>
+        </p:cNvPr>
+        <p:cNvGrpSpPr/>
+        <p:nvPr/>
+      </p:nvGrpSpPr>
+      <p:grpSpPr>
+        <a:xfrm>
+          <a:off x="0" y="0"/>
+          <a:ext cx="0" cy="0"/>
+          <a:chOff x="0" y="0"/>
+          <a:chExt cx="0" cy="0"/>
+        </a:xfrm>
+      </p:grpSpPr>
+      <p:sp>
+        <p:nvSpPr>
+          <p:cNvPr id="63" name="Google Shape;63;g359956e13c8_0_5:notes">
+            <a:extLst>
+              <a:ext uri="{FF2B5EF4-FFF2-40B4-BE49-F238E27FC236}">
+                <a16:creationId xmlns:a16="http://schemas.microsoft.com/office/drawing/2014/main" id="{A6968ABC-2222-55BE-CB37-78EEA282F980}"/>
+              </a:ext>
+            </a:extLst>
+          </p:cNvPr>
+          <p:cNvSpPr>
+            <a:spLocks noGrp="1" noRot="1" noChangeAspect="1"/>
+          </p:cNvSpPr>
+          <p:nvPr>
+            <p:ph type="sldImg" idx="2"/>
+          </p:nvPr>
+        </p:nvSpPr>
+        <p:spPr>
+          <a:xfrm>
+            <a:off x="381000" y="685800"/>
+            <a:ext cx="6096000" cy="3429000"/>
+          </a:xfrm>
+          <a:custGeom>
+            <a:avLst/>
+            <a:gdLst/>
+            <a:ahLst/>
+            <a:cxnLst/>
+            <a:rect l="l" t="t" r="r" b="b"/>
+            <a:pathLst>
+              <a:path w="120000" h="120000" extrusionOk="0">
+                <a:moveTo>
+                  <a:pt x="0" y="0"/>
+                </a:moveTo>
+                <a:lnTo>
+                  <a:pt x="120000" y="0"/>
+                </a:lnTo>
+                <a:lnTo>
+                  <a:pt x="120000" y="120000"/>
+                </a:lnTo>
+                <a:lnTo>
+                  <a:pt x="0" y="120000"/>
+                </a:lnTo>
+                <a:close/>
+              </a:path>
+            </a:pathLst>
+          </a:custGeom>
+        </p:spPr>
+      </p:sp>
+      <p:sp>
+        <p:nvSpPr>
+          <p:cNvPr id="64" name="Google Shape;64;g359956e13c8_0_5:notes">
+            <a:extLst>
+              <a:ext uri="{FF2B5EF4-FFF2-40B4-BE49-F238E27FC236}">
+                <a16:creationId xmlns:a16="http://schemas.microsoft.com/office/drawing/2014/main" id="{0FAE89EA-B919-5525-C172-4B2D8AD41EDC}"/>
+              </a:ext>
+            </a:extLst>
+          </p:cNvPr>
+          <p:cNvSpPr txBox="1">
+            <a:spLocks noGrp="1"/>
+          </p:cNvSpPr>
+          <p:nvPr>
+            <p:ph type="body" idx="1"/>
+          </p:nvPr>
+        </p:nvSpPr>
+        <p:spPr>
+          <a:xfrm>
+            <a:off x="685800" y="4343400"/>
+            <a:ext cx="5486400" cy="4114800"/>
+          </a:xfrm>
+          <a:prstGeom prst="rect">
+            <a:avLst/>
+          </a:prstGeom>
+        </p:spPr>
+        <p:txBody>
+          <a:bodyPr spcFirstLastPara="1" wrap="square" lIns="91425" tIns="91425" rIns="91425" bIns="91425" anchor="t" anchorCtr="0">
+            <a:noAutofit/>
+          </a:bodyPr>
+          <a:lstStyle/>
+          <a:p>
+            <a:pPr marL="0" lvl="0" indent="0" algn="l" rtl="0">
+              <a:spcBef>
+                <a:spcPts val="0"/>
+              </a:spcBef>
+              <a:spcAft>
+                <a:spcPts val="0"/>
+              </a:spcAft>
+              <a:buNone/>
+            </a:pPr>
+            <a:endParaRPr/>
+          </a:p>
+        </p:txBody>
+      </p:sp>
+    </p:spTree>
+    <p:extLst>
+      <p:ext uri="{BB962C8B-B14F-4D97-AF65-F5344CB8AC3E}">
+        <p14:creationId xmlns:p14="http://schemas.microsoft.com/office/powerpoint/2010/main" val="570827785"/>
       </p:ext>
     </p:extLst>
   </p:cSld>
@@ -5655,7 +6879,7 @@
               </a:defRPr>
             </a:pPr>
             <a:r>
-              <a:t>PERIODE FILTER: Bulan = JUL-2026, AGU-2026 (2 Periode Terpilih)</a:t>
+              <a:t>PERIODE FILTER: Bulan = AGU-2026 | MTM = KA</a:t>
             </a:r>
             <a:endParaRPr dirty="0"/>
           </a:p>
@@ -5805,7 +7029,7 @@
               </a:defRPr>
             </a:pPr>
             <a:r>
-              <a:t>1. EXECUTIVE KPI SUMMARY &amp; TREND (JUL-2026)</a:t>
+              <a:t>1. EXECUTIVE KPI SUMMARY &amp; TREND (AGU-2026)</a:t>
             </a:r>
           </a:p>
           <a:p>
@@ -5817,7 +7041,7 @@
               </a:defRPr>
             </a:pPr>
             <a:r>
-              <a:t>📌 Filter Aktif: Bulan = JUL-2026</a:t>
+              <a:t>📌 Filter Aktif: Bulan = AGU-2026 | MTM = KA</a:t>
             </a:r>
           </a:p>
         </p:txBody>
@@ -5883,7 +7107,7 @@
               </a:defRPr>
             </a:pPr>
             <a:r>
-              <a:t>86.0%</a:t>
+              <a:t>90.2%</a:t>
             </a:r>
           </a:p>
           <a:p>
@@ -5961,7 +7185,7 @@
               </a:defRPr>
             </a:pPr>
             <a:r>
-              <a:t>85.5%</a:t>
+              <a:t>89.5%</a:t>
             </a:r>
           </a:p>
           <a:p>
@@ -6039,7 +7263,7 @@
               </a:defRPr>
             </a:pPr>
             <a:r>
-              <a:t>-0.5%</a:t>
+              <a:t>-0.7%</a:t>
             </a:r>
           </a:p>
           <a:p>
@@ -6056,6 +7280,24 @@
           </a:p>
         </p:txBody>
       </p:sp>
+      <p:graphicFrame>
+        <p:nvGraphicFramePr>
+          <p:cNvPr id="6" name="Chart 5"/>
+          <p:cNvGraphicFramePr>
+            <a:graphicFrameLocks noGrp="1"/>
+          </p:cNvGraphicFramePr>
+          <p:nvPr/>
+        </p:nvGraphicFramePr>
+        <p:xfrm>
+          <a:off x="502920" y="1993392"/>
+          <a:ext cx="8046720" cy="2331720"/>
+        </p:xfrm>
+        <a:graphic>
+          <a:graphicData uri="http://schemas.openxmlformats.org/drawingml/2006/chart">
+            <c:chart xmlns:c="http://schemas.openxmlformats.org/drawingml/2006/chart" r:id="rId4"/>
+          </a:graphicData>
+        </a:graphic>
+      </p:graphicFrame>
     </p:spTree>
   </p:cSld>
   <p:clrMapOvr>
@@ -6128,7 +7370,7 @@
               </a:defRPr>
             </a:pPr>
             <a:r>
-              <a:t>1. EXECUTIVE KPI SUMMARY &amp; TREND (AGU-2026)</a:t>
+              <a:t>1.1 SERVICE LEVEL PER GRUP BRAND (AGU-2026)</a:t>
             </a:r>
           </a:p>
           <a:p>
@@ -6140,249 +7382,1465 @@
               </a:defRPr>
             </a:pPr>
             <a:r>
-              <a:t>📌 Filter Aktif: Bulan = AGU-2026</a:t>
+              <a:t>📌 Filter Aktif: Bulan = AGU-2026 | MTM = KA | Performa Pengiriman (SL Kirim) &amp; Realisasi (SL Realisasi) Per Grup Brand</a:t>
             </a:r>
           </a:p>
         </p:txBody>
       </p:sp>
+      <p:graphicFrame>
+        <p:nvGraphicFramePr>
+          <p:cNvPr id="3" name="Chart 2"/>
+          <p:cNvGraphicFramePr>
+            <a:graphicFrameLocks noGrp="1"/>
+          </p:cNvGraphicFramePr>
+          <p:nvPr/>
+        </p:nvGraphicFramePr>
+        <p:xfrm>
+          <a:off x="502920" y="1051560"/>
+          <a:ext cx="4206240" cy="3246120"/>
+        </p:xfrm>
+        <a:graphic>
+          <a:graphicData uri="http://schemas.openxmlformats.org/drawingml/2006/chart">
+            <c:chart xmlns:c="http://schemas.openxmlformats.org/drawingml/2006/chart" r:id="rId4"/>
+          </a:graphicData>
+        </a:graphic>
+      </p:graphicFrame>
+      <p:graphicFrame>
+        <p:nvGraphicFramePr>
+          <p:cNvPr id="4" name="Table 3"/>
+          <p:cNvGraphicFramePr>
+            <a:graphicFrameLocks noGrp="1"/>
+          </p:cNvGraphicFramePr>
+          <p:nvPr/>
+        </p:nvGraphicFramePr>
+        <p:xfrm>
+          <a:off x="4754880" y="1051560"/>
+          <a:ext cx="3886200" cy="3246120"/>
+        </p:xfrm>
+        <a:graphic>
+          <a:graphicData uri="http://schemas.openxmlformats.org/drawingml/2006/table">
+            <a:tbl>
+              <a:tblPr firstRow="1" bandRow="1">
+                <a:tableStyleId>{5C22544A-7EE6-4342-B048-85BDC9FD1C3A}</a:tableStyleId>
+              </a:tblPr>
+              <a:tblGrid>
+                <a:gridCol w="777240"/>
+                <a:gridCol w="777240"/>
+                <a:gridCol w="777240"/>
+                <a:gridCol w="502920"/>
+                <a:gridCol w="502920"/>
+                <a:gridCol w="548640"/>
+              </a:tblGrid>
+              <a:tr h="405765">
+                <a:tc>
+                  <a:txBody>
+                    <a:bodyPr/>
+                    <a:lstStyle/>
+                    <a:p>
+                      <a:pPr algn="ctr">
+                        <a:defRPr b="1" sz="750">
+                          <a:solidFill>
+                            <a:srgbClr val="FFFFFF"/>
+                          </a:solidFill>
+                        </a:defRPr>
+                      </a:pPr>
+                      <a:r>
+                        <a:t>Grup Brand</a:t>
+                      </a:r>
+                    </a:p>
+                  </a:txBody>
+                  <a:tcPr>
+                    <a:solidFill>
+                      <a:srgbClr val="C00000"/>
+                    </a:solidFill>
+                  </a:tcPr>
+                </a:tc>
+                <a:tc>
+                  <a:txBody>
+                    <a:bodyPr/>
+                    <a:lstStyle/>
+                    <a:p>
+                      <a:pPr algn="ctr">
+                        <a:defRPr b="1" sz="750">
+                          <a:solidFill>
+                            <a:srgbClr val="FFFFFF"/>
+                          </a:solidFill>
+                        </a:defRPr>
+                      </a:pPr>
+                      <a:r>
+                        <a:t>Total Order</a:t>
+                      </a:r>
+                    </a:p>
+                  </a:txBody>
+                  <a:tcPr>
+                    <a:solidFill>
+                      <a:srgbClr val="C00000"/>
+                    </a:solidFill>
+                  </a:tcPr>
+                </a:tc>
+                <a:tc>
+                  <a:txBody>
+                    <a:bodyPr/>
+                    <a:lstStyle/>
+                    <a:p>
+                      <a:pPr algn="ctr">
+                        <a:defRPr b="1" sz="750">
+                          <a:solidFill>
+                            <a:srgbClr val="FFFFFF"/>
+                          </a:solidFill>
+                        </a:defRPr>
+                      </a:pPr>
+                      <a:r>
+                        <a:t>Total Kirim</a:t>
+                      </a:r>
+                    </a:p>
+                  </a:txBody>
+                  <a:tcPr>
+                    <a:solidFill>
+                      <a:srgbClr val="C00000"/>
+                    </a:solidFill>
+                  </a:tcPr>
+                </a:tc>
+                <a:tc>
+                  <a:txBody>
+                    <a:bodyPr/>
+                    <a:lstStyle/>
+                    <a:p>
+                      <a:pPr algn="ctr">
+                        <a:defRPr b="1" sz="750">
+                          <a:solidFill>
+                            <a:srgbClr val="FFFFFF"/>
+                          </a:solidFill>
+                        </a:defRPr>
+                      </a:pPr>
+                      <a:r>
+                        <a:t>SL Kirim</a:t>
+                      </a:r>
+                    </a:p>
+                  </a:txBody>
+                  <a:tcPr>
+                    <a:solidFill>
+                      <a:srgbClr val="C00000"/>
+                    </a:solidFill>
+                  </a:tcPr>
+                </a:tc>
+                <a:tc>
+                  <a:txBody>
+                    <a:bodyPr/>
+                    <a:lstStyle/>
+                    <a:p>
+                      <a:pPr algn="ctr">
+                        <a:defRPr b="1" sz="750">
+                          <a:solidFill>
+                            <a:srgbClr val="FFFFFF"/>
+                          </a:solidFill>
+                        </a:defRPr>
+                      </a:pPr>
+                      <a:r>
+                        <a:t>SL Real.</a:t>
+                      </a:r>
+                    </a:p>
+                  </a:txBody>
+                  <a:tcPr>
+                    <a:solidFill>
+                      <a:srgbClr val="C00000"/>
+                    </a:solidFill>
+                  </a:tcPr>
+                </a:tc>
+                <a:tc>
+                  <a:txBody>
+                    <a:bodyPr/>
+                    <a:lstStyle/>
+                    <a:p>
+                      <a:pPr algn="ctr">
+                        <a:defRPr b="1" sz="750">
+                          <a:solidFill>
+                            <a:srgbClr val="FFFFFF"/>
+                          </a:solidFill>
+                        </a:defRPr>
+                      </a:pPr>
+                      <a:r>
+                        <a:t>GAP</a:t>
+                      </a:r>
+                    </a:p>
+                  </a:txBody>
+                  <a:tcPr>
+                    <a:solidFill>
+                      <a:srgbClr val="C00000"/>
+                    </a:solidFill>
+                  </a:tcPr>
+                </a:tc>
+              </a:tr>
+              <a:tr h="405765">
+                <a:tc>
+                  <a:txBody>
+                    <a:bodyPr/>
+                    <a:lstStyle/>
+                    <a:p>
+                      <a:pPr algn="ctr">
+                        <a:defRPr sz="700"/>
+                      </a:pPr>
+                      <a:r>
+                        <a:t>GB 1</a:t>
+                      </a:r>
+                    </a:p>
+                  </a:txBody>
+                  <a:tcPr marL="25400" marR="25400" marT="12700" marB="12700"/>
+                </a:tc>
+                <a:tc>
+                  <a:txBody>
+                    <a:bodyPr/>
+                    <a:lstStyle/>
+                    <a:p>
+                      <a:pPr algn="r">
+                        <a:defRPr sz="700"/>
+                      </a:pPr>
+                      <a:r>
+                        <a:t>1,813,076,750</a:t>
+                      </a:r>
+                    </a:p>
+                  </a:txBody>
+                  <a:tcPr marL="25400" marR="25400" marT="12700" marB="12700"/>
+                </a:tc>
+                <a:tc>
+                  <a:txBody>
+                    <a:bodyPr/>
+                    <a:lstStyle/>
+                    <a:p>
+                      <a:pPr algn="r">
+                        <a:defRPr sz="700"/>
+                      </a:pPr>
+                      <a:r>
+                        <a:t>1,715,607,960</a:t>
+                      </a:r>
+                    </a:p>
+                  </a:txBody>
+                  <a:tcPr marL="25400" marR="25400" marT="12700" marB="12700"/>
+                </a:tc>
+                <a:tc>
+                  <a:txBody>
+                    <a:bodyPr/>
+                    <a:lstStyle/>
+                    <a:p>
+                      <a:pPr algn="ctr">
+                        <a:defRPr sz="700"/>
+                      </a:pPr>
+                      <a:r>
+                        <a:t>94.6%</a:t>
+                      </a:r>
+                    </a:p>
+                  </a:txBody>
+                  <a:tcPr marL="25400" marR="25400" marT="12700" marB="12700"/>
+                </a:tc>
+                <a:tc>
+                  <a:txBody>
+                    <a:bodyPr/>
+                    <a:lstStyle/>
+                    <a:p>
+                      <a:pPr algn="ctr">
+                        <a:defRPr sz="700"/>
+                      </a:pPr>
+                      <a:r>
+                        <a:t>94.3%</a:t>
+                      </a:r>
+                    </a:p>
+                  </a:txBody>
+                  <a:tcPr marL="25400" marR="25400" marT="12700" marB="12700"/>
+                </a:tc>
+                <a:tc>
+                  <a:txBody>
+                    <a:bodyPr/>
+                    <a:lstStyle/>
+                    <a:p>
+                      <a:pPr algn="ctr">
+                        <a:defRPr sz="700" b="1">
+                          <a:solidFill>
+                            <a:srgbClr val="DC2626"/>
+                          </a:solidFill>
+                        </a:defRPr>
+                      </a:pPr>
+                      <a:r>
+                        <a:t>-0.3%</a:t>
+                      </a:r>
+                    </a:p>
+                  </a:txBody>
+                  <a:tcPr marL="25400" marR="25400" marT="12700" marB="12700"/>
+                </a:tc>
+              </a:tr>
+              <a:tr h="405765">
+                <a:tc>
+                  <a:txBody>
+                    <a:bodyPr/>
+                    <a:lstStyle/>
+                    <a:p>
+                      <a:pPr algn="ctr">
+                        <a:defRPr sz="700"/>
+                      </a:pPr>
+                      <a:r>
+                        <a:t>GB 2</a:t>
+                      </a:r>
+                    </a:p>
+                  </a:txBody>
+                  <a:tcPr marL="25400" marR="25400" marT="12700" marB="12700"/>
+                </a:tc>
+                <a:tc>
+                  <a:txBody>
+                    <a:bodyPr/>
+                    <a:lstStyle/>
+                    <a:p>
+                      <a:pPr algn="r">
+                        <a:defRPr sz="700"/>
+                      </a:pPr>
+                      <a:r>
+                        <a:t>7,895,205,508</a:t>
+                      </a:r>
+                    </a:p>
+                  </a:txBody>
+                  <a:tcPr marL="25400" marR="25400" marT="12700" marB="12700"/>
+                </a:tc>
+                <a:tc>
+                  <a:txBody>
+                    <a:bodyPr/>
+                    <a:lstStyle/>
+                    <a:p>
+                      <a:pPr algn="r">
+                        <a:defRPr sz="700"/>
+                      </a:pPr>
+                      <a:r>
+                        <a:t>7,134,192,718</a:t>
+                      </a:r>
+                    </a:p>
+                  </a:txBody>
+                  <a:tcPr marL="25400" marR="25400" marT="12700" marB="12700"/>
+                </a:tc>
+                <a:tc>
+                  <a:txBody>
+                    <a:bodyPr/>
+                    <a:lstStyle/>
+                    <a:p>
+                      <a:pPr algn="ctr">
+                        <a:defRPr sz="700"/>
+                      </a:pPr>
+                      <a:r>
+                        <a:t>90.4%</a:t>
+                      </a:r>
+                    </a:p>
+                  </a:txBody>
+                  <a:tcPr marL="25400" marR="25400" marT="12700" marB="12700"/>
+                </a:tc>
+                <a:tc>
+                  <a:txBody>
+                    <a:bodyPr/>
+                    <a:lstStyle/>
+                    <a:p>
+                      <a:pPr algn="ctr">
+                        <a:defRPr sz="700"/>
+                      </a:pPr>
+                      <a:r>
+                        <a:t>89.9%</a:t>
+                      </a:r>
+                    </a:p>
+                  </a:txBody>
+                  <a:tcPr marL="25400" marR="25400" marT="12700" marB="12700"/>
+                </a:tc>
+                <a:tc>
+                  <a:txBody>
+                    <a:bodyPr/>
+                    <a:lstStyle/>
+                    <a:p>
+                      <a:pPr algn="ctr">
+                        <a:defRPr sz="700" b="1">
+                          <a:solidFill>
+                            <a:srgbClr val="DC2626"/>
+                          </a:solidFill>
+                        </a:defRPr>
+                      </a:pPr>
+                      <a:r>
+                        <a:t>-0.4%</a:t>
+                      </a:r>
+                    </a:p>
+                  </a:txBody>
+                  <a:tcPr marL="25400" marR="25400" marT="12700" marB="12700"/>
+                </a:tc>
+              </a:tr>
+              <a:tr h="405765">
+                <a:tc>
+                  <a:txBody>
+                    <a:bodyPr/>
+                    <a:lstStyle/>
+                    <a:p>
+                      <a:pPr algn="ctr">
+                        <a:defRPr sz="700"/>
+                      </a:pPr>
+                      <a:r>
+                        <a:t>GB 3</a:t>
+                      </a:r>
+                    </a:p>
+                  </a:txBody>
+                  <a:tcPr marL="25400" marR="25400" marT="12700" marB="12700"/>
+                </a:tc>
+                <a:tc>
+                  <a:txBody>
+                    <a:bodyPr/>
+                    <a:lstStyle/>
+                    <a:p>
+                      <a:pPr algn="r">
+                        <a:defRPr sz="700"/>
+                      </a:pPr>
+                      <a:r>
+                        <a:t>1,389,719,660</a:t>
+                      </a:r>
+                    </a:p>
+                  </a:txBody>
+                  <a:tcPr marL="25400" marR="25400" marT="12700" marB="12700"/>
+                </a:tc>
+                <a:tc>
+                  <a:txBody>
+                    <a:bodyPr/>
+                    <a:lstStyle/>
+                    <a:p>
+                      <a:pPr algn="r">
+                        <a:defRPr sz="700"/>
+                      </a:pPr>
+                      <a:r>
+                        <a:t>1,202,327,230</a:t>
+                      </a:r>
+                    </a:p>
+                  </a:txBody>
+                  <a:tcPr marL="25400" marR="25400" marT="12700" marB="12700"/>
+                </a:tc>
+                <a:tc>
+                  <a:txBody>
+                    <a:bodyPr/>
+                    <a:lstStyle/>
+                    <a:p>
+                      <a:pPr algn="ctr">
+                        <a:defRPr sz="700"/>
+                      </a:pPr>
+                      <a:r>
+                        <a:t>86.5%</a:t>
+                      </a:r>
+                    </a:p>
+                  </a:txBody>
+                  <a:tcPr marL="25400" marR="25400" marT="12700" marB="12700"/>
+                </a:tc>
+                <a:tc>
+                  <a:txBody>
+                    <a:bodyPr/>
+                    <a:lstStyle/>
+                    <a:p>
+                      <a:pPr algn="ctr">
+                        <a:defRPr sz="700"/>
+                      </a:pPr>
+                      <a:r>
+                        <a:t>85.8%</a:t>
+                      </a:r>
+                    </a:p>
+                  </a:txBody>
+                  <a:tcPr marL="25400" marR="25400" marT="12700" marB="12700"/>
+                </a:tc>
+                <a:tc>
+                  <a:txBody>
+                    <a:bodyPr/>
+                    <a:lstStyle/>
+                    <a:p>
+                      <a:pPr algn="ctr">
+                        <a:defRPr sz="700" b="1">
+                          <a:solidFill>
+                            <a:srgbClr val="DC2626"/>
+                          </a:solidFill>
+                        </a:defRPr>
+                      </a:pPr>
+                      <a:r>
+                        <a:t>-0.8%</a:t>
+                      </a:r>
+                    </a:p>
+                  </a:txBody>
+                  <a:tcPr marL="25400" marR="25400" marT="12700" marB="12700"/>
+                </a:tc>
+              </a:tr>
+              <a:tr h="405765">
+                <a:tc>
+                  <a:txBody>
+                    <a:bodyPr/>
+                    <a:lstStyle/>
+                    <a:p>
+                      <a:pPr algn="ctr">
+                        <a:defRPr sz="700"/>
+                      </a:pPr>
+                      <a:r>
+                        <a:t>GB 4</a:t>
+                      </a:r>
+                    </a:p>
+                  </a:txBody>
+                  <a:tcPr marL="25400" marR="25400" marT="12700" marB="12700"/>
+                </a:tc>
+                <a:tc>
+                  <a:txBody>
+                    <a:bodyPr/>
+                    <a:lstStyle/>
+                    <a:p>
+                      <a:pPr algn="r">
+                        <a:defRPr sz="700"/>
+                      </a:pPr>
+                      <a:r>
+                        <a:t>3,243,563,020</a:t>
+                      </a:r>
+                    </a:p>
+                  </a:txBody>
+                  <a:tcPr marL="25400" marR="25400" marT="12700" marB="12700"/>
+                </a:tc>
+                <a:tc>
+                  <a:txBody>
+                    <a:bodyPr/>
+                    <a:lstStyle/>
+                    <a:p>
+                      <a:pPr algn="r">
+                        <a:defRPr sz="700"/>
+                      </a:pPr>
+                      <a:r>
+                        <a:t>2,940,846,220</a:t>
+                      </a:r>
+                    </a:p>
+                  </a:txBody>
+                  <a:tcPr marL="25400" marR="25400" marT="12700" marB="12700"/>
+                </a:tc>
+                <a:tc>
+                  <a:txBody>
+                    <a:bodyPr/>
+                    <a:lstStyle/>
+                    <a:p>
+                      <a:pPr algn="ctr">
+                        <a:defRPr sz="700"/>
+                      </a:pPr>
+                      <a:r>
+                        <a:t>90.7%</a:t>
+                      </a:r>
+                    </a:p>
+                  </a:txBody>
+                  <a:tcPr marL="25400" marR="25400" marT="12700" marB="12700"/>
+                </a:tc>
+                <a:tc>
+                  <a:txBody>
+                    <a:bodyPr/>
+                    <a:lstStyle/>
+                    <a:p>
+                      <a:pPr algn="ctr">
+                        <a:defRPr sz="700"/>
+                      </a:pPr>
+                      <a:r>
+                        <a:t>90.2%</a:t>
+                      </a:r>
+                    </a:p>
+                  </a:txBody>
+                  <a:tcPr marL="25400" marR="25400" marT="12700" marB="12700"/>
+                </a:tc>
+                <a:tc>
+                  <a:txBody>
+                    <a:bodyPr/>
+                    <a:lstStyle/>
+                    <a:p>
+                      <a:pPr algn="ctr">
+                        <a:defRPr sz="700" b="1">
+                          <a:solidFill>
+                            <a:srgbClr val="DC2626"/>
+                          </a:solidFill>
+                        </a:defRPr>
+                      </a:pPr>
+                      <a:r>
+                        <a:t>-0.5%</a:t>
+                      </a:r>
+                    </a:p>
+                  </a:txBody>
+                  <a:tcPr marL="25400" marR="25400" marT="12700" marB="12700"/>
+                </a:tc>
+              </a:tr>
+              <a:tr h="405765">
+                <a:tc>
+                  <a:txBody>
+                    <a:bodyPr/>
+                    <a:lstStyle/>
+                    <a:p>
+                      <a:pPr algn="ctr">
+                        <a:defRPr sz="700"/>
+                      </a:pPr>
+                      <a:r>
+                        <a:t>GB 5</a:t>
+                      </a:r>
+                    </a:p>
+                  </a:txBody>
+                  <a:tcPr marL="25400" marR="25400" marT="12700" marB="12700"/>
+                </a:tc>
+                <a:tc>
+                  <a:txBody>
+                    <a:bodyPr/>
+                    <a:lstStyle/>
+                    <a:p>
+                      <a:pPr algn="r">
+                        <a:defRPr sz="700"/>
+                      </a:pPr>
+                      <a:r>
+                        <a:t>5,735,865,938</a:t>
+                      </a:r>
+                    </a:p>
+                  </a:txBody>
+                  <a:tcPr marL="25400" marR="25400" marT="12700" marB="12700"/>
+                </a:tc>
+                <a:tc>
+                  <a:txBody>
+                    <a:bodyPr/>
+                    <a:lstStyle/>
+                    <a:p>
+                      <a:pPr algn="r">
+                        <a:defRPr sz="700"/>
+                      </a:pPr>
+                      <a:r>
+                        <a:t>4,762,043,730</a:t>
+                      </a:r>
+                    </a:p>
+                  </a:txBody>
+                  <a:tcPr marL="25400" marR="25400" marT="12700" marB="12700"/>
+                </a:tc>
+                <a:tc>
+                  <a:txBody>
+                    <a:bodyPr/>
+                    <a:lstStyle/>
+                    <a:p>
+                      <a:pPr algn="ctr">
+                        <a:defRPr sz="700"/>
+                      </a:pPr>
+                      <a:r>
+                        <a:t>83.0%</a:t>
+                      </a:r>
+                    </a:p>
+                  </a:txBody>
+                  <a:tcPr marL="25400" marR="25400" marT="12700" marB="12700"/>
+                </a:tc>
+                <a:tc>
+                  <a:txBody>
+                    <a:bodyPr/>
+                    <a:lstStyle/>
+                    <a:p>
+                      <a:pPr algn="ctr">
+                        <a:defRPr sz="700"/>
+                      </a:pPr>
+                      <a:r>
+                        <a:t>82.2%</a:t>
+                      </a:r>
+                    </a:p>
+                  </a:txBody>
+                  <a:tcPr marL="25400" marR="25400" marT="12700" marB="12700"/>
+                </a:tc>
+                <a:tc>
+                  <a:txBody>
+                    <a:bodyPr/>
+                    <a:lstStyle/>
+                    <a:p>
+                      <a:pPr algn="ctr">
+                        <a:defRPr sz="700" b="1">
+                          <a:solidFill>
+                            <a:srgbClr val="DC2626"/>
+                          </a:solidFill>
+                        </a:defRPr>
+                      </a:pPr>
+                      <a:r>
+                        <a:t>-0.8%</a:t>
+                      </a:r>
+                    </a:p>
+                  </a:txBody>
+                  <a:tcPr marL="25400" marR="25400" marT="12700" marB="12700"/>
+                </a:tc>
+              </a:tr>
+              <a:tr h="405765">
+                <a:tc>
+                  <a:txBody>
+                    <a:bodyPr/>
+                    <a:lstStyle/>
+                    <a:p>
+                      <a:pPr algn="ctr">
+                        <a:defRPr sz="700"/>
+                      </a:pPr>
+                      <a:r>
+                        <a:t>GB 6</a:t>
+                      </a:r>
+                    </a:p>
+                  </a:txBody>
+                  <a:tcPr marL="25400" marR="25400" marT="12700" marB="12700"/>
+                </a:tc>
+                <a:tc>
+                  <a:txBody>
+                    <a:bodyPr/>
+                    <a:lstStyle/>
+                    <a:p>
+                      <a:pPr algn="r">
+                        <a:defRPr sz="700"/>
+                      </a:pPr>
+                      <a:r>
+                        <a:t>5,053,507,178</a:t>
+                      </a:r>
+                    </a:p>
+                  </a:txBody>
+                  <a:tcPr marL="25400" marR="25400" marT="12700" marB="12700"/>
+                </a:tc>
+                <a:tc>
+                  <a:txBody>
+                    <a:bodyPr/>
+                    <a:lstStyle/>
+                    <a:p>
+                      <a:pPr algn="r">
+                        <a:defRPr sz="700"/>
+                      </a:pPr>
+                      <a:r>
+                        <a:t>4,894,161,572</a:t>
+                      </a:r>
+                    </a:p>
+                  </a:txBody>
+                  <a:tcPr marL="25400" marR="25400" marT="12700" marB="12700"/>
+                </a:tc>
+                <a:tc>
+                  <a:txBody>
+                    <a:bodyPr/>
+                    <a:lstStyle/>
+                    <a:p>
+                      <a:pPr algn="ctr">
+                        <a:defRPr sz="700"/>
+                      </a:pPr>
+                      <a:r>
+                        <a:t>96.8%</a:t>
+                      </a:r>
+                    </a:p>
+                  </a:txBody>
+                  <a:tcPr marL="25400" marR="25400" marT="12700" marB="12700"/>
+                </a:tc>
+                <a:tc>
+                  <a:txBody>
+                    <a:bodyPr/>
+                    <a:lstStyle/>
+                    <a:p>
+                      <a:pPr algn="ctr">
+                        <a:defRPr sz="700"/>
+                      </a:pPr>
+                      <a:r>
+                        <a:t>96.4%</a:t>
+                      </a:r>
+                    </a:p>
+                  </a:txBody>
+                  <a:tcPr marL="25400" marR="25400" marT="12700" marB="12700"/>
+                </a:tc>
+                <a:tc>
+                  <a:txBody>
+                    <a:bodyPr/>
+                    <a:lstStyle/>
+                    <a:p>
+                      <a:pPr algn="ctr">
+                        <a:defRPr sz="700" b="1">
+                          <a:solidFill>
+                            <a:srgbClr val="DC2626"/>
+                          </a:solidFill>
+                        </a:defRPr>
+                      </a:pPr>
+                      <a:r>
+                        <a:t>-0.4%</a:t>
+                      </a:r>
+                    </a:p>
+                  </a:txBody>
+                  <a:tcPr marL="25400" marR="25400" marT="12700" marB="12700"/>
+                </a:tc>
+              </a:tr>
+              <a:tr h="405765">
+                <a:tc>
+                  <a:txBody>
+                    <a:bodyPr/>
+                    <a:lstStyle/>
+                    <a:p>
+                      <a:pPr algn="ctr">
+                        <a:defRPr sz="700"/>
+                      </a:pPr>
+                      <a:r>
+                        <a:t>GB ET</a:t>
+                      </a:r>
+                    </a:p>
+                  </a:txBody>
+                  <a:tcPr marL="25400" marR="25400" marT="12700" marB="12700"/>
+                </a:tc>
+                <a:tc>
+                  <a:txBody>
+                    <a:bodyPr/>
+                    <a:lstStyle/>
+                    <a:p>
+                      <a:pPr algn="r">
+                        <a:defRPr sz="700"/>
+                      </a:pPr>
+                      <a:r>
+                        <a:t>351,842,500</a:t>
+                      </a:r>
+                    </a:p>
+                  </a:txBody>
+                  <a:tcPr marL="25400" marR="25400" marT="12700" marB="12700"/>
+                </a:tc>
+                <a:tc>
+                  <a:txBody>
+                    <a:bodyPr/>
+                    <a:lstStyle/>
+                    <a:p>
+                      <a:pPr algn="r">
+                        <a:defRPr sz="700"/>
+                      </a:pPr>
+                      <a:r>
+                        <a:t>341,985,000</a:t>
+                      </a:r>
+                    </a:p>
+                  </a:txBody>
+                  <a:tcPr marL="25400" marR="25400" marT="12700" marB="12700"/>
+                </a:tc>
+                <a:tc>
+                  <a:txBody>
+                    <a:bodyPr/>
+                    <a:lstStyle/>
+                    <a:p>
+                      <a:pPr algn="ctr">
+                        <a:defRPr sz="700"/>
+                      </a:pPr>
+                      <a:r>
+                        <a:t>97.2%</a:t>
+                      </a:r>
+                    </a:p>
+                  </a:txBody>
+                  <a:tcPr marL="25400" marR="25400" marT="12700" marB="12700"/>
+                </a:tc>
+                <a:tc>
+                  <a:txBody>
+                    <a:bodyPr/>
+                    <a:lstStyle/>
+                    <a:p>
+                      <a:pPr algn="ctr">
+                        <a:defRPr sz="700"/>
+                      </a:pPr>
+                      <a:r>
+                        <a:t>84.4%</a:t>
+                      </a:r>
+                    </a:p>
+                  </a:txBody>
+                  <a:tcPr marL="25400" marR="25400" marT="12700" marB="12700"/>
+                </a:tc>
+                <a:tc>
+                  <a:txBody>
+                    <a:bodyPr/>
+                    <a:lstStyle/>
+                    <a:p>
+                      <a:pPr algn="ctr">
+                        <a:defRPr sz="700" b="1">
+                          <a:solidFill>
+                            <a:srgbClr val="DC2626"/>
+                          </a:solidFill>
+                        </a:defRPr>
+                      </a:pPr>
+                      <a:r>
+                        <a:t>-12.8%</a:t>
+                      </a:r>
+                    </a:p>
+                  </a:txBody>
+                  <a:tcPr marL="25400" marR="25400" marT="12700" marB="12700"/>
+                </a:tc>
+              </a:tr>
+            </a:tbl>
+          </a:graphicData>
+        </a:graphic>
+      </p:graphicFrame>
+    </p:spTree>
+    <p:extLst>
+      <p:ext uri="{BB962C8B-B14F-4D97-AF65-F5344CB8AC3E}">
+        <p14:creationId xmlns:p14="http://schemas.microsoft.com/office/powerpoint/2010/main" val="439507773"/>
+      </p:ext>
+    </p:extLst>
+  </p:cSld>
+  <p:clrMapOvr>
+    <a:masterClrMapping/>
+  </p:clrMapOvr>
+</p:sld>
+</file>
+
+<file path=ppt/slides/slide4.xml><?xml version="1.0" encoding="utf-8"?>
+<p:sld xmlns:a="http://schemas.openxmlformats.org/drawingml/2006/main" xmlns:r="http://schemas.openxmlformats.org/officeDocument/2006/relationships" xmlns:p="http://schemas.openxmlformats.org/presentationml/2006/main">
+  <p:cSld>
+    <p:bg>
+      <p:bgPr>
+        <a:blipFill>
+          <a:blip r:embed="rId3"/>
+          <a:stretch>
+            <a:fillRect/>
+          </a:stretch>
+        </a:blipFill>
+        <a:effectLst/>
+      </p:bgPr>
+    </p:bg>
+    <p:spTree>
+      <p:nvGrpSpPr>
+        <p:cNvPr id="1" name="Shape 65">
+          <a:extLst>
+            <a:ext uri="{FF2B5EF4-FFF2-40B4-BE49-F238E27FC236}">
+              <a16:creationId xmlns:a16="http://schemas.microsoft.com/office/drawing/2014/main" id="{BC51AF43-D872-719A-C6EA-864FDF7EA22C}"/>
+            </a:ext>
+          </a:extLst>
+        </p:cNvPr>
+        <p:cNvGrpSpPr/>
+        <p:nvPr/>
+      </p:nvGrpSpPr>
+      <p:grpSpPr>
+        <a:xfrm>
+          <a:off x="0" y="0"/>
+          <a:ext cx="0" cy="0"/>
+          <a:chOff x="0" y="0"/>
+          <a:chExt cx="0" cy="0"/>
+        </a:xfrm>
+      </p:grpSpPr>
       <p:sp>
         <p:nvSpPr>
-          <p:cNvPr id="3" name="Rounded Rectangle 2"/>
-          <p:cNvSpPr/>
+          <p:cNvPr id="2" name="TextBox 1"/>
+          <p:cNvSpPr txBox="1"/>
           <p:nvPr/>
         </p:nvSpPr>
         <p:spPr>
           <a:xfrm>
-            <a:off x="502920" y="1051560"/>
-            <a:ext cx="2514600" cy="868680"/>
+            <a:off x="411480" y="365760"/>
+            <a:ext cx="6858000" cy="594360"/>
           </a:xfrm>
-          <a:prstGeom prst="roundRect">
+          <a:prstGeom prst="rect">
             <a:avLst/>
           </a:prstGeom>
-          <a:solidFill>
-            <a:srgbClr val="F8F9FA"/>
-          </a:solidFill>
-          <a:ln>
-            <a:solidFill>
-              <a:srgbClr val="C00000"/>
-            </a:solidFill>
-          </a:ln>
+          <a:noFill/>
         </p:spPr>
-        <p:style>
-          <a:lnRef idx="1">
-            <a:schemeClr val="accent1"/>
-          </a:lnRef>
-          <a:fillRef idx="3">
-            <a:schemeClr val="accent1"/>
-          </a:fillRef>
-          <a:effectRef idx="2">
-            <a:schemeClr val="accent1"/>
-          </a:effectRef>
-          <a:fontRef idx="minor">
-            <a:schemeClr val="lt1"/>
-          </a:fontRef>
-        </p:style>
         <p:txBody>
-          <a:bodyPr rtlCol="0" anchor="ctr" wrap="square"/>
+          <a:bodyPr wrap="square">
+            <a:spAutoFit/>
+          </a:bodyPr>
           <a:lstStyle/>
           <a:p>
-            <a:pPr algn="ctr">
-              <a:defRPr sz="900" b="1">
+            <a:pPr>
+              <a:defRPr sz="1600" b="1">
+                <a:solidFill>
+                  <a:srgbClr val="C00000"/>
+                </a:solidFill>
+              </a:defRPr>
+            </a:pPr>
+            <a:r>
+              <a:t>2.1 ANALISIS PARETO UNFULLFILL - ALASAN KETERLAMBATAN (AGU-2026)</a:t>
+            </a:r>
+          </a:p>
+          <a:p>
+            <a:pPr>
+              <a:defRPr sz="850" b="1">
                 <a:solidFill>
                   <a:srgbClr val="646464"/>
                 </a:solidFill>
               </a:defRPr>
             </a:pPr>
             <a:r>
-              <a:t>SERVICE LEVEL KIRIM</a:t>
+              <a:t>📌 Filter Aktif: Bulan = AGU-2026 | MTM = KA | Pareto 80% (1 - 4 dari 4 Alasan)</a:t>
             </a:r>
           </a:p>
+        </p:txBody>
+      </p:sp>
+      <p:pic>
+        <p:nvPicPr>
+          <p:cNvPr id="3" name="Picture 2" descr="treemap_img_jdclackd.png"/>
+          <p:cNvPicPr>
+            <a:picLocks noChangeAspect="1"/>
+          </p:cNvPicPr>
+          <p:nvPr/>
+        </p:nvPicPr>
+        <p:blipFill>
+          <a:blip r:embed="rId4"/>
+          <a:stretch>
+            <a:fillRect/>
+          </a:stretch>
+        </p:blipFill>
+        <p:spPr>
+          <a:xfrm>
+            <a:off x="411480" y="1005840"/>
+            <a:ext cx="8183879" cy="3520440"/>
+          </a:xfrm>
+          <a:prstGeom prst="rect">
+            <a:avLst/>
+          </a:prstGeom>
+        </p:spPr>
+      </p:pic>
+    </p:spTree>
+    <p:extLst>
+      <p:ext uri="{BB962C8B-B14F-4D97-AF65-F5344CB8AC3E}">
+        <p14:creationId xmlns:p14="http://schemas.microsoft.com/office/powerpoint/2010/main" val="3012474682"/>
+      </p:ext>
+    </p:extLst>
+  </p:cSld>
+  <p:clrMapOvr>
+    <a:masterClrMapping/>
+  </p:clrMapOvr>
+</p:sld>
+</file>
+
+<file path=ppt/slides/slide5.xml><?xml version="1.0" encoding="utf-8"?>
+<p:sld xmlns:a="http://schemas.openxmlformats.org/drawingml/2006/main" xmlns:r="http://schemas.openxmlformats.org/officeDocument/2006/relationships" xmlns:p="http://schemas.openxmlformats.org/presentationml/2006/main">
+  <p:cSld>
+    <p:bg>
+      <p:bgPr>
+        <a:blipFill>
+          <a:blip r:embed="rId3"/>
+          <a:stretch>
+            <a:fillRect/>
+          </a:stretch>
+        </a:blipFill>
+        <a:effectLst/>
+      </p:bgPr>
+    </p:bg>
+    <p:spTree>
+      <p:nvGrpSpPr>
+        <p:cNvPr id="1" name="Shape 65">
+          <a:extLst>
+            <a:ext uri="{FF2B5EF4-FFF2-40B4-BE49-F238E27FC236}">
+              <a16:creationId xmlns:a16="http://schemas.microsoft.com/office/drawing/2014/main" id="{8290DC83-EC4D-3586-8C2A-30BF3570C910}"/>
+            </a:ext>
+          </a:extLst>
+        </p:cNvPr>
+        <p:cNvGrpSpPr/>
+        <p:nvPr/>
+      </p:nvGrpSpPr>
+      <p:grpSpPr>
+        <a:xfrm>
+          <a:off x="0" y="0"/>
+          <a:ext cx="0" cy="0"/>
+          <a:chOff x="0" y="0"/>
+          <a:chExt cx="0" cy="0"/>
+        </a:xfrm>
+      </p:grpSpPr>
+      <p:sp>
+        <p:nvSpPr>
+          <p:cNvPr id="2" name="TextBox 1"/>
+          <p:cNvSpPr txBox="1"/>
+          <p:nvPr/>
+        </p:nvSpPr>
+        <p:spPr>
+          <a:xfrm>
+            <a:off x="411480" y="365760"/>
+            <a:ext cx="6858000" cy="594360"/>
+          </a:xfrm>
+          <a:prstGeom prst="rect">
+            <a:avLst/>
+          </a:prstGeom>
+          <a:noFill/>
+        </p:spPr>
+        <p:txBody>
+          <a:bodyPr wrap="square">
+            <a:spAutoFit/>
+          </a:bodyPr>
+          <a:lstStyle/>
           <a:p>
-            <a:pPr algn="ctr">
-              <a:defRPr sz="1900" b="1">
+            <a:pPr>
+              <a:defRPr sz="1600" b="1">
                 <a:solidFill>
                   <a:srgbClr val="C00000"/>
                 </a:solidFill>
               </a:defRPr>
             </a:pPr>
             <a:r>
-              <a:t>87.1%</a:t>
+              <a:t>3.1 ANALISIS PARETO UNFULLFILL - AKUN MTM ALIAS (AGU-2026)</a:t>
             </a:r>
           </a:p>
           <a:p>
-            <a:pPr algn="ctr">
-              <a:defRPr sz="750">
-                <a:solidFill>
-                  <a:srgbClr val="787878"/>
-                </a:solidFill>
-              </a:defRPr>
-            </a:pPr>
-            <a:r>
-              <a:t>Target Acuan: 85.0%</a:t>
-            </a:r>
-          </a:p>
-        </p:txBody>
-      </p:sp>
-      <p:sp>
-        <p:nvSpPr>
-          <p:cNvPr id="4" name="Rounded Rectangle 3"/>
-          <p:cNvSpPr/>
-          <p:nvPr/>
-        </p:nvSpPr>
-        <p:spPr>
-          <a:xfrm>
-            <a:off x="3273552" y="1051560"/>
-            <a:ext cx="2514600" cy="868680"/>
-          </a:xfrm>
-          <a:prstGeom prst="roundRect">
-            <a:avLst/>
-          </a:prstGeom>
-          <a:solidFill>
-            <a:srgbClr val="F8F9FA"/>
-          </a:solidFill>
-          <a:ln>
-            <a:solidFill>
-              <a:srgbClr val="C00000"/>
-            </a:solidFill>
-          </a:ln>
-        </p:spPr>
-        <p:style>
-          <a:lnRef idx="1">
-            <a:schemeClr val="accent1"/>
-          </a:lnRef>
-          <a:fillRef idx="3">
-            <a:schemeClr val="accent1"/>
-          </a:fillRef>
-          <a:effectRef idx="2">
-            <a:schemeClr val="accent1"/>
-          </a:effectRef>
-          <a:fontRef idx="minor">
-            <a:schemeClr val="lt1"/>
-          </a:fontRef>
-        </p:style>
-        <p:txBody>
-          <a:bodyPr rtlCol="0" anchor="ctr" wrap="square"/>
-          <a:lstStyle/>
-          <a:p>
-            <a:pPr algn="ctr">
-              <a:defRPr sz="900" b="1">
+            <a:pPr>
+              <a:defRPr sz="850" b="1">
                 <a:solidFill>
                   <a:srgbClr val="646464"/>
                 </a:solidFill>
               </a:defRPr>
             </a:pPr>
             <a:r>
-              <a:t>SERVICE LEVEL REALISASI</a:t>
+              <a:t>📌 Filter Aktif: Bulan = AGU-2026 | MTM = KA | Pareto 80% (1 - 8 dari 8 Akun MTM)</a:t>
             </a:r>
           </a:p>
+        </p:txBody>
+      </p:sp>
+      <p:pic>
+        <p:nvPicPr>
+          <p:cNvPr id="3" name="Picture 2" descr="treemap_img_bwexl7db.png"/>
+          <p:cNvPicPr>
+            <a:picLocks noChangeAspect="1"/>
+          </p:cNvPicPr>
+          <p:nvPr/>
+        </p:nvPicPr>
+        <p:blipFill>
+          <a:blip r:embed="rId4"/>
+          <a:stretch>
+            <a:fillRect/>
+          </a:stretch>
+        </p:blipFill>
+        <p:spPr>
+          <a:xfrm>
+            <a:off x="411480" y="1005840"/>
+            <a:ext cx="8183879" cy="3520440"/>
+          </a:xfrm>
+          <a:prstGeom prst="rect">
+            <a:avLst/>
+          </a:prstGeom>
+        </p:spPr>
+      </p:pic>
+    </p:spTree>
+    <p:extLst>
+      <p:ext uri="{BB962C8B-B14F-4D97-AF65-F5344CB8AC3E}">
+        <p14:creationId xmlns:p14="http://schemas.microsoft.com/office/powerpoint/2010/main" val="3892127728"/>
+      </p:ext>
+    </p:extLst>
+  </p:cSld>
+  <p:clrMapOvr>
+    <a:masterClrMapping/>
+  </p:clrMapOvr>
+</p:sld>
+</file>
+
+<file path=ppt/slides/slide6.xml><?xml version="1.0" encoding="utf-8"?>
+<p:sld xmlns:a="http://schemas.openxmlformats.org/drawingml/2006/main" xmlns:r="http://schemas.openxmlformats.org/officeDocument/2006/relationships" xmlns:p="http://schemas.openxmlformats.org/presentationml/2006/main">
+  <p:cSld>
+    <p:bg>
+      <p:bgPr>
+        <a:blipFill>
+          <a:blip r:embed="rId3"/>
+          <a:stretch>
+            <a:fillRect/>
+          </a:stretch>
+        </a:blipFill>
+        <a:effectLst/>
+      </p:bgPr>
+    </p:bg>
+    <p:spTree>
+      <p:nvGrpSpPr>
+        <p:cNvPr id="1" name="Shape 65">
+          <a:extLst>
+            <a:ext uri="{FF2B5EF4-FFF2-40B4-BE49-F238E27FC236}">
+              <a16:creationId xmlns:a16="http://schemas.microsoft.com/office/drawing/2014/main" id="{12D3925E-80E8-B29F-04BB-63BBBFE47672}"/>
+            </a:ext>
+          </a:extLst>
+        </p:cNvPr>
+        <p:cNvGrpSpPr/>
+        <p:nvPr/>
+      </p:nvGrpSpPr>
+      <p:grpSpPr>
+        <a:xfrm>
+          <a:off x="0" y="0"/>
+          <a:ext cx="0" cy="0"/>
+          <a:chOff x="0" y="0"/>
+          <a:chExt cx="0" cy="0"/>
+        </a:xfrm>
+      </p:grpSpPr>
+      <p:sp>
+        <p:nvSpPr>
+          <p:cNvPr id="2" name="TextBox 1"/>
+          <p:cNvSpPr txBox="1"/>
+          <p:nvPr/>
+        </p:nvSpPr>
+        <p:spPr>
+          <a:xfrm>
+            <a:off x="411480" y="365760"/>
+            <a:ext cx="6858000" cy="594360"/>
+          </a:xfrm>
+          <a:prstGeom prst="rect">
+            <a:avLst/>
+          </a:prstGeom>
+          <a:noFill/>
+        </p:spPr>
+        <p:txBody>
+          <a:bodyPr wrap="square">
+            <a:spAutoFit/>
+          </a:bodyPr>
+          <a:lstStyle/>
           <a:p>
-            <a:pPr algn="ctr">
-              <a:defRPr sz="1900" b="1">
+            <a:pPr>
+              <a:defRPr sz="1600" b="1">
                 <a:solidFill>
                   <a:srgbClr val="C00000"/>
                 </a:solidFill>
               </a:defRPr>
             </a:pPr>
             <a:r>
-              <a:t>74.6%</a:t>
+              <a:t>4.1 ANALISIS PARETO UNFULLFILL - NAMA CABANG (AGU-2026)</a:t>
             </a:r>
           </a:p>
           <a:p>
-            <a:pPr algn="ctr">
-              <a:defRPr sz="750">
-                <a:solidFill>
-                  <a:srgbClr val="787878"/>
-                </a:solidFill>
-              </a:defRPr>
-            </a:pPr>
-            <a:r>
-              <a:t>Target Acuan: 85.0%</a:t>
-            </a:r>
-          </a:p>
-        </p:txBody>
-      </p:sp>
-      <p:sp>
-        <p:nvSpPr>
-          <p:cNvPr id="5" name="Rounded Rectangle 4"/>
-          <p:cNvSpPr/>
-          <p:nvPr/>
-        </p:nvSpPr>
-        <p:spPr>
-          <a:xfrm>
-            <a:off x="6044184" y="1051560"/>
-            <a:ext cx="2514600" cy="868680"/>
-          </a:xfrm>
-          <a:prstGeom prst="roundRect">
-            <a:avLst/>
-          </a:prstGeom>
-          <a:solidFill>
-            <a:srgbClr val="F8F9FA"/>
-          </a:solidFill>
-          <a:ln>
-            <a:solidFill>
-              <a:srgbClr val="C00000"/>
-            </a:solidFill>
-          </a:ln>
-        </p:spPr>
-        <p:style>
-          <a:lnRef idx="1">
-            <a:schemeClr val="accent1"/>
-          </a:lnRef>
-          <a:fillRef idx="3">
-            <a:schemeClr val="accent1"/>
-          </a:fillRef>
-          <a:effectRef idx="2">
-            <a:schemeClr val="accent1"/>
-          </a:effectRef>
-          <a:fontRef idx="minor">
-            <a:schemeClr val="lt1"/>
-          </a:fontRef>
-        </p:style>
-        <p:txBody>
-          <a:bodyPr rtlCol="0" anchor="ctr" wrap="square"/>
-          <a:lstStyle/>
-          <a:p>
-            <a:pPr algn="ctr">
-              <a:defRPr sz="900" b="1">
+            <a:pPr>
+              <a:defRPr sz="850" b="1">
                 <a:solidFill>
                   <a:srgbClr val="646464"/>
                 </a:solidFill>
               </a:defRPr>
             </a:pPr>
             <a:r>
-              <a:t>GAP REALISASI VS KIRIM</a:t>
+              <a:t>📌 Filter Aktif: Bulan = AGU-2026 | MTM = KA | Pareto 80% (1 - 16 dari 16 Cabang)</a:t>
             </a:r>
           </a:p>
+        </p:txBody>
+      </p:sp>
+      <p:pic>
+        <p:nvPicPr>
+          <p:cNvPr id="3" name="Picture 2" descr="treemap_img_5_jnvfv1.png"/>
+          <p:cNvPicPr>
+            <a:picLocks noChangeAspect="1"/>
+          </p:cNvPicPr>
+          <p:nvPr/>
+        </p:nvPicPr>
+        <p:blipFill>
+          <a:blip r:embed="rId4"/>
+          <a:stretch>
+            <a:fillRect/>
+          </a:stretch>
+        </p:blipFill>
+        <p:spPr>
+          <a:xfrm>
+            <a:off x="411480" y="1005840"/>
+            <a:ext cx="8183879" cy="3520440"/>
+          </a:xfrm>
+          <a:prstGeom prst="rect">
+            <a:avLst/>
+          </a:prstGeom>
+        </p:spPr>
+      </p:pic>
+    </p:spTree>
+    <p:extLst>
+      <p:ext uri="{BB962C8B-B14F-4D97-AF65-F5344CB8AC3E}">
+        <p14:creationId xmlns:p14="http://schemas.microsoft.com/office/powerpoint/2010/main" val="3356628504"/>
+      </p:ext>
+    </p:extLst>
+  </p:cSld>
+  <p:clrMapOvr>
+    <a:masterClrMapping/>
+  </p:clrMapOvr>
+</p:sld>
+</file>
+
+<file path=ppt/slides/slide7.xml><?xml version="1.0" encoding="utf-8"?>
+<p:sld xmlns:a="http://schemas.openxmlformats.org/drawingml/2006/main" xmlns:r="http://schemas.openxmlformats.org/officeDocument/2006/relationships" xmlns:p="http://schemas.openxmlformats.org/presentationml/2006/main">
+  <p:cSld>
+    <p:bg>
+      <p:bgPr>
+        <a:blipFill>
+          <a:blip r:embed="rId3"/>
+          <a:stretch>
+            <a:fillRect/>
+          </a:stretch>
+        </a:blipFill>
+        <a:effectLst/>
+      </p:bgPr>
+    </p:bg>
+    <p:spTree>
+      <p:nvGrpSpPr>
+        <p:cNvPr id="1" name="Shape 65">
+          <a:extLst>
+            <a:ext uri="{FF2B5EF4-FFF2-40B4-BE49-F238E27FC236}">
+              <a16:creationId xmlns:a16="http://schemas.microsoft.com/office/drawing/2014/main" id="{576672C9-1209-F7C7-1A25-228ECDABB35F}"/>
+            </a:ext>
+          </a:extLst>
+        </p:cNvPr>
+        <p:cNvGrpSpPr/>
+        <p:nvPr/>
+      </p:nvGrpSpPr>
+      <p:grpSpPr>
+        <a:xfrm>
+          <a:off x="0" y="0"/>
+          <a:ext cx="0" cy="0"/>
+          <a:chOff x="0" y="0"/>
+          <a:chExt cx="0" cy="0"/>
+        </a:xfrm>
+      </p:grpSpPr>
+      <p:sp>
+        <p:nvSpPr>
+          <p:cNvPr id="2" name="TextBox 1"/>
+          <p:cNvSpPr txBox="1"/>
+          <p:nvPr/>
+        </p:nvSpPr>
+        <p:spPr>
+          <a:xfrm>
+            <a:off x="411480" y="365760"/>
+            <a:ext cx="6858000" cy="594360"/>
+          </a:xfrm>
+          <a:prstGeom prst="rect">
+            <a:avLst/>
+          </a:prstGeom>
+          <a:noFill/>
+        </p:spPr>
+        <p:txBody>
+          <a:bodyPr wrap="square">
+            <a:spAutoFit/>
+          </a:bodyPr>
+          <a:lstStyle/>
           <a:p>
-            <a:pPr algn="ctr">
-              <a:defRPr sz="1900" b="1">
+            <a:pPr>
+              <a:defRPr sz="1600" b="1">
                 <a:solidFill>
-                  <a:srgbClr val="EF4444"/>
+                  <a:srgbClr val="C00000"/>
                 </a:solidFill>
               </a:defRPr>
             </a:pPr>
             <a:r>
-              <a:t>-12.5%</a:t>
+              <a:t>5.1 ANALISIS PARETO UNFULLFILL - GRUP BRAND (AGU-2026)</a:t>
             </a:r>
           </a:p>
           <a:p>
-            <a:pPr algn="ctr">
-              <a:defRPr sz="750">
+            <a:pPr>
+              <a:defRPr sz="850" b="1">
                 <a:solidFill>
-                  <a:srgbClr val="787878"/>
+                  <a:srgbClr val="646464"/>
                 </a:solidFill>
               </a:defRPr>
             </a:pPr>
             <a:r>
-              <a:t>Selisih Performa</a:t>
+              <a:t>📌 Filter Aktif: Bulan = AGU-2026 | MTM = KA | Pareto 80% (1 - 3 dari 3 Grup Brand)</a:t>
             </a:r>
           </a:p>
         </p:txBody>
       </p:sp>
+      <p:pic>
+        <p:nvPicPr>
+          <p:cNvPr id="3" name="Picture 2" descr="treemap_img_i9pt5cdl.png"/>
+          <p:cNvPicPr>
+            <a:picLocks noChangeAspect="1"/>
+          </p:cNvPicPr>
+          <p:nvPr/>
+        </p:nvPicPr>
+        <p:blipFill>
+          <a:blip r:embed="rId4"/>
+          <a:stretch>
+            <a:fillRect/>
+          </a:stretch>
+        </p:blipFill>
+        <p:spPr>
+          <a:xfrm>
+            <a:off x="411480" y="1005840"/>
+            <a:ext cx="8183879" cy="3520440"/>
+          </a:xfrm>
+          <a:prstGeom prst="rect">
+            <a:avLst/>
+          </a:prstGeom>
+        </p:spPr>
+      </p:pic>
     </p:spTree>
     <p:extLst>
       <p:ext uri="{BB962C8B-B14F-4D97-AF65-F5344CB8AC3E}">
-        <p14:creationId xmlns:p14="http://schemas.microsoft.com/office/powerpoint/2010/main" val="439507773"/>
+        <p14:creationId xmlns:p14="http://schemas.microsoft.com/office/powerpoint/2010/main" val="3674420193"/>
+      </p:ext>
+    </p:extLst>
+  </p:cSld>
+  <p:clrMapOvr>
+    <a:masterClrMapping/>
+  </p:clrMapOvr>
+</p:sld>
+</file>
+
+<file path=ppt/slides/slide8.xml><?xml version="1.0" encoding="utf-8"?>
+<p:sld xmlns:a="http://schemas.openxmlformats.org/drawingml/2006/main" xmlns:r="http://schemas.openxmlformats.org/officeDocument/2006/relationships" xmlns:p="http://schemas.openxmlformats.org/presentationml/2006/main">
+  <p:cSld>
+    <p:bg>
+      <p:bgPr>
+        <a:blipFill>
+          <a:blip r:embed="rId3"/>
+          <a:stretch>
+            <a:fillRect/>
+          </a:stretch>
+        </a:blipFill>
+        <a:effectLst/>
+      </p:bgPr>
+    </p:bg>
+    <p:spTree>
+      <p:nvGrpSpPr>
+        <p:cNvPr id="1" name="Shape 65">
+          <a:extLst>
+            <a:ext uri="{FF2B5EF4-FFF2-40B4-BE49-F238E27FC236}">
+              <a16:creationId xmlns:a16="http://schemas.microsoft.com/office/drawing/2014/main" id="{FB602098-D1C6-EF02-6157-47FD5E079D6C}"/>
+            </a:ext>
+          </a:extLst>
+        </p:cNvPr>
+        <p:cNvGrpSpPr/>
+        <p:nvPr/>
+      </p:nvGrpSpPr>
+      <p:grpSpPr>
+        <a:xfrm>
+          <a:off x="0" y="0"/>
+          <a:ext cx="0" cy="0"/>
+          <a:chOff x="0" y="0"/>
+          <a:chExt cx="0" cy="0"/>
+        </a:xfrm>
+      </p:grpSpPr>
+      <p:sp>
+        <p:nvSpPr>
+          <p:cNvPr id="2" name="TextBox 1"/>
+          <p:cNvSpPr txBox="1"/>
+          <p:nvPr/>
+        </p:nvSpPr>
+        <p:spPr>
+          <a:xfrm>
+            <a:off x="411480" y="365760"/>
+            <a:ext cx="6858000" cy="594360"/>
+          </a:xfrm>
+          <a:prstGeom prst="rect">
+            <a:avLst/>
+          </a:prstGeom>
+          <a:noFill/>
+        </p:spPr>
+        <p:txBody>
+          <a:bodyPr wrap="square">
+            <a:spAutoFit/>
+          </a:bodyPr>
+          <a:lstStyle/>
+          <a:p>
+            <a:pPr>
+              <a:defRPr sz="1600" b="1">
+                <a:solidFill>
+                  <a:srgbClr val="C00000"/>
+                </a:solidFill>
+              </a:defRPr>
+            </a:pPr>
+            <a:r>
+              <a:t>6.1 ANALISIS PARETO UNFULLFILL - ITEM / PRODUK SKU (AGU-2026)</a:t>
+            </a:r>
+          </a:p>
+          <a:p>
+            <a:pPr>
+              <a:defRPr sz="850" b="1">
+                <a:solidFill>
+                  <a:srgbClr val="646464"/>
+                </a:solidFill>
+              </a:defRPr>
+            </a:pPr>
+            <a:r>
+              <a:t>📌 Filter Aktif: Bulan = AGU-2026 | MTM = KA | Pareto 80% (1 - 34 dari 34 Item SKU)</a:t>
+            </a:r>
+          </a:p>
+        </p:txBody>
+      </p:sp>
+      <p:pic>
+        <p:nvPicPr>
+          <p:cNvPr id="3" name="Picture 2" descr="treemap_img_4hg09q00.png"/>
+          <p:cNvPicPr>
+            <a:picLocks noChangeAspect="1"/>
+          </p:cNvPicPr>
+          <p:nvPr/>
+        </p:nvPicPr>
+        <p:blipFill>
+          <a:blip r:embed="rId4"/>
+          <a:stretch>
+            <a:fillRect/>
+          </a:stretch>
+        </p:blipFill>
+        <p:spPr>
+          <a:xfrm>
+            <a:off x="411480" y="1005840"/>
+            <a:ext cx="8183879" cy="3520440"/>
+          </a:xfrm>
+          <a:prstGeom prst="rect">
+            <a:avLst/>
+          </a:prstGeom>
+        </p:spPr>
+      </p:pic>
+    </p:spTree>
+    <p:extLst>
+      <p:ext uri="{BB962C8B-B14F-4D97-AF65-F5344CB8AC3E}">
+        <p14:creationId xmlns:p14="http://schemas.microsoft.com/office/powerpoint/2010/main" val="2003159494"/>
       </p:ext>
     </p:extLst>
   </p:cSld>

</xml_diff>

<commit_message>
fix: resolve launcher path quote issue, enhance server connection handling, and sync latest dataset
</commit_message>
<xml_diff>
--- a/backend/generated_mtm_report.pptx
+++ b/backend/generated_mtm_report.pptx
@@ -16,6 +16,12 @@
     <p:sldId id="263" r:id="rId7"/>
     <p:sldId id="270" r:id="rId8"/>
     <p:sldId id="271" r:id="rId9"/>
+    <p:sldId id="266" r:id="rId10"/>
+    <p:sldId id="269" r:id="rId11"/>
+    <p:sldId id="267" r:id="rId12"/>
+    <p:sldId id="268" r:id="rId13"/>
+    <p:sldId id="265" r:id="rId14"/>
+    <p:sldId id="264" r:id="rId15"/>
     <p:sldId id="259" r:id="rId16"/>
   </p:sldIdLst>
   <p:sldSz cx="9144000" cy="5143500" type="screen16x9"/>
@@ -266,590 +272,6 @@
     </p:ext>
   </p:extLst>
 </p:presentation>
-</file>
-
-<file path=ppt/charts/chart1.xml><?xml version="1.0" encoding="utf-8"?>
-<c:chartSpace xmlns:c="http://schemas.openxmlformats.org/drawingml/2006/chart" xmlns:a="http://schemas.openxmlformats.org/drawingml/2006/main" xmlns:r="http://schemas.openxmlformats.org/officeDocument/2006/relationships">
-  <c:date1904 val="0"/>
-  <c:chart>
-    <c:autoTitleDeleted val="0"/>
-    <c:plotArea>
-      <c:barChart>
-        <c:barDir val="col"/>
-        <c:grouping val="clustered"/>
-        <c:ser>
-          <c:idx val="0"/>
-          <c:order val="0"/>
-          <c:tx>
-            <c:strRef>
-              <c:f>Sheet1!$B$1</c:f>
-              <c:strCache>
-                <c:ptCount val="1"/>
-                <c:pt idx="0">
-                  <c:v>SL Kirim (%)</c:v>
-                </c:pt>
-              </c:strCache>
-            </c:strRef>
-          </c:tx>
-          <c:spPr>
-            <a:solidFill>
-              <a:srgbClr val="C00000"/>
-            </a:solidFill>
-          </c:spPr>
-          <c:cat>
-            <c:strRef>
-              <c:f>Sheet1!$A$2:$A$9</c:f>
-              <c:strCache>
-                <c:ptCount val="8"/>
-                <c:pt idx="0">
-                  <c:v>JAN-2026</c:v>
-                </c:pt>
-                <c:pt idx="1">
-                  <c:v>FEB-2026</c:v>
-                </c:pt>
-                <c:pt idx="2">
-                  <c:v>MAR-2026</c:v>
-                </c:pt>
-                <c:pt idx="3">
-                  <c:v>APR-2026</c:v>
-                </c:pt>
-                <c:pt idx="4">
-                  <c:v>MEI-2026</c:v>
-                </c:pt>
-                <c:pt idx="5">
-                  <c:v>JUN-2026</c:v>
-                </c:pt>
-                <c:pt idx="6">
-                  <c:v>JUL-2026</c:v>
-                </c:pt>
-                <c:pt idx="7">
-                  <c:v>AGU-2026</c:v>
-                </c:pt>
-              </c:strCache>
-            </c:strRef>
-          </c:cat>
-          <c:val>
-            <c:numRef>
-              <c:f>Sheet1!$B$2:$B$9</c:f>
-              <c:numCache>
-                <c:formatCode>General</c:formatCode>
-                <c:ptCount val="8"/>
-                <c:pt idx="0">
-                  <c:v>73.2</c:v>
-                </c:pt>
-                <c:pt idx="1">
-                  <c:v>77.1</c:v>
-                </c:pt>
-                <c:pt idx="2">
-                  <c:v>86.1</c:v>
-                </c:pt>
-                <c:pt idx="3">
-                  <c:v>89.0</c:v>
-                </c:pt>
-                <c:pt idx="4">
-                  <c:v>90.7</c:v>
-                </c:pt>
-                <c:pt idx="5">
-                  <c:v>91.2</c:v>
-                </c:pt>
-                <c:pt idx="6">
-                  <c:v>89.7</c:v>
-                </c:pt>
-                <c:pt idx="7">
-                  <c:v>90.2</c:v>
-                </c:pt>
-              </c:numCache>
-            </c:numRef>
-          </c:val>
-        </c:ser>
-        <c:ser>
-          <c:idx val="1"/>
-          <c:order val="1"/>
-          <c:tx>
-            <c:strRef>
-              <c:f>Sheet1!$C$1</c:f>
-              <c:strCache>
-                <c:ptCount val="1"/>
-                <c:pt idx="0">
-                  <c:v>SL Realisasi (%)</c:v>
-                </c:pt>
-              </c:strCache>
-            </c:strRef>
-          </c:tx>
-          <c:spPr>
-            <a:solidFill>
-              <a:srgbClr val="2563EB"/>
-            </a:solidFill>
-          </c:spPr>
-          <c:cat>
-            <c:strRef>
-              <c:f>Sheet1!$A$2:$A$9</c:f>
-              <c:strCache>
-                <c:ptCount val="8"/>
-                <c:pt idx="0">
-                  <c:v>JAN-2026</c:v>
-                </c:pt>
-                <c:pt idx="1">
-                  <c:v>FEB-2026</c:v>
-                </c:pt>
-                <c:pt idx="2">
-                  <c:v>MAR-2026</c:v>
-                </c:pt>
-                <c:pt idx="3">
-                  <c:v>APR-2026</c:v>
-                </c:pt>
-                <c:pt idx="4">
-                  <c:v>MEI-2026</c:v>
-                </c:pt>
-                <c:pt idx="5">
-                  <c:v>JUN-2026</c:v>
-                </c:pt>
-                <c:pt idx="6">
-                  <c:v>JUL-2026</c:v>
-                </c:pt>
-                <c:pt idx="7">
-                  <c:v>AGU-2026</c:v>
-                </c:pt>
-              </c:strCache>
-            </c:strRef>
-          </c:cat>
-          <c:val>
-            <c:numRef>
-              <c:f>Sheet1!$C$2:$C$9</c:f>
-              <c:numCache>
-                <c:formatCode>General</c:formatCode>
-                <c:ptCount val="8"/>
-                <c:pt idx="0">
-                  <c:v>72.4</c:v>
-                </c:pt>
-                <c:pt idx="1">
-                  <c:v>76.2</c:v>
-                </c:pt>
-                <c:pt idx="2">
-                  <c:v>84.5</c:v>
-                </c:pt>
-                <c:pt idx="3">
-                  <c:v>88.1</c:v>
-                </c:pt>
-                <c:pt idx="4">
-                  <c:v>90.1</c:v>
-                </c:pt>
-                <c:pt idx="5">
-                  <c:v>90.5</c:v>
-                </c:pt>
-                <c:pt idx="6">
-                  <c:v>89.0</c:v>
-                </c:pt>
-                <c:pt idx="7">
-                  <c:v>89.5</c:v>
-                </c:pt>
-              </c:numCache>
-            </c:numRef>
-          </c:val>
-        </c:ser>
-        <c:dLbls>
-          <c:numFmt formatCode="0.0&quot;%&quot;" sourceLinked="0"/>
-          <c:txPr>
-            <a:bodyPr/>
-            <a:lstStyle/>
-            <a:p>
-              <a:pPr>
-                <a:defRPr sz="700" b="1">
-                  <a:solidFill>
-                    <a:srgbClr val="0F172A"/>
-                  </a:solidFill>
-                </a:defRPr>
-              </a:pPr>
-            </a:p>
-          </c:txPr>
-          <c:dLblPos val="outEnd"/>
-          <c:showLegendKey val="0"/>
-          <c:showVal val="1"/>
-          <c:showCatName val="0"/>
-          <c:showSerName val="0"/>
-          <c:showPercent val="0"/>
-          <c:showBubbleSize val="0"/>
-          <c:showLeaderLines val="1"/>
-        </c:dLbls>
-        <c:gapWidth val="55"/>
-        <c:overlap val="-10"/>
-        <c:axId val="-2068027336"/>
-        <c:axId val="-2113994440"/>
-      </c:barChart>
-      <c:catAx>
-        <c:axId val="-2068027336"/>
-        <c:scaling>
-          <c:orientation val="minMax"/>
-        </c:scaling>
-        <c:delete val="0"/>
-        <c:axPos val="b"/>
-        <c:majorTickMark val="out"/>
-        <c:minorTickMark val="none"/>
-        <c:tickLblPos val="nextTo"/>
-        <c:txPr>
-          <a:bodyPr/>
-          <a:lstStyle/>
-          <a:p>
-            <a:pPr>
-              <a:defRPr sz="850" b="1">
-                <a:solidFill>
-                  <a:srgbClr val="1E293B"/>
-                </a:solidFill>
-              </a:defRPr>
-            </a:pPr>
-          </a:p>
-        </c:txPr>
-        <c:crossAx val="-2113994440"/>
-        <c:crosses val="autoZero"/>
-        <c:auto val="1"/>
-        <c:lblAlgn val="ctr"/>
-        <c:lblOffset val="100"/>
-        <c:noMultiLvlLbl val="0"/>
-      </c:catAx>
-      <c:valAx>
-        <c:axId val="-2113994440"/>
-        <c:scaling>
-          <c:max val="115.0"/>
-          <c:min val="0.0"/>
-        </c:scaling>
-        <c:delete val="0"/>
-        <c:axPos val="l"/>
-        <c:majorTickMark val="out"/>
-        <c:minorTickMark val="none"/>
-        <c:tickLblPos val="nextTo"/>
-        <c:txPr>
-          <a:bodyPr/>
-          <a:lstStyle/>
-          <a:p>
-            <a:pPr>
-              <a:defRPr sz="800">
-                <a:solidFill>
-                  <a:srgbClr val="64748B"/>
-                </a:solidFill>
-              </a:defRPr>
-            </a:pPr>
-          </a:p>
-        </c:txPr>
-        <c:crossAx val="-2068027336"/>
-        <c:crosses val="autoZero"/>
-        <c:majorUnit val="20.0"/>
-      </c:valAx>
-    </c:plotArea>
-    <c:legend>
-      <c:legendPos val="t"/>
-      <c:overlay val="0"/>
-      <c:txPr>
-        <a:bodyPr/>
-        <a:lstStyle/>
-        <a:p>
-          <a:pPr>
-            <a:defRPr sz="850"/>
-          </a:pPr>
-        </a:p>
-      </c:txPr>
-    </c:legend>
-    <c:dispBlanksAs val="gap"/>
-  </c:chart>
-  <c:txPr>
-    <a:bodyPr/>
-    <a:lstStyle/>
-    <a:p>
-      <a:pPr>
-        <a:defRPr sz="1800"/>
-      </a:pPr>
-      <a:endParaRPr lang="en-US"/>
-    </a:p>
-  </c:txPr>
-  <c:externalData r:id="rId1">
-    <c:autoUpdate val="0"/>
-  </c:externalData>
-</c:chartSpace>
-</file>
-
-<file path=ppt/charts/chart2.xml><?xml version="1.0" encoding="utf-8"?>
-<c:chartSpace xmlns:c="http://schemas.openxmlformats.org/drawingml/2006/chart" xmlns:a="http://schemas.openxmlformats.org/drawingml/2006/main" xmlns:r="http://schemas.openxmlformats.org/officeDocument/2006/relationships">
-  <c:date1904 val="0"/>
-  <c:chart>
-    <c:autoTitleDeleted val="0"/>
-    <c:plotArea>
-      <c:barChart>
-        <c:barDir val="col"/>
-        <c:grouping val="clustered"/>
-        <c:ser>
-          <c:idx val="0"/>
-          <c:order val="0"/>
-          <c:tx>
-            <c:strRef>
-              <c:f>Sheet1!$B$1</c:f>
-              <c:strCache>
-                <c:ptCount val="1"/>
-                <c:pt idx="0">
-                  <c:v>SL Kirim (%)</c:v>
-                </c:pt>
-              </c:strCache>
-            </c:strRef>
-          </c:tx>
-          <c:spPr>
-            <a:solidFill>
-              <a:srgbClr val="C00000"/>
-            </a:solidFill>
-          </c:spPr>
-          <c:cat>
-            <c:strRef>
-              <c:f>Sheet1!$A$2:$A$8</c:f>
-              <c:strCache>
-                <c:ptCount val="7"/>
-                <c:pt idx="0">
-                  <c:v>GB 1</c:v>
-                </c:pt>
-                <c:pt idx="1">
-                  <c:v>GB 2</c:v>
-                </c:pt>
-                <c:pt idx="2">
-                  <c:v>GB 3</c:v>
-                </c:pt>
-                <c:pt idx="3">
-                  <c:v>GB 4</c:v>
-                </c:pt>
-                <c:pt idx="4">
-                  <c:v>GB 5</c:v>
-                </c:pt>
-                <c:pt idx="5">
-                  <c:v>GB 6</c:v>
-                </c:pt>
-                <c:pt idx="6">
-                  <c:v>GB ET</c:v>
-                </c:pt>
-              </c:strCache>
-            </c:strRef>
-          </c:cat>
-          <c:val>
-            <c:numRef>
-              <c:f>Sheet1!$B$2:$B$8</c:f>
-              <c:numCache>
-                <c:formatCode>General</c:formatCode>
-                <c:ptCount val="7"/>
-                <c:pt idx="0">
-                  <c:v>94.6</c:v>
-                </c:pt>
-                <c:pt idx="1">
-                  <c:v>90.4</c:v>
-                </c:pt>
-                <c:pt idx="2">
-                  <c:v>86.5</c:v>
-                </c:pt>
-                <c:pt idx="3">
-                  <c:v>90.7</c:v>
-                </c:pt>
-                <c:pt idx="4">
-                  <c:v>83.0</c:v>
-                </c:pt>
-                <c:pt idx="5">
-                  <c:v>96.8</c:v>
-                </c:pt>
-                <c:pt idx="6">
-                  <c:v>97.2</c:v>
-                </c:pt>
-              </c:numCache>
-            </c:numRef>
-          </c:val>
-        </c:ser>
-        <c:ser>
-          <c:idx val="1"/>
-          <c:order val="1"/>
-          <c:tx>
-            <c:strRef>
-              <c:f>Sheet1!$C$1</c:f>
-              <c:strCache>
-                <c:ptCount val="1"/>
-                <c:pt idx="0">
-                  <c:v>SL Realisasi (%)</c:v>
-                </c:pt>
-              </c:strCache>
-            </c:strRef>
-          </c:tx>
-          <c:spPr>
-            <a:solidFill>
-              <a:srgbClr val="2563EB"/>
-            </a:solidFill>
-          </c:spPr>
-          <c:cat>
-            <c:strRef>
-              <c:f>Sheet1!$A$2:$A$8</c:f>
-              <c:strCache>
-                <c:ptCount val="7"/>
-                <c:pt idx="0">
-                  <c:v>GB 1</c:v>
-                </c:pt>
-                <c:pt idx="1">
-                  <c:v>GB 2</c:v>
-                </c:pt>
-                <c:pt idx="2">
-                  <c:v>GB 3</c:v>
-                </c:pt>
-                <c:pt idx="3">
-                  <c:v>GB 4</c:v>
-                </c:pt>
-                <c:pt idx="4">
-                  <c:v>GB 5</c:v>
-                </c:pt>
-                <c:pt idx="5">
-                  <c:v>GB 6</c:v>
-                </c:pt>
-                <c:pt idx="6">
-                  <c:v>GB ET</c:v>
-                </c:pt>
-              </c:strCache>
-            </c:strRef>
-          </c:cat>
-          <c:val>
-            <c:numRef>
-              <c:f>Sheet1!$C$2:$C$8</c:f>
-              <c:numCache>
-                <c:formatCode>General</c:formatCode>
-                <c:ptCount val="7"/>
-                <c:pt idx="0">
-                  <c:v>94.3</c:v>
-                </c:pt>
-                <c:pt idx="1">
-                  <c:v>89.9</c:v>
-                </c:pt>
-                <c:pt idx="2">
-                  <c:v>85.8</c:v>
-                </c:pt>
-                <c:pt idx="3">
-                  <c:v>90.2</c:v>
-                </c:pt>
-                <c:pt idx="4">
-                  <c:v>82.2</c:v>
-                </c:pt>
-                <c:pt idx="5">
-                  <c:v>96.4</c:v>
-                </c:pt>
-                <c:pt idx="6">
-                  <c:v>84.4</c:v>
-                </c:pt>
-              </c:numCache>
-            </c:numRef>
-          </c:val>
-        </c:ser>
-        <c:dLbls>
-          <c:numFmt formatCode="0.0&quot;%&quot;" sourceLinked="0"/>
-          <c:txPr>
-            <a:bodyPr/>
-            <a:lstStyle/>
-            <a:p>
-              <a:pPr>
-                <a:defRPr sz="650" b="1">
-                  <a:solidFill>
-                    <a:srgbClr val="0F172A"/>
-                  </a:solidFill>
-                </a:defRPr>
-              </a:pPr>
-            </a:p>
-          </c:txPr>
-          <c:dLblPos val="outEnd"/>
-          <c:showLegendKey val="0"/>
-          <c:showVal val="1"/>
-          <c:showCatName val="0"/>
-          <c:showSerName val="0"/>
-          <c:showPercent val="0"/>
-          <c:showBubbleSize val="0"/>
-          <c:showLeaderLines val="1"/>
-        </c:dLbls>
-        <c:gapWidth val="55"/>
-        <c:overlap val="-10"/>
-        <c:axId val="-2068027336"/>
-        <c:axId val="-2113994440"/>
-      </c:barChart>
-      <c:catAx>
-        <c:axId val="-2068027336"/>
-        <c:scaling>
-          <c:orientation val="minMax"/>
-        </c:scaling>
-        <c:delete val="0"/>
-        <c:axPos val="b"/>
-        <c:majorTickMark val="out"/>
-        <c:minorTickMark val="none"/>
-        <c:tickLblPos val="nextTo"/>
-        <c:txPr>
-          <a:bodyPr/>
-          <a:lstStyle/>
-          <a:p>
-            <a:pPr>
-              <a:defRPr sz="750" b="1">
-                <a:solidFill>
-                  <a:srgbClr val="1E293B"/>
-                </a:solidFill>
-              </a:defRPr>
-            </a:pPr>
-          </a:p>
-        </c:txPr>
-        <c:crossAx val="-2113994440"/>
-        <c:crosses val="autoZero"/>
-        <c:auto val="1"/>
-        <c:lblAlgn val="ctr"/>
-        <c:lblOffset val="100"/>
-        <c:noMultiLvlLbl val="0"/>
-      </c:catAx>
-      <c:valAx>
-        <c:axId val="-2113994440"/>
-        <c:scaling>
-          <c:max val="115.0"/>
-          <c:min val="0.0"/>
-        </c:scaling>
-        <c:delete val="0"/>
-        <c:axPos val="l"/>
-        <c:majorTickMark val="out"/>
-        <c:minorTickMark val="none"/>
-        <c:tickLblPos val="nextTo"/>
-        <c:txPr>
-          <a:bodyPr/>
-          <a:lstStyle/>
-          <a:p>
-            <a:pPr>
-              <a:defRPr sz="750">
-                <a:solidFill>
-                  <a:srgbClr val="64748B"/>
-                </a:solidFill>
-              </a:defRPr>
-            </a:pPr>
-          </a:p>
-        </c:txPr>
-        <c:crossAx val="-2068027336"/>
-        <c:crosses val="autoZero"/>
-        <c:majorUnit val="20.0"/>
-      </c:valAx>
-    </c:plotArea>
-    <c:legend>
-      <c:legendPos val="t"/>
-      <c:overlay val="0"/>
-      <c:txPr>
-        <a:bodyPr/>
-        <a:lstStyle/>
-        <a:p>
-          <a:pPr>
-            <a:defRPr sz="800"/>
-          </a:pPr>
-        </a:p>
-      </c:txPr>
-    </c:legend>
-    <c:dispBlanksAs val="gap"/>
-  </c:chart>
-  <c:txPr>
-    <a:bodyPr/>
-    <a:lstStyle/>
-    <a:p>
-      <a:pPr>
-        <a:defRPr sz="1800"/>
-      </a:pPr>
-      <a:endParaRPr lang="en-US"/>
-    </a:p>
-  </c:txPr>
-  <c:externalData r:id="rId1">
-    <c:autoUpdate val="0"/>
-  </c:externalData>
-</c:chartSpace>
 </file>
 
 <file path=ppt/notesMasters/notesMaster1.xml><?xml version="1.0" encoding="utf-8"?>
@@ -1397,6 +819,641 @@
 </p:notes>
 </file>
 
+<file path=ppt/notesSlides/notesSlide10.xml><?xml version="1.0" encoding="utf-8"?>
+<p:notes xmlns:a="http://schemas.openxmlformats.org/drawingml/2006/main" xmlns:r="http://schemas.openxmlformats.org/officeDocument/2006/relationships" xmlns:p="http://schemas.openxmlformats.org/presentationml/2006/main" showMasterSp="0" showMasterPhAnim="0">
+  <p:cSld>
+    <p:spTree>
+      <p:nvGrpSpPr>
+        <p:cNvPr id="1" name="Shape 62">
+          <a:extLst>
+            <a:ext uri="{FF2B5EF4-FFF2-40B4-BE49-F238E27FC236}">
+              <a16:creationId xmlns:a16="http://schemas.microsoft.com/office/drawing/2014/main" id="{61B7D0EF-016A-4A7C-878B-8EBE05F3BD68}"/>
+            </a:ext>
+          </a:extLst>
+        </p:cNvPr>
+        <p:cNvGrpSpPr/>
+        <p:nvPr/>
+      </p:nvGrpSpPr>
+      <p:grpSpPr>
+        <a:xfrm>
+          <a:off x="0" y="0"/>
+          <a:ext cx="0" cy="0"/>
+          <a:chOff x="0" y="0"/>
+          <a:chExt cx="0" cy="0"/>
+        </a:xfrm>
+      </p:grpSpPr>
+      <p:sp>
+        <p:nvSpPr>
+          <p:cNvPr id="63" name="Google Shape;63;g359956e13c8_0_5:notes">
+            <a:extLst>
+              <a:ext uri="{FF2B5EF4-FFF2-40B4-BE49-F238E27FC236}">
+                <a16:creationId xmlns:a16="http://schemas.microsoft.com/office/drawing/2014/main" id="{2330CD92-FF13-3B9D-AE96-7F27438395DE}"/>
+              </a:ext>
+            </a:extLst>
+          </p:cNvPr>
+          <p:cNvSpPr>
+            <a:spLocks noGrp="1" noRot="1" noChangeAspect="1"/>
+          </p:cNvSpPr>
+          <p:nvPr>
+            <p:ph type="sldImg" idx="2"/>
+          </p:nvPr>
+        </p:nvSpPr>
+        <p:spPr>
+          <a:xfrm>
+            <a:off x="381000" y="685800"/>
+            <a:ext cx="6096000" cy="3429000"/>
+          </a:xfrm>
+          <a:custGeom>
+            <a:avLst/>
+            <a:gdLst/>
+            <a:ahLst/>
+            <a:cxnLst/>
+            <a:rect l="l" t="t" r="r" b="b"/>
+            <a:pathLst>
+              <a:path w="120000" h="120000" extrusionOk="0">
+                <a:moveTo>
+                  <a:pt x="0" y="0"/>
+                </a:moveTo>
+                <a:lnTo>
+                  <a:pt x="120000" y="0"/>
+                </a:lnTo>
+                <a:lnTo>
+                  <a:pt x="120000" y="120000"/>
+                </a:lnTo>
+                <a:lnTo>
+                  <a:pt x="0" y="120000"/>
+                </a:lnTo>
+                <a:close/>
+              </a:path>
+            </a:pathLst>
+          </a:custGeom>
+        </p:spPr>
+      </p:sp>
+      <p:sp>
+        <p:nvSpPr>
+          <p:cNvPr id="64" name="Google Shape;64;g359956e13c8_0_5:notes">
+            <a:extLst>
+              <a:ext uri="{FF2B5EF4-FFF2-40B4-BE49-F238E27FC236}">
+                <a16:creationId xmlns:a16="http://schemas.microsoft.com/office/drawing/2014/main" id="{8211F923-B081-362B-0760-DFA7DBD0EB30}"/>
+              </a:ext>
+            </a:extLst>
+          </p:cNvPr>
+          <p:cNvSpPr txBox="1">
+            <a:spLocks noGrp="1"/>
+          </p:cNvSpPr>
+          <p:nvPr>
+            <p:ph type="body" idx="1"/>
+          </p:nvPr>
+        </p:nvSpPr>
+        <p:spPr>
+          <a:xfrm>
+            <a:off x="685800" y="4343400"/>
+            <a:ext cx="5486400" cy="4114800"/>
+          </a:xfrm>
+          <a:prstGeom prst="rect">
+            <a:avLst/>
+          </a:prstGeom>
+        </p:spPr>
+        <p:txBody>
+          <a:bodyPr spcFirstLastPara="1" wrap="square" lIns="91425" tIns="91425" rIns="91425" bIns="91425" anchor="t" anchorCtr="0">
+            <a:noAutofit/>
+          </a:bodyPr>
+          <a:lstStyle/>
+          <a:p>
+            <a:pPr marL="0" lvl="0" indent="0" algn="l" rtl="0">
+              <a:spcBef>
+                <a:spcPts val="0"/>
+              </a:spcBef>
+              <a:spcAft>
+                <a:spcPts val="0"/>
+              </a:spcAft>
+              <a:buNone/>
+            </a:pPr>
+            <a:endParaRPr/>
+          </a:p>
+        </p:txBody>
+      </p:sp>
+    </p:spTree>
+    <p:extLst>
+      <p:ext uri="{BB962C8B-B14F-4D97-AF65-F5344CB8AC3E}">
+        <p14:creationId xmlns:p14="http://schemas.microsoft.com/office/powerpoint/2010/main" val="782501518"/>
+      </p:ext>
+    </p:extLst>
+  </p:cSld>
+  <p:clrMapOvr>
+    <a:masterClrMapping/>
+  </p:clrMapOvr>
+</p:notes>
+</file>
+
+<file path=ppt/notesSlides/notesSlide11.xml><?xml version="1.0" encoding="utf-8"?>
+<p:notes xmlns:a="http://schemas.openxmlformats.org/drawingml/2006/main" xmlns:r="http://schemas.openxmlformats.org/officeDocument/2006/relationships" xmlns:p="http://schemas.openxmlformats.org/presentationml/2006/main" showMasterSp="0" showMasterPhAnim="0">
+  <p:cSld>
+    <p:spTree>
+      <p:nvGrpSpPr>
+        <p:cNvPr id="1" name="Shape 62">
+          <a:extLst>
+            <a:ext uri="{FF2B5EF4-FFF2-40B4-BE49-F238E27FC236}">
+              <a16:creationId xmlns:a16="http://schemas.microsoft.com/office/drawing/2014/main" id="{A9035E2A-A1D9-CF75-9035-E0C41B14C706}"/>
+            </a:ext>
+          </a:extLst>
+        </p:cNvPr>
+        <p:cNvGrpSpPr/>
+        <p:nvPr/>
+      </p:nvGrpSpPr>
+      <p:grpSpPr>
+        <a:xfrm>
+          <a:off x="0" y="0"/>
+          <a:ext cx="0" cy="0"/>
+          <a:chOff x="0" y="0"/>
+          <a:chExt cx="0" cy="0"/>
+        </a:xfrm>
+      </p:grpSpPr>
+      <p:sp>
+        <p:nvSpPr>
+          <p:cNvPr id="63" name="Google Shape;63;g359956e13c8_0_5:notes">
+            <a:extLst>
+              <a:ext uri="{FF2B5EF4-FFF2-40B4-BE49-F238E27FC236}">
+                <a16:creationId xmlns:a16="http://schemas.microsoft.com/office/drawing/2014/main" id="{8105034D-FD2B-1CD5-D5EA-B1C8FA1FAC79}"/>
+              </a:ext>
+            </a:extLst>
+          </p:cNvPr>
+          <p:cNvSpPr>
+            <a:spLocks noGrp="1" noRot="1" noChangeAspect="1"/>
+          </p:cNvSpPr>
+          <p:nvPr>
+            <p:ph type="sldImg" idx="2"/>
+          </p:nvPr>
+        </p:nvSpPr>
+        <p:spPr>
+          <a:xfrm>
+            <a:off x="381000" y="685800"/>
+            <a:ext cx="6096000" cy="3429000"/>
+          </a:xfrm>
+          <a:custGeom>
+            <a:avLst/>
+            <a:gdLst/>
+            <a:ahLst/>
+            <a:cxnLst/>
+            <a:rect l="l" t="t" r="r" b="b"/>
+            <a:pathLst>
+              <a:path w="120000" h="120000" extrusionOk="0">
+                <a:moveTo>
+                  <a:pt x="0" y="0"/>
+                </a:moveTo>
+                <a:lnTo>
+                  <a:pt x="120000" y="0"/>
+                </a:lnTo>
+                <a:lnTo>
+                  <a:pt x="120000" y="120000"/>
+                </a:lnTo>
+                <a:lnTo>
+                  <a:pt x="0" y="120000"/>
+                </a:lnTo>
+                <a:close/>
+              </a:path>
+            </a:pathLst>
+          </a:custGeom>
+        </p:spPr>
+      </p:sp>
+      <p:sp>
+        <p:nvSpPr>
+          <p:cNvPr id="64" name="Google Shape;64;g359956e13c8_0_5:notes">
+            <a:extLst>
+              <a:ext uri="{FF2B5EF4-FFF2-40B4-BE49-F238E27FC236}">
+                <a16:creationId xmlns:a16="http://schemas.microsoft.com/office/drawing/2014/main" id="{2B995F57-B596-1FB8-2F5E-F279AD4CA26D}"/>
+              </a:ext>
+            </a:extLst>
+          </p:cNvPr>
+          <p:cNvSpPr txBox="1">
+            <a:spLocks noGrp="1"/>
+          </p:cNvSpPr>
+          <p:nvPr>
+            <p:ph type="body" idx="1"/>
+          </p:nvPr>
+        </p:nvSpPr>
+        <p:spPr>
+          <a:xfrm>
+            <a:off x="685800" y="4343400"/>
+            <a:ext cx="5486400" cy="4114800"/>
+          </a:xfrm>
+          <a:prstGeom prst="rect">
+            <a:avLst/>
+          </a:prstGeom>
+        </p:spPr>
+        <p:txBody>
+          <a:bodyPr spcFirstLastPara="1" wrap="square" lIns="91425" tIns="91425" rIns="91425" bIns="91425" anchor="t" anchorCtr="0">
+            <a:noAutofit/>
+          </a:bodyPr>
+          <a:lstStyle/>
+          <a:p>
+            <a:pPr marL="0" lvl="0" indent="0" algn="l" rtl="0">
+              <a:spcBef>
+                <a:spcPts val="0"/>
+              </a:spcBef>
+              <a:spcAft>
+                <a:spcPts val="0"/>
+              </a:spcAft>
+              <a:buNone/>
+            </a:pPr>
+            <a:endParaRPr/>
+          </a:p>
+        </p:txBody>
+      </p:sp>
+    </p:spTree>
+    <p:extLst>
+      <p:ext uri="{BB962C8B-B14F-4D97-AF65-F5344CB8AC3E}">
+        <p14:creationId xmlns:p14="http://schemas.microsoft.com/office/powerpoint/2010/main" val="3617224655"/>
+      </p:ext>
+    </p:extLst>
+  </p:cSld>
+  <p:clrMapOvr>
+    <a:masterClrMapping/>
+  </p:clrMapOvr>
+</p:notes>
+</file>
+
+<file path=ppt/notesSlides/notesSlide12.xml><?xml version="1.0" encoding="utf-8"?>
+<p:notes xmlns:a="http://schemas.openxmlformats.org/drawingml/2006/main" xmlns:r="http://schemas.openxmlformats.org/officeDocument/2006/relationships" xmlns:p="http://schemas.openxmlformats.org/presentationml/2006/main" showMasterSp="0" showMasterPhAnim="0">
+  <p:cSld>
+    <p:spTree>
+      <p:nvGrpSpPr>
+        <p:cNvPr id="1" name="Shape 62">
+          <a:extLst>
+            <a:ext uri="{FF2B5EF4-FFF2-40B4-BE49-F238E27FC236}">
+              <a16:creationId xmlns:a16="http://schemas.microsoft.com/office/drawing/2014/main" id="{43A8F4B5-84C3-A1C7-769E-CCA180E058D0}"/>
+            </a:ext>
+          </a:extLst>
+        </p:cNvPr>
+        <p:cNvGrpSpPr/>
+        <p:nvPr/>
+      </p:nvGrpSpPr>
+      <p:grpSpPr>
+        <a:xfrm>
+          <a:off x="0" y="0"/>
+          <a:ext cx="0" cy="0"/>
+          <a:chOff x="0" y="0"/>
+          <a:chExt cx="0" cy="0"/>
+        </a:xfrm>
+      </p:grpSpPr>
+      <p:sp>
+        <p:nvSpPr>
+          <p:cNvPr id="63" name="Google Shape;63;g359956e13c8_0_5:notes">
+            <a:extLst>
+              <a:ext uri="{FF2B5EF4-FFF2-40B4-BE49-F238E27FC236}">
+                <a16:creationId xmlns:a16="http://schemas.microsoft.com/office/drawing/2014/main" id="{7CF7AAB0-44D6-D635-BD4B-8C3F5D2F9942}"/>
+              </a:ext>
+            </a:extLst>
+          </p:cNvPr>
+          <p:cNvSpPr>
+            <a:spLocks noGrp="1" noRot="1" noChangeAspect="1"/>
+          </p:cNvSpPr>
+          <p:nvPr>
+            <p:ph type="sldImg" idx="2"/>
+          </p:nvPr>
+        </p:nvSpPr>
+        <p:spPr>
+          <a:xfrm>
+            <a:off x="381000" y="685800"/>
+            <a:ext cx="6096000" cy="3429000"/>
+          </a:xfrm>
+          <a:custGeom>
+            <a:avLst/>
+            <a:gdLst/>
+            <a:ahLst/>
+            <a:cxnLst/>
+            <a:rect l="l" t="t" r="r" b="b"/>
+            <a:pathLst>
+              <a:path w="120000" h="120000" extrusionOk="0">
+                <a:moveTo>
+                  <a:pt x="0" y="0"/>
+                </a:moveTo>
+                <a:lnTo>
+                  <a:pt x="120000" y="0"/>
+                </a:lnTo>
+                <a:lnTo>
+                  <a:pt x="120000" y="120000"/>
+                </a:lnTo>
+                <a:lnTo>
+                  <a:pt x="0" y="120000"/>
+                </a:lnTo>
+                <a:close/>
+              </a:path>
+            </a:pathLst>
+          </a:custGeom>
+        </p:spPr>
+      </p:sp>
+      <p:sp>
+        <p:nvSpPr>
+          <p:cNvPr id="64" name="Google Shape;64;g359956e13c8_0_5:notes">
+            <a:extLst>
+              <a:ext uri="{FF2B5EF4-FFF2-40B4-BE49-F238E27FC236}">
+                <a16:creationId xmlns:a16="http://schemas.microsoft.com/office/drawing/2014/main" id="{0A8FE482-77A2-3F2F-5CE1-93F303471E8F}"/>
+              </a:ext>
+            </a:extLst>
+          </p:cNvPr>
+          <p:cNvSpPr txBox="1">
+            <a:spLocks noGrp="1"/>
+          </p:cNvSpPr>
+          <p:nvPr>
+            <p:ph type="body" idx="1"/>
+          </p:nvPr>
+        </p:nvSpPr>
+        <p:spPr>
+          <a:xfrm>
+            <a:off x="685800" y="4343400"/>
+            <a:ext cx="5486400" cy="4114800"/>
+          </a:xfrm>
+          <a:prstGeom prst="rect">
+            <a:avLst/>
+          </a:prstGeom>
+        </p:spPr>
+        <p:txBody>
+          <a:bodyPr spcFirstLastPara="1" wrap="square" lIns="91425" tIns="91425" rIns="91425" bIns="91425" anchor="t" anchorCtr="0">
+            <a:noAutofit/>
+          </a:bodyPr>
+          <a:lstStyle/>
+          <a:p>
+            <a:pPr marL="0" lvl="0" indent="0" algn="l" rtl="0">
+              <a:spcBef>
+                <a:spcPts val="0"/>
+              </a:spcBef>
+              <a:spcAft>
+                <a:spcPts val="0"/>
+              </a:spcAft>
+              <a:buNone/>
+            </a:pPr>
+            <a:endParaRPr/>
+          </a:p>
+        </p:txBody>
+      </p:sp>
+    </p:spTree>
+    <p:extLst>
+      <p:ext uri="{BB962C8B-B14F-4D97-AF65-F5344CB8AC3E}">
+        <p14:creationId xmlns:p14="http://schemas.microsoft.com/office/powerpoint/2010/main" val="1578608578"/>
+      </p:ext>
+    </p:extLst>
+  </p:cSld>
+  <p:clrMapOvr>
+    <a:masterClrMapping/>
+  </p:clrMapOvr>
+</p:notes>
+</file>
+
+<file path=ppt/notesSlides/notesSlide13.xml><?xml version="1.0" encoding="utf-8"?>
+<p:notes xmlns:a="http://schemas.openxmlformats.org/drawingml/2006/main" xmlns:r="http://schemas.openxmlformats.org/officeDocument/2006/relationships" xmlns:p="http://schemas.openxmlformats.org/presentationml/2006/main" showMasterSp="0" showMasterPhAnim="0">
+  <p:cSld>
+    <p:spTree>
+      <p:nvGrpSpPr>
+        <p:cNvPr id="1" name="Shape 62">
+          <a:extLst>
+            <a:ext uri="{FF2B5EF4-FFF2-40B4-BE49-F238E27FC236}">
+              <a16:creationId xmlns:a16="http://schemas.microsoft.com/office/drawing/2014/main" id="{1C159C1C-07D8-CC85-D0BC-41A817854151}"/>
+            </a:ext>
+          </a:extLst>
+        </p:cNvPr>
+        <p:cNvGrpSpPr/>
+        <p:nvPr/>
+      </p:nvGrpSpPr>
+      <p:grpSpPr>
+        <a:xfrm>
+          <a:off x="0" y="0"/>
+          <a:ext cx="0" cy="0"/>
+          <a:chOff x="0" y="0"/>
+          <a:chExt cx="0" cy="0"/>
+        </a:xfrm>
+      </p:grpSpPr>
+      <p:sp>
+        <p:nvSpPr>
+          <p:cNvPr id="63" name="Google Shape;63;g359956e13c8_0_5:notes">
+            <a:extLst>
+              <a:ext uri="{FF2B5EF4-FFF2-40B4-BE49-F238E27FC236}">
+                <a16:creationId xmlns:a16="http://schemas.microsoft.com/office/drawing/2014/main" id="{18E5637A-5D45-6440-550F-265BD4B5363E}"/>
+              </a:ext>
+            </a:extLst>
+          </p:cNvPr>
+          <p:cNvSpPr>
+            <a:spLocks noGrp="1" noRot="1" noChangeAspect="1"/>
+          </p:cNvSpPr>
+          <p:nvPr>
+            <p:ph type="sldImg" idx="2"/>
+          </p:nvPr>
+        </p:nvSpPr>
+        <p:spPr>
+          <a:xfrm>
+            <a:off x="381000" y="685800"/>
+            <a:ext cx="6096000" cy="3429000"/>
+          </a:xfrm>
+          <a:custGeom>
+            <a:avLst/>
+            <a:gdLst/>
+            <a:ahLst/>
+            <a:cxnLst/>
+            <a:rect l="l" t="t" r="r" b="b"/>
+            <a:pathLst>
+              <a:path w="120000" h="120000" extrusionOk="0">
+                <a:moveTo>
+                  <a:pt x="0" y="0"/>
+                </a:moveTo>
+                <a:lnTo>
+                  <a:pt x="120000" y="0"/>
+                </a:lnTo>
+                <a:lnTo>
+                  <a:pt x="120000" y="120000"/>
+                </a:lnTo>
+                <a:lnTo>
+                  <a:pt x="0" y="120000"/>
+                </a:lnTo>
+                <a:close/>
+              </a:path>
+            </a:pathLst>
+          </a:custGeom>
+        </p:spPr>
+      </p:sp>
+      <p:sp>
+        <p:nvSpPr>
+          <p:cNvPr id="64" name="Google Shape;64;g359956e13c8_0_5:notes">
+            <a:extLst>
+              <a:ext uri="{FF2B5EF4-FFF2-40B4-BE49-F238E27FC236}">
+                <a16:creationId xmlns:a16="http://schemas.microsoft.com/office/drawing/2014/main" id="{9C906013-F764-31EC-F463-FFB54B8BC5D7}"/>
+              </a:ext>
+            </a:extLst>
+          </p:cNvPr>
+          <p:cNvSpPr txBox="1">
+            <a:spLocks noGrp="1"/>
+          </p:cNvSpPr>
+          <p:nvPr>
+            <p:ph type="body" idx="1"/>
+          </p:nvPr>
+        </p:nvSpPr>
+        <p:spPr>
+          <a:xfrm>
+            <a:off x="685800" y="4343400"/>
+            <a:ext cx="5486400" cy="4114800"/>
+          </a:xfrm>
+          <a:prstGeom prst="rect">
+            <a:avLst/>
+          </a:prstGeom>
+        </p:spPr>
+        <p:txBody>
+          <a:bodyPr spcFirstLastPara="1" wrap="square" lIns="91425" tIns="91425" rIns="91425" bIns="91425" anchor="t" anchorCtr="0">
+            <a:noAutofit/>
+          </a:bodyPr>
+          <a:lstStyle/>
+          <a:p>
+            <a:pPr marL="0" lvl="0" indent="0" algn="l" rtl="0">
+              <a:spcBef>
+                <a:spcPts val="0"/>
+              </a:spcBef>
+              <a:spcAft>
+                <a:spcPts val="0"/>
+              </a:spcAft>
+              <a:buNone/>
+            </a:pPr>
+            <a:endParaRPr/>
+          </a:p>
+        </p:txBody>
+      </p:sp>
+    </p:spTree>
+    <p:extLst>
+      <p:ext uri="{BB962C8B-B14F-4D97-AF65-F5344CB8AC3E}">
+        <p14:creationId xmlns:p14="http://schemas.microsoft.com/office/powerpoint/2010/main" val="1616506532"/>
+      </p:ext>
+    </p:extLst>
+  </p:cSld>
+  <p:clrMapOvr>
+    <a:masterClrMapping/>
+  </p:clrMapOvr>
+</p:notes>
+</file>
+
+<file path=ppt/notesSlides/notesSlide14.xml><?xml version="1.0" encoding="utf-8"?>
+<p:notes xmlns:a="http://schemas.openxmlformats.org/drawingml/2006/main" xmlns:r="http://schemas.openxmlformats.org/officeDocument/2006/relationships" xmlns:p="http://schemas.openxmlformats.org/presentationml/2006/main" showMasterSp="0" showMasterPhAnim="0">
+  <p:cSld>
+    <p:spTree>
+      <p:nvGrpSpPr>
+        <p:cNvPr id="1" name="Shape 62">
+          <a:extLst>
+            <a:ext uri="{FF2B5EF4-FFF2-40B4-BE49-F238E27FC236}">
+              <a16:creationId xmlns:a16="http://schemas.microsoft.com/office/drawing/2014/main" id="{0A7FF4F6-A366-0D88-28B1-68D0D42C07FC}"/>
+            </a:ext>
+          </a:extLst>
+        </p:cNvPr>
+        <p:cNvGrpSpPr/>
+        <p:nvPr/>
+      </p:nvGrpSpPr>
+      <p:grpSpPr>
+        <a:xfrm>
+          <a:off x="0" y="0"/>
+          <a:ext cx="0" cy="0"/>
+          <a:chOff x="0" y="0"/>
+          <a:chExt cx="0" cy="0"/>
+        </a:xfrm>
+      </p:grpSpPr>
+      <p:sp>
+        <p:nvSpPr>
+          <p:cNvPr id="63" name="Google Shape;63;g359956e13c8_0_5:notes">
+            <a:extLst>
+              <a:ext uri="{FF2B5EF4-FFF2-40B4-BE49-F238E27FC236}">
+                <a16:creationId xmlns:a16="http://schemas.microsoft.com/office/drawing/2014/main" id="{72337A15-678A-ADD6-F47D-06477CD2AA95}"/>
+              </a:ext>
+            </a:extLst>
+          </p:cNvPr>
+          <p:cNvSpPr>
+            <a:spLocks noGrp="1" noRot="1" noChangeAspect="1"/>
+          </p:cNvSpPr>
+          <p:nvPr>
+            <p:ph type="sldImg" idx="2"/>
+          </p:nvPr>
+        </p:nvSpPr>
+        <p:spPr>
+          <a:xfrm>
+            <a:off x="381000" y="685800"/>
+            <a:ext cx="6096000" cy="3429000"/>
+          </a:xfrm>
+          <a:custGeom>
+            <a:avLst/>
+            <a:gdLst/>
+            <a:ahLst/>
+            <a:cxnLst/>
+            <a:rect l="l" t="t" r="r" b="b"/>
+            <a:pathLst>
+              <a:path w="120000" h="120000" extrusionOk="0">
+                <a:moveTo>
+                  <a:pt x="0" y="0"/>
+                </a:moveTo>
+                <a:lnTo>
+                  <a:pt x="120000" y="0"/>
+                </a:lnTo>
+                <a:lnTo>
+                  <a:pt x="120000" y="120000"/>
+                </a:lnTo>
+                <a:lnTo>
+                  <a:pt x="0" y="120000"/>
+                </a:lnTo>
+                <a:close/>
+              </a:path>
+            </a:pathLst>
+          </a:custGeom>
+        </p:spPr>
+      </p:sp>
+      <p:sp>
+        <p:nvSpPr>
+          <p:cNvPr id="64" name="Google Shape;64;g359956e13c8_0_5:notes">
+            <a:extLst>
+              <a:ext uri="{FF2B5EF4-FFF2-40B4-BE49-F238E27FC236}">
+                <a16:creationId xmlns:a16="http://schemas.microsoft.com/office/drawing/2014/main" id="{2BAAE48E-3361-5E29-D263-8A97CE1636B2}"/>
+              </a:ext>
+            </a:extLst>
+          </p:cNvPr>
+          <p:cNvSpPr txBox="1">
+            <a:spLocks noGrp="1"/>
+          </p:cNvSpPr>
+          <p:nvPr>
+            <p:ph type="body" idx="1"/>
+          </p:nvPr>
+        </p:nvSpPr>
+        <p:spPr>
+          <a:xfrm>
+            <a:off x="685800" y="4343400"/>
+            <a:ext cx="5486400" cy="4114800"/>
+          </a:xfrm>
+          <a:prstGeom prst="rect">
+            <a:avLst/>
+          </a:prstGeom>
+        </p:spPr>
+        <p:txBody>
+          <a:bodyPr spcFirstLastPara="1" wrap="square" lIns="91425" tIns="91425" rIns="91425" bIns="91425" anchor="t" anchorCtr="0">
+            <a:noAutofit/>
+          </a:bodyPr>
+          <a:lstStyle/>
+          <a:p>
+            <a:pPr marL="0" lvl="0" indent="0" algn="l" rtl="0">
+              <a:spcBef>
+                <a:spcPts val="0"/>
+              </a:spcBef>
+              <a:spcAft>
+                <a:spcPts val="0"/>
+              </a:spcAft>
+              <a:buNone/>
+            </a:pPr>
+            <a:endParaRPr/>
+          </a:p>
+        </p:txBody>
+      </p:sp>
+    </p:spTree>
+    <p:extLst>
+      <p:ext uri="{BB962C8B-B14F-4D97-AF65-F5344CB8AC3E}">
+        <p14:creationId xmlns:p14="http://schemas.microsoft.com/office/powerpoint/2010/main" val="1018412350"/>
+      </p:ext>
+    </p:extLst>
+  </p:cSld>
+  <p:clrMapOvr>
+    <a:masterClrMapping/>
+  </p:clrMapOvr>
+</p:notes>
+</file>
+
 <file path=ppt/notesSlides/notesSlide15.xml><?xml version="1.0" encoding="utf-8"?>
 <p:notes xmlns:a="http://schemas.openxmlformats.org/drawingml/2006/main" xmlns:r="http://schemas.openxmlformats.org/officeDocument/2006/relationships" xmlns:p="http://schemas.openxmlformats.org/presentationml/2006/main" showMasterSp="0" showMasterPhAnim="0">
   <p:cSld>
@@ -2358,6 +2415,133 @@
     <p:extLst>
       <p:ext uri="{BB962C8B-B14F-4D97-AF65-F5344CB8AC3E}">
         <p14:creationId xmlns:p14="http://schemas.microsoft.com/office/powerpoint/2010/main" val="570827785"/>
+      </p:ext>
+    </p:extLst>
+  </p:cSld>
+  <p:clrMapOvr>
+    <a:masterClrMapping/>
+  </p:clrMapOvr>
+</p:notes>
+</file>
+
+<file path=ppt/notesSlides/notesSlide9.xml><?xml version="1.0" encoding="utf-8"?>
+<p:notes xmlns:a="http://schemas.openxmlformats.org/drawingml/2006/main" xmlns:r="http://schemas.openxmlformats.org/officeDocument/2006/relationships" xmlns:p="http://schemas.openxmlformats.org/presentationml/2006/main" showMasterSp="0" showMasterPhAnim="0">
+  <p:cSld>
+    <p:spTree>
+      <p:nvGrpSpPr>
+        <p:cNvPr id="1" name="Shape 62">
+          <a:extLst>
+            <a:ext uri="{FF2B5EF4-FFF2-40B4-BE49-F238E27FC236}">
+              <a16:creationId xmlns:a16="http://schemas.microsoft.com/office/drawing/2014/main" id="{19FFE525-B9C3-85BF-BEF2-605997922F4D}"/>
+            </a:ext>
+          </a:extLst>
+        </p:cNvPr>
+        <p:cNvGrpSpPr/>
+        <p:nvPr/>
+      </p:nvGrpSpPr>
+      <p:grpSpPr>
+        <a:xfrm>
+          <a:off x="0" y="0"/>
+          <a:ext cx="0" cy="0"/>
+          <a:chOff x="0" y="0"/>
+          <a:chExt cx="0" cy="0"/>
+        </a:xfrm>
+      </p:grpSpPr>
+      <p:sp>
+        <p:nvSpPr>
+          <p:cNvPr id="63" name="Google Shape;63;g359956e13c8_0_5:notes">
+            <a:extLst>
+              <a:ext uri="{FF2B5EF4-FFF2-40B4-BE49-F238E27FC236}">
+                <a16:creationId xmlns:a16="http://schemas.microsoft.com/office/drawing/2014/main" id="{19919787-6D23-5A50-D70D-37EF26624F6B}"/>
+              </a:ext>
+            </a:extLst>
+          </p:cNvPr>
+          <p:cNvSpPr>
+            <a:spLocks noGrp="1" noRot="1" noChangeAspect="1"/>
+          </p:cNvSpPr>
+          <p:nvPr>
+            <p:ph type="sldImg" idx="2"/>
+          </p:nvPr>
+        </p:nvSpPr>
+        <p:spPr>
+          <a:xfrm>
+            <a:off x="381000" y="685800"/>
+            <a:ext cx="6096000" cy="3429000"/>
+          </a:xfrm>
+          <a:custGeom>
+            <a:avLst/>
+            <a:gdLst/>
+            <a:ahLst/>
+            <a:cxnLst/>
+            <a:rect l="l" t="t" r="r" b="b"/>
+            <a:pathLst>
+              <a:path w="120000" h="120000" extrusionOk="0">
+                <a:moveTo>
+                  <a:pt x="0" y="0"/>
+                </a:moveTo>
+                <a:lnTo>
+                  <a:pt x="120000" y="0"/>
+                </a:lnTo>
+                <a:lnTo>
+                  <a:pt x="120000" y="120000"/>
+                </a:lnTo>
+                <a:lnTo>
+                  <a:pt x="0" y="120000"/>
+                </a:lnTo>
+                <a:close/>
+              </a:path>
+            </a:pathLst>
+          </a:custGeom>
+        </p:spPr>
+      </p:sp>
+      <p:sp>
+        <p:nvSpPr>
+          <p:cNvPr id="64" name="Google Shape;64;g359956e13c8_0_5:notes">
+            <a:extLst>
+              <a:ext uri="{FF2B5EF4-FFF2-40B4-BE49-F238E27FC236}">
+                <a16:creationId xmlns:a16="http://schemas.microsoft.com/office/drawing/2014/main" id="{2BF22B23-C2A7-6B5C-3BA3-39EABE3C6807}"/>
+              </a:ext>
+            </a:extLst>
+          </p:cNvPr>
+          <p:cNvSpPr txBox="1">
+            <a:spLocks noGrp="1"/>
+          </p:cNvSpPr>
+          <p:nvPr>
+            <p:ph type="body" idx="1"/>
+          </p:nvPr>
+        </p:nvSpPr>
+        <p:spPr>
+          <a:xfrm>
+            <a:off x="685800" y="4343400"/>
+            <a:ext cx="5486400" cy="4114800"/>
+          </a:xfrm>
+          <a:prstGeom prst="rect">
+            <a:avLst/>
+          </a:prstGeom>
+        </p:spPr>
+        <p:txBody>
+          <a:bodyPr spcFirstLastPara="1" wrap="square" lIns="91425" tIns="91425" rIns="91425" bIns="91425" anchor="t" anchorCtr="0">
+            <a:noAutofit/>
+          </a:bodyPr>
+          <a:lstStyle/>
+          <a:p>
+            <a:pPr marL="0" lvl="0" indent="0" algn="l" rtl="0">
+              <a:spcBef>
+                <a:spcPts val="0"/>
+              </a:spcBef>
+              <a:spcAft>
+                <a:spcPts val="0"/>
+              </a:spcAft>
+              <a:buNone/>
+            </a:pPr>
+            <a:endParaRPr/>
+          </a:p>
+        </p:txBody>
+      </p:sp>
+    </p:spTree>
+    <p:extLst>
+      <p:ext uri="{BB962C8B-B14F-4D97-AF65-F5344CB8AC3E}">
+        <p14:creationId xmlns:p14="http://schemas.microsoft.com/office/powerpoint/2010/main" val="4025963139"/>
       </p:ext>
     </p:extLst>
   </p:cSld>
@@ -6814,28 +6998,8 @@
                 <a:spcPts val="0"/>
               </a:spcAft>
               <a:buNone/>
-              <a:defRPr sz="2000" b="1">
-                <a:solidFill>
-                  <a:srgbClr val="FFFFFF"/>
-                </a:solidFill>
-              </a:defRPr>
             </a:pPr>
-            <a:r>
-              <a:t>LAPORAN EXECUTIVE SERVICE LEVEL MTM</a:t>
-            </a:r>
             <a:endParaRPr sz="2400" dirty="0"/>
-          </a:p>
-          <a:p>
-            <a:pPr>
-              <a:defRPr sz="1200">
-                <a:solidFill>
-                  <a:srgbClr val="FFD700"/>
-                </a:solidFill>
-              </a:defRPr>
-            </a:pPr>
-            <a:r>
-              <a:t>Analisis Performa Pengiriman, Realisasi, dan Pareto Unfulfill</a:t>
-            </a:r>
           </a:p>
         </p:txBody>
       </p:sp>
@@ -6872,20 +7036,382 @@
                 <a:spcPts val="0"/>
               </a:spcAft>
               <a:buNone/>
-              <a:defRPr sz="950" b="1">
-                <a:solidFill>
-                  <a:srgbClr val="FFFFFF"/>
-                </a:solidFill>
-              </a:defRPr>
             </a:pPr>
-            <a:r>
-              <a:t>PERIODE FILTER: Bulan = AGU-2026 | MTM = KA</a:t>
-            </a:r>
             <a:endParaRPr dirty="0"/>
           </a:p>
         </p:txBody>
       </p:sp>
     </p:spTree>
+  </p:cSld>
+  <p:clrMapOvr>
+    <a:masterClrMapping/>
+  </p:clrMapOvr>
+</p:sld>
+</file>
+
+<file path=ppt/slides/slide10.xml><?xml version="1.0" encoding="utf-8"?>
+<p:sld xmlns:a="http://schemas.openxmlformats.org/drawingml/2006/main" xmlns:r="http://schemas.openxmlformats.org/officeDocument/2006/relationships" xmlns:p="http://schemas.openxmlformats.org/presentationml/2006/main">
+  <p:cSld>
+    <p:bg>
+      <p:bgPr>
+        <a:blipFill>
+          <a:blip r:embed="rId3"/>
+          <a:stretch>
+            <a:fillRect/>
+          </a:stretch>
+        </a:blipFill>
+        <a:effectLst/>
+      </p:bgPr>
+    </p:bg>
+    <p:spTree>
+      <p:nvGrpSpPr>
+        <p:cNvPr id="1" name="Shape 65">
+          <a:extLst>
+            <a:ext uri="{FF2B5EF4-FFF2-40B4-BE49-F238E27FC236}">
+              <a16:creationId xmlns:a16="http://schemas.microsoft.com/office/drawing/2014/main" id="{A12EBA9A-DA19-29D5-0B95-A306FB0F36C4}"/>
+            </a:ext>
+          </a:extLst>
+        </p:cNvPr>
+        <p:cNvGrpSpPr/>
+        <p:nvPr/>
+      </p:nvGrpSpPr>
+      <p:grpSpPr>
+        <a:xfrm>
+          <a:off x="0" y="0"/>
+          <a:ext cx="0" cy="0"/>
+          <a:chOff x="0" y="0"/>
+          <a:chExt cx="0" cy="0"/>
+        </a:xfrm>
+      </p:grpSpPr>
+      <p:sp>
+        <p:nvSpPr>
+          <p:cNvPr id="5" name="Title 4">
+            <a:extLst>
+              <a:ext uri="{FF2B5EF4-FFF2-40B4-BE49-F238E27FC236}">
+                <a16:creationId xmlns:a16="http://schemas.microsoft.com/office/drawing/2014/main" id="{94F76BFB-1D1A-8727-0F67-89A13F3A1B67}"/>
+              </a:ext>
+            </a:extLst>
+          </p:cNvPr>
+          <p:cNvSpPr>
+            <a:spLocks noGrp="1"/>
+          </p:cNvSpPr>
+          <p:nvPr>
+            <p:ph type="title"/>
+          </p:nvPr>
+        </p:nvSpPr>
+        <p:spPr/>
+        <p:txBody>
+          <a:bodyPr>
+            <a:normAutofit fontScale="90000"/>
+          </a:bodyPr>
+          <a:lstStyle/>
+          <a:p>
+            <a:endParaRPr lang="en-ID"/>
+          </a:p>
+        </p:txBody>
+      </p:sp>
+    </p:spTree>
+    <p:extLst>
+      <p:ext uri="{BB962C8B-B14F-4D97-AF65-F5344CB8AC3E}">
+        <p14:creationId xmlns:p14="http://schemas.microsoft.com/office/powerpoint/2010/main" val="3265166932"/>
+      </p:ext>
+    </p:extLst>
+  </p:cSld>
+  <p:clrMapOvr>
+    <a:masterClrMapping/>
+  </p:clrMapOvr>
+</p:sld>
+</file>
+
+<file path=ppt/slides/slide11.xml><?xml version="1.0" encoding="utf-8"?>
+<p:sld xmlns:a="http://schemas.openxmlformats.org/drawingml/2006/main" xmlns:r="http://schemas.openxmlformats.org/officeDocument/2006/relationships" xmlns:p="http://schemas.openxmlformats.org/presentationml/2006/main">
+  <p:cSld>
+    <p:bg>
+      <p:bgPr>
+        <a:blipFill>
+          <a:blip r:embed="rId3"/>
+          <a:stretch>
+            <a:fillRect/>
+          </a:stretch>
+        </a:blipFill>
+        <a:effectLst/>
+      </p:bgPr>
+    </p:bg>
+    <p:spTree>
+      <p:nvGrpSpPr>
+        <p:cNvPr id="1" name="Shape 65">
+          <a:extLst>
+            <a:ext uri="{FF2B5EF4-FFF2-40B4-BE49-F238E27FC236}">
+              <a16:creationId xmlns:a16="http://schemas.microsoft.com/office/drawing/2014/main" id="{D48E1645-063B-09BC-F293-FED7ECC0BF9F}"/>
+            </a:ext>
+          </a:extLst>
+        </p:cNvPr>
+        <p:cNvGrpSpPr/>
+        <p:nvPr/>
+      </p:nvGrpSpPr>
+      <p:grpSpPr>
+        <a:xfrm>
+          <a:off x="0" y="0"/>
+          <a:ext cx="0" cy="0"/>
+          <a:chOff x="0" y="0"/>
+          <a:chExt cx="0" cy="0"/>
+        </a:xfrm>
+      </p:grpSpPr>
+      <p:sp>
+        <p:nvSpPr>
+          <p:cNvPr id="5" name="Title 4">
+            <a:extLst>
+              <a:ext uri="{FF2B5EF4-FFF2-40B4-BE49-F238E27FC236}">
+                <a16:creationId xmlns:a16="http://schemas.microsoft.com/office/drawing/2014/main" id="{097C93F1-EBE7-EB4E-74C1-58E38670B0A3}"/>
+              </a:ext>
+            </a:extLst>
+          </p:cNvPr>
+          <p:cNvSpPr>
+            <a:spLocks noGrp="1"/>
+          </p:cNvSpPr>
+          <p:nvPr>
+            <p:ph type="title"/>
+          </p:nvPr>
+        </p:nvSpPr>
+        <p:spPr/>
+        <p:txBody>
+          <a:bodyPr>
+            <a:normAutofit fontScale="90000"/>
+          </a:bodyPr>
+          <a:lstStyle/>
+          <a:p>
+            <a:endParaRPr lang="en-ID"/>
+          </a:p>
+        </p:txBody>
+      </p:sp>
+    </p:spTree>
+    <p:extLst>
+      <p:ext uri="{BB962C8B-B14F-4D97-AF65-F5344CB8AC3E}">
+        <p14:creationId xmlns:p14="http://schemas.microsoft.com/office/powerpoint/2010/main" val="1589716599"/>
+      </p:ext>
+    </p:extLst>
+  </p:cSld>
+  <p:clrMapOvr>
+    <a:masterClrMapping/>
+  </p:clrMapOvr>
+</p:sld>
+</file>
+
+<file path=ppt/slides/slide12.xml><?xml version="1.0" encoding="utf-8"?>
+<p:sld xmlns:a="http://schemas.openxmlformats.org/drawingml/2006/main" xmlns:r="http://schemas.openxmlformats.org/officeDocument/2006/relationships" xmlns:p="http://schemas.openxmlformats.org/presentationml/2006/main">
+  <p:cSld>
+    <p:bg>
+      <p:bgPr>
+        <a:blipFill>
+          <a:blip r:embed="rId3"/>
+          <a:stretch>
+            <a:fillRect/>
+          </a:stretch>
+        </a:blipFill>
+        <a:effectLst/>
+      </p:bgPr>
+    </p:bg>
+    <p:spTree>
+      <p:nvGrpSpPr>
+        <p:cNvPr id="1" name="Shape 65">
+          <a:extLst>
+            <a:ext uri="{FF2B5EF4-FFF2-40B4-BE49-F238E27FC236}">
+              <a16:creationId xmlns:a16="http://schemas.microsoft.com/office/drawing/2014/main" id="{B191C14E-3FF4-C0CF-05AA-E8CB8025671F}"/>
+            </a:ext>
+          </a:extLst>
+        </p:cNvPr>
+        <p:cNvGrpSpPr/>
+        <p:nvPr/>
+      </p:nvGrpSpPr>
+      <p:grpSpPr>
+        <a:xfrm>
+          <a:off x="0" y="0"/>
+          <a:ext cx="0" cy="0"/>
+          <a:chOff x="0" y="0"/>
+          <a:chExt cx="0" cy="0"/>
+        </a:xfrm>
+      </p:grpSpPr>
+      <p:sp>
+        <p:nvSpPr>
+          <p:cNvPr id="5" name="Title 4">
+            <a:extLst>
+              <a:ext uri="{FF2B5EF4-FFF2-40B4-BE49-F238E27FC236}">
+                <a16:creationId xmlns:a16="http://schemas.microsoft.com/office/drawing/2014/main" id="{485FD782-D77D-A60C-62FD-E297C6800CB3}"/>
+              </a:ext>
+            </a:extLst>
+          </p:cNvPr>
+          <p:cNvSpPr>
+            <a:spLocks noGrp="1"/>
+          </p:cNvSpPr>
+          <p:nvPr>
+            <p:ph type="title"/>
+          </p:nvPr>
+        </p:nvSpPr>
+        <p:spPr/>
+        <p:txBody>
+          <a:bodyPr>
+            <a:normAutofit fontScale="90000"/>
+          </a:bodyPr>
+          <a:lstStyle/>
+          <a:p>
+            <a:endParaRPr lang="en-ID"/>
+          </a:p>
+        </p:txBody>
+      </p:sp>
+    </p:spTree>
+    <p:extLst>
+      <p:ext uri="{BB962C8B-B14F-4D97-AF65-F5344CB8AC3E}">
+        <p14:creationId xmlns:p14="http://schemas.microsoft.com/office/powerpoint/2010/main" val="1001758246"/>
+      </p:ext>
+    </p:extLst>
+  </p:cSld>
+  <p:clrMapOvr>
+    <a:masterClrMapping/>
+  </p:clrMapOvr>
+</p:sld>
+</file>
+
+<file path=ppt/slides/slide13.xml><?xml version="1.0" encoding="utf-8"?>
+<p:sld xmlns:a="http://schemas.openxmlformats.org/drawingml/2006/main" xmlns:r="http://schemas.openxmlformats.org/officeDocument/2006/relationships" xmlns:p="http://schemas.openxmlformats.org/presentationml/2006/main">
+  <p:cSld>
+    <p:bg>
+      <p:bgPr>
+        <a:blipFill>
+          <a:blip r:embed="rId3"/>
+          <a:stretch>
+            <a:fillRect/>
+          </a:stretch>
+        </a:blipFill>
+        <a:effectLst/>
+      </p:bgPr>
+    </p:bg>
+    <p:spTree>
+      <p:nvGrpSpPr>
+        <p:cNvPr id="1" name="Shape 65">
+          <a:extLst>
+            <a:ext uri="{FF2B5EF4-FFF2-40B4-BE49-F238E27FC236}">
+              <a16:creationId xmlns:a16="http://schemas.microsoft.com/office/drawing/2014/main" id="{B4942BD2-F047-0ABF-74B2-587068D80599}"/>
+            </a:ext>
+          </a:extLst>
+        </p:cNvPr>
+        <p:cNvGrpSpPr/>
+        <p:nvPr/>
+      </p:nvGrpSpPr>
+      <p:grpSpPr>
+        <a:xfrm>
+          <a:off x="0" y="0"/>
+          <a:ext cx="0" cy="0"/>
+          <a:chOff x="0" y="0"/>
+          <a:chExt cx="0" cy="0"/>
+        </a:xfrm>
+      </p:grpSpPr>
+      <p:sp>
+        <p:nvSpPr>
+          <p:cNvPr id="5" name="Title 4">
+            <a:extLst>
+              <a:ext uri="{FF2B5EF4-FFF2-40B4-BE49-F238E27FC236}">
+                <a16:creationId xmlns:a16="http://schemas.microsoft.com/office/drawing/2014/main" id="{03196CAC-51FF-4C2A-7A7E-FA3C13884E66}"/>
+              </a:ext>
+            </a:extLst>
+          </p:cNvPr>
+          <p:cNvSpPr>
+            <a:spLocks noGrp="1"/>
+          </p:cNvSpPr>
+          <p:nvPr>
+            <p:ph type="title"/>
+          </p:nvPr>
+        </p:nvSpPr>
+        <p:spPr/>
+        <p:txBody>
+          <a:bodyPr>
+            <a:normAutofit fontScale="90000"/>
+          </a:bodyPr>
+          <a:lstStyle/>
+          <a:p>
+            <a:endParaRPr lang="en-ID"/>
+          </a:p>
+        </p:txBody>
+      </p:sp>
+    </p:spTree>
+    <p:extLst>
+      <p:ext uri="{BB962C8B-B14F-4D97-AF65-F5344CB8AC3E}">
+        <p14:creationId xmlns:p14="http://schemas.microsoft.com/office/powerpoint/2010/main" val="729131376"/>
+      </p:ext>
+    </p:extLst>
+  </p:cSld>
+  <p:clrMapOvr>
+    <a:masterClrMapping/>
+  </p:clrMapOvr>
+</p:sld>
+</file>
+
+<file path=ppt/slides/slide14.xml><?xml version="1.0" encoding="utf-8"?>
+<p:sld xmlns:a="http://schemas.openxmlformats.org/drawingml/2006/main" xmlns:r="http://schemas.openxmlformats.org/officeDocument/2006/relationships" xmlns:p="http://schemas.openxmlformats.org/presentationml/2006/main">
+  <p:cSld>
+    <p:bg>
+      <p:bgPr>
+        <a:blipFill>
+          <a:blip r:embed="rId3"/>
+          <a:stretch>
+            <a:fillRect/>
+          </a:stretch>
+        </a:blipFill>
+        <a:effectLst/>
+      </p:bgPr>
+    </p:bg>
+    <p:spTree>
+      <p:nvGrpSpPr>
+        <p:cNvPr id="1" name="Shape 65">
+          <a:extLst>
+            <a:ext uri="{FF2B5EF4-FFF2-40B4-BE49-F238E27FC236}">
+              <a16:creationId xmlns:a16="http://schemas.microsoft.com/office/drawing/2014/main" id="{876BAB00-CC1D-7FB0-9F05-DB7FABBBFF59}"/>
+            </a:ext>
+          </a:extLst>
+        </p:cNvPr>
+        <p:cNvGrpSpPr/>
+        <p:nvPr/>
+      </p:nvGrpSpPr>
+      <p:grpSpPr>
+        <a:xfrm>
+          <a:off x="0" y="0"/>
+          <a:ext cx="0" cy="0"/>
+          <a:chOff x="0" y="0"/>
+          <a:chExt cx="0" cy="0"/>
+        </a:xfrm>
+      </p:grpSpPr>
+      <p:sp>
+        <p:nvSpPr>
+          <p:cNvPr id="5" name="Title 4">
+            <a:extLst>
+              <a:ext uri="{FF2B5EF4-FFF2-40B4-BE49-F238E27FC236}">
+                <a16:creationId xmlns:a16="http://schemas.microsoft.com/office/drawing/2014/main" id="{38560CC1-E48C-DADB-F5D3-B581DCCDCA58}"/>
+              </a:ext>
+            </a:extLst>
+          </p:cNvPr>
+          <p:cNvSpPr>
+            <a:spLocks noGrp="1"/>
+          </p:cNvSpPr>
+          <p:nvPr>
+            <p:ph type="title"/>
+          </p:nvPr>
+        </p:nvSpPr>
+        <p:spPr/>
+        <p:txBody>
+          <a:bodyPr>
+            <a:normAutofit fontScale="90000"/>
+          </a:bodyPr>
+          <a:lstStyle/>
+          <a:p>
+            <a:endParaRPr lang="en-ID"/>
+          </a:p>
+        </p:txBody>
+      </p:sp>
+    </p:spTree>
+    <p:extLst>
+      <p:ext uri="{BB962C8B-B14F-4D97-AF65-F5344CB8AC3E}">
+        <p14:creationId xmlns:p14="http://schemas.microsoft.com/office/powerpoint/2010/main" val="107323562"/>
+      </p:ext>
+    </p:extLst>
   </p:cSld>
   <p:clrMapOvr>
     <a:masterClrMapping/>
@@ -7001,303 +7527,31 @@
       </p:grpSpPr>
       <p:sp>
         <p:nvSpPr>
-          <p:cNvPr id="2" name="TextBox 1"/>
-          <p:cNvSpPr txBox="1"/>
-          <p:nvPr/>
+          <p:cNvPr id="5" name="Title 4">
+            <a:extLst>
+              <a:ext uri="{FF2B5EF4-FFF2-40B4-BE49-F238E27FC236}">
+                <a16:creationId xmlns:a16="http://schemas.microsoft.com/office/drawing/2014/main" id="{96840651-27F4-D052-2160-F974056B4D30}"/>
+              </a:ext>
+            </a:extLst>
+          </p:cNvPr>
+          <p:cNvSpPr>
+            <a:spLocks noGrp="1"/>
+          </p:cNvSpPr>
+          <p:nvPr>
+            <p:ph type="title"/>
+          </p:nvPr>
         </p:nvSpPr>
-        <p:spPr>
-          <a:xfrm>
-            <a:off x="502920" y="411480"/>
-            <a:ext cx="8046720" cy="548640"/>
-          </a:xfrm>
-          <a:prstGeom prst="rect">
-            <a:avLst/>
-          </a:prstGeom>
-          <a:noFill/>
-        </p:spPr>
+        <p:spPr/>
         <p:txBody>
-          <a:bodyPr wrap="square">
-            <a:spAutoFit/>
+          <a:bodyPr>
+            <a:normAutofit fontScale="90000"/>
           </a:bodyPr>
           <a:lstStyle/>
           <a:p>
-            <a:pPr>
-              <a:defRPr sz="1700" b="1">
-                <a:solidFill>
-                  <a:srgbClr val="C00000"/>
-                </a:solidFill>
-              </a:defRPr>
-            </a:pPr>
-            <a:r>
-              <a:t>1. EXECUTIVE KPI SUMMARY &amp; TREND (AGU-2026)</a:t>
-            </a:r>
-          </a:p>
-          <a:p>
-            <a:pPr>
-              <a:defRPr sz="850" b="1">
-                <a:solidFill>
-                  <a:srgbClr val="646464"/>
-                </a:solidFill>
-              </a:defRPr>
-            </a:pPr>
-            <a:r>
-              <a:t>📌 Filter Aktif: Bulan = AGU-2026 | MTM = KA</a:t>
-            </a:r>
+            <a:endParaRPr lang="en-ID"/>
           </a:p>
         </p:txBody>
       </p:sp>
-      <p:sp>
-        <p:nvSpPr>
-          <p:cNvPr id="3" name="Rounded Rectangle 2"/>
-          <p:cNvSpPr/>
-          <p:nvPr/>
-        </p:nvSpPr>
-        <p:spPr>
-          <a:xfrm>
-            <a:off x="502920" y="1051560"/>
-            <a:ext cx="2514600" cy="868680"/>
-          </a:xfrm>
-          <a:prstGeom prst="roundRect">
-            <a:avLst/>
-          </a:prstGeom>
-          <a:solidFill>
-            <a:srgbClr val="F8F9FA"/>
-          </a:solidFill>
-          <a:ln>
-            <a:solidFill>
-              <a:srgbClr val="C00000"/>
-            </a:solidFill>
-          </a:ln>
-        </p:spPr>
-        <p:style>
-          <a:lnRef idx="1">
-            <a:schemeClr val="accent1"/>
-          </a:lnRef>
-          <a:fillRef idx="3">
-            <a:schemeClr val="accent1"/>
-          </a:fillRef>
-          <a:effectRef idx="2">
-            <a:schemeClr val="accent1"/>
-          </a:effectRef>
-          <a:fontRef idx="minor">
-            <a:schemeClr val="lt1"/>
-          </a:fontRef>
-        </p:style>
-        <p:txBody>
-          <a:bodyPr rtlCol="0" anchor="ctr" wrap="square"/>
-          <a:lstStyle/>
-          <a:p>
-            <a:pPr algn="ctr">
-              <a:defRPr sz="900" b="1">
-                <a:solidFill>
-                  <a:srgbClr val="646464"/>
-                </a:solidFill>
-              </a:defRPr>
-            </a:pPr>
-            <a:r>
-              <a:t>SERVICE LEVEL KIRIM</a:t>
-            </a:r>
-          </a:p>
-          <a:p>
-            <a:pPr algn="ctr">
-              <a:defRPr sz="1900" b="1">
-                <a:solidFill>
-                  <a:srgbClr val="C00000"/>
-                </a:solidFill>
-              </a:defRPr>
-            </a:pPr>
-            <a:r>
-              <a:t>90.2%</a:t>
-            </a:r>
-          </a:p>
-          <a:p>
-            <a:pPr algn="ctr">
-              <a:defRPr sz="750">
-                <a:solidFill>
-                  <a:srgbClr val="787878"/>
-                </a:solidFill>
-              </a:defRPr>
-            </a:pPr>
-            <a:r>
-              <a:t>Target Acuan: 85.0%</a:t>
-            </a:r>
-          </a:p>
-        </p:txBody>
-      </p:sp>
-      <p:sp>
-        <p:nvSpPr>
-          <p:cNvPr id="4" name="Rounded Rectangle 3"/>
-          <p:cNvSpPr/>
-          <p:nvPr/>
-        </p:nvSpPr>
-        <p:spPr>
-          <a:xfrm>
-            <a:off x="3273552" y="1051560"/>
-            <a:ext cx="2514600" cy="868680"/>
-          </a:xfrm>
-          <a:prstGeom prst="roundRect">
-            <a:avLst/>
-          </a:prstGeom>
-          <a:solidFill>
-            <a:srgbClr val="F8F9FA"/>
-          </a:solidFill>
-          <a:ln>
-            <a:solidFill>
-              <a:srgbClr val="C00000"/>
-            </a:solidFill>
-          </a:ln>
-        </p:spPr>
-        <p:style>
-          <a:lnRef idx="1">
-            <a:schemeClr val="accent1"/>
-          </a:lnRef>
-          <a:fillRef idx="3">
-            <a:schemeClr val="accent1"/>
-          </a:fillRef>
-          <a:effectRef idx="2">
-            <a:schemeClr val="accent1"/>
-          </a:effectRef>
-          <a:fontRef idx="minor">
-            <a:schemeClr val="lt1"/>
-          </a:fontRef>
-        </p:style>
-        <p:txBody>
-          <a:bodyPr rtlCol="0" anchor="ctr" wrap="square"/>
-          <a:lstStyle/>
-          <a:p>
-            <a:pPr algn="ctr">
-              <a:defRPr sz="900" b="1">
-                <a:solidFill>
-                  <a:srgbClr val="646464"/>
-                </a:solidFill>
-              </a:defRPr>
-            </a:pPr>
-            <a:r>
-              <a:t>SERVICE LEVEL REALISASI</a:t>
-            </a:r>
-          </a:p>
-          <a:p>
-            <a:pPr algn="ctr">
-              <a:defRPr sz="1900" b="1">
-                <a:solidFill>
-                  <a:srgbClr val="C00000"/>
-                </a:solidFill>
-              </a:defRPr>
-            </a:pPr>
-            <a:r>
-              <a:t>89.5%</a:t>
-            </a:r>
-          </a:p>
-          <a:p>
-            <a:pPr algn="ctr">
-              <a:defRPr sz="750">
-                <a:solidFill>
-                  <a:srgbClr val="787878"/>
-                </a:solidFill>
-              </a:defRPr>
-            </a:pPr>
-            <a:r>
-              <a:t>Target Acuan: 85.0%</a:t>
-            </a:r>
-          </a:p>
-        </p:txBody>
-      </p:sp>
-      <p:sp>
-        <p:nvSpPr>
-          <p:cNvPr id="5" name="Rounded Rectangle 4"/>
-          <p:cNvSpPr/>
-          <p:nvPr/>
-        </p:nvSpPr>
-        <p:spPr>
-          <a:xfrm>
-            <a:off x="6044184" y="1051560"/>
-            <a:ext cx="2514600" cy="868680"/>
-          </a:xfrm>
-          <a:prstGeom prst="roundRect">
-            <a:avLst/>
-          </a:prstGeom>
-          <a:solidFill>
-            <a:srgbClr val="F8F9FA"/>
-          </a:solidFill>
-          <a:ln>
-            <a:solidFill>
-              <a:srgbClr val="C00000"/>
-            </a:solidFill>
-          </a:ln>
-        </p:spPr>
-        <p:style>
-          <a:lnRef idx="1">
-            <a:schemeClr val="accent1"/>
-          </a:lnRef>
-          <a:fillRef idx="3">
-            <a:schemeClr val="accent1"/>
-          </a:fillRef>
-          <a:effectRef idx="2">
-            <a:schemeClr val="accent1"/>
-          </a:effectRef>
-          <a:fontRef idx="minor">
-            <a:schemeClr val="lt1"/>
-          </a:fontRef>
-        </p:style>
-        <p:txBody>
-          <a:bodyPr rtlCol="0" anchor="ctr" wrap="square"/>
-          <a:lstStyle/>
-          <a:p>
-            <a:pPr algn="ctr">
-              <a:defRPr sz="900" b="1">
-                <a:solidFill>
-                  <a:srgbClr val="646464"/>
-                </a:solidFill>
-              </a:defRPr>
-            </a:pPr>
-            <a:r>
-              <a:t>GAP REALISASI VS KIRIM</a:t>
-            </a:r>
-          </a:p>
-          <a:p>
-            <a:pPr algn="ctr">
-              <a:defRPr sz="1900" b="1">
-                <a:solidFill>
-                  <a:srgbClr val="EF4444"/>
-                </a:solidFill>
-              </a:defRPr>
-            </a:pPr>
-            <a:r>
-              <a:t>-0.7%</a:t>
-            </a:r>
-          </a:p>
-          <a:p>
-            <a:pPr algn="ctr">
-              <a:defRPr sz="750">
-                <a:solidFill>
-                  <a:srgbClr val="787878"/>
-                </a:solidFill>
-              </a:defRPr>
-            </a:pPr>
-            <a:r>
-              <a:t>Selisih Performa</a:t>
-            </a:r>
-          </a:p>
-        </p:txBody>
-      </p:sp>
-      <p:graphicFrame>
-        <p:nvGraphicFramePr>
-          <p:cNvPr id="6" name="Chart 5"/>
-          <p:cNvGraphicFramePr>
-            <a:graphicFrameLocks noGrp="1"/>
-          </p:cNvGraphicFramePr>
-          <p:nvPr/>
-        </p:nvGraphicFramePr>
-        <p:xfrm>
-          <a:off x="502920" y="1993392"/>
-          <a:ext cx="8046720" cy="2331720"/>
-        </p:xfrm>
-        <a:graphic>
-          <a:graphicData uri="http://schemas.openxmlformats.org/drawingml/2006/chart">
-            <c:chart xmlns:c="http://schemas.openxmlformats.org/drawingml/2006/chart" r:id="rId4"/>
-          </a:graphicData>
-        </a:graphic>
-      </p:graphicFrame>
     </p:spTree>
   </p:cSld>
   <p:clrMapOvr>
@@ -7342,911 +7596,31 @@
       </p:grpSpPr>
       <p:sp>
         <p:nvSpPr>
-          <p:cNvPr id="2" name="TextBox 1"/>
-          <p:cNvSpPr txBox="1"/>
-          <p:nvPr/>
+          <p:cNvPr id="5" name="Title 4">
+            <a:extLst>
+              <a:ext uri="{FF2B5EF4-FFF2-40B4-BE49-F238E27FC236}">
+                <a16:creationId xmlns:a16="http://schemas.microsoft.com/office/drawing/2014/main" id="{724D293C-6F97-D20D-F13C-40E531557CF5}"/>
+              </a:ext>
+            </a:extLst>
+          </p:cNvPr>
+          <p:cNvSpPr>
+            <a:spLocks noGrp="1"/>
+          </p:cNvSpPr>
+          <p:nvPr>
+            <p:ph type="title"/>
+          </p:nvPr>
         </p:nvSpPr>
-        <p:spPr>
-          <a:xfrm>
-            <a:off x="502920" y="411480"/>
-            <a:ext cx="8046720" cy="548640"/>
-          </a:xfrm>
-          <a:prstGeom prst="rect">
-            <a:avLst/>
-          </a:prstGeom>
-          <a:noFill/>
-        </p:spPr>
+        <p:spPr/>
         <p:txBody>
-          <a:bodyPr wrap="square">
-            <a:spAutoFit/>
+          <a:bodyPr>
+            <a:normAutofit fontScale="90000"/>
           </a:bodyPr>
           <a:lstStyle/>
           <a:p>
-            <a:pPr>
-              <a:defRPr sz="1700" b="1">
-                <a:solidFill>
-                  <a:srgbClr val="C00000"/>
-                </a:solidFill>
-              </a:defRPr>
-            </a:pPr>
-            <a:r>
-              <a:t>1.1 SERVICE LEVEL PER GRUP BRAND (AGU-2026)</a:t>
-            </a:r>
-          </a:p>
-          <a:p>
-            <a:pPr>
-              <a:defRPr sz="850" b="1">
-                <a:solidFill>
-                  <a:srgbClr val="646464"/>
-                </a:solidFill>
-              </a:defRPr>
-            </a:pPr>
-            <a:r>
-              <a:t>📌 Filter Aktif: Bulan = AGU-2026 | MTM = KA | Performa Pengiriman (SL Kirim) &amp; Realisasi (SL Realisasi) Per Grup Brand</a:t>
-            </a:r>
+            <a:endParaRPr lang="en-ID"/>
           </a:p>
         </p:txBody>
       </p:sp>
-      <p:graphicFrame>
-        <p:nvGraphicFramePr>
-          <p:cNvPr id="3" name="Chart 2"/>
-          <p:cNvGraphicFramePr>
-            <a:graphicFrameLocks noGrp="1"/>
-          </p:cNvGraphicFramePr>
-          <p:nvPr/>
-        </p:nvGraphicFramePr>
-        <p:xfrm>
-          <a:off x="502920" y="1051560"/>
-          <a:ext cx="4206240" cy="3246120"/>
-        </p:xfrm>
-        <a:graphic>
-          <a:graphicData uri="http://schemas.openxmlformats.org/drawingml/2006/chart">
-            <c:chart xmlns:c="http://schemas.openxmlformats.org/drawingml/2006/chart" r:id="rId4"/>
-          </a:graphicData>
-        </a:graphic>
-      </p:graphicFrame>
-      <p:graphicFrame>
-        <p:nvGraphicFramePr>
-          <p:cNvPr id="4" name="Table 3"/>
-          <p:cNvGraphicFramePr>
-            <a:graphicFrameLocks noGrp="1"/>
-          </p:cNvGraphicFramePr>
-          <p:nvPr/>
-        </p:nvGraphicFramePr>
-        <p:xfrm>
-          <a:off x="4754880" y="1051560"/>
-          <a:ext cx="3886200" cy="3246120"/>
-        </p:xfrm>
-        <a:graphic>
-          <a:graphicData uri="http://schemas.openxmlformats.org/drawingml/2006/table">
-            <a:tbl>
-              <a:tblPr firstRow="1" bandRow="1">
-                <a:tableStyleId>{5C22544A-7EE6-4342-B048-85BDC9FD1C3A}</a:tableStyleId>
-              </a:tblPr>
-              <a:tblGrid>
-                <a:gridCol w="777240"/>
-                <a:gridCol w="777240"/>
-                <a:gridCol w="777240"/>
-                <a:gridCol w="502920"/>
-                <a:gridCol w="502920"/>
-                <a:gridCol w="548640"/>
-              </a:tblGrid>
-              <a:tr h="405765">
-                <a:tc>
-                  <a:txBody>
-                    <a:bodyPr/>
-                    <a:lstStyle/>
-                    <a:p>
-                      <a:pPr algn="ctr">
-                        <a:defRPr b="1" sz="750">
-                          <a:solidFill>
-                            <a:srgbClr val="FFFFFF"/>
-                          </a:solidFill>
-                        </a:defRPr>
-                      </a:pPr>
-                      <a:r>
-                        <a:t>Grup Brand</a:t>
-                      </a:r>
-                    </a:p>
-                  </a:txBody>
-                  <a:tcPr>
-                    <a:solidFill>
-                      <a:srgbClr val="C00000"/>
-                    </a:solidFill>
-                  </a:tcPr>
-                </a:tc>
-                <a:tc>
-                  <a:txBody>
-                    <a:bodyPr/>
-                    <a:lstStyle/>
-                    <a:p>
-                      <a:pPr algn="ctr">
-                        <a:defRPr b="1" sz="750">
-                          <a:solidFill>
-                            <a:srgbClr val="FFFFFF"/>
-                          </a:solidFill>
-                        </a:defRPr>
-                      </a:pPr>
-                      <a:r>
-                        <a:t>Total Order</a:t>
-                      </a:r>
-                    </a:p>
-                  </a:txBody>
-                  <a:tcPr>
-                    <a:solidFill>
-                      <a:srgbClr val="C00000"/>
-                    </a:solidFill>
-                  </a:tcPr>
-                </a:tc>
-                <a:tc>
-                  <a:txBody>
-                    <a:bodyPr/>
-                    <a:lstStyle/>
-                    <a:p>
-                      <a:pPr algn="ctr">
-                        <a:defRPr b="1" sz="750">
-                          <a:solidFill>
-                            <a:srgbClr val="FFFFFF"/>
-                          </a:solidFill>
-                        </a:defRPr>
-                      </a:pPr>
-                      <a:r>
-                        <a:t>Total Kirim</a:t>
-                      </a:r>
-                    </a:p>
-                  </a:txBody>
-                  <a:tcPr>
-                    <a:solidFill>
-                      <a:srgbClr val="C00000"/>
-                    </a:solidFill>
-                  </a:tcPr>
-                </a:tc>
-                <a:tc>
-                  <a:txBody>
-                    <a:bodyPr/>
-                    <a:lstStyle/>
-                    <a:p>
-                      <a:pPr algn="ctr">
-                        <a:defRPr b="1" sz="750">
-                          <a:solidFill>
-                            <a:srgbClr val="FFFFFF"/>
-                          </a:solidFill>
-                        </a:defRPr>
-                      </a:pPr>
-                      <a:r>
-                        <a:t>SL Kirim</a:t>
-                      </a:r>
-                    </a:p>
-                  </a:txBody>
-                  <a:tcPr>
-                    <a:solidFill>
-                      <a:srgbClr val="C00000"/>
-                    </a:solidFill>
-                  </a:tcPr>
-                </a:tc>
-                <a:tc>
-                  <a:txBody>
-                    <a:bodyPr/>
-                    <a:lstStyle/>
-                    <a:p>
-                      <a:pPr algn="ctr">
-                        <a:defRPr b="1" sz="750">
-                          <a:solidFill>
-                            <a:srgbClr val="FFFFFF"/>
-                          </a:solidFill>
-                        </a:defRPr>
-                      </a:pPr>
-                      <a:r>
-                        <a:t>SL Real.</a:t>
-                      </a:r>
-                    </a:p>
-                  </a:txBody>
-                  <a:tcPr>
-                    <a:solidFill>
-                      <a:srgbClr val="C00000"/>
-                    </a:solidFill>
-                  </a:tcPr>
-                </a:tc>
-                <a:tc>
-                  <a:txBody>
-                    <a:bodyPr/>
-                    <a:lstStyle/>
-                    <a:p>
-                      <a:pPr algn="ctr">
-                        <a:defRPr b="1" sz="750">
-                          <a:solidFill>
-                            <a:srgbClr val="FFFFFF"/>
-                          </a:solidFill>
-                        </a:defRPr>
-                      </a:pPr>
-                      <a:r>
-                        <a:t>GAP</a:t>
-                      </a:r>
-                    </a:p>
-                  </a:txBody>
-                  <a:tcPr>
-                    <a:solidFill>
-                      <a:srgbClr val="C00000"/>
-                    </a:solidFill>
-                  </a:tcPr>
-                </a:tc>
-              </a:tr>
-              <a:tr h="405765">
-                <a:tc>
-                  <a:txBody>
-                    <a:bodyPr/>
-                    <a:lstStyle/>
-                    <a:p>
-                      <a:pPr algn="ctr">
-                        <a:defRPr sz="700"/>
-                      </a:pPr>
-                      <a:r>
-                        <a:t>GB 1</a:t>
-                      </a:r>
-                    </a:p>
-                  </a:txBody>
-                  <a:tcPr marL="25400" marR="25400" marT="12700" marB="12700"/>
-                </a:tc>
-                <a:tc>
-                  <a:txBody>
-                    <a:bodyPr/>
-                    <a:lstStyle/>
-                    <a:p>
-                      <a:pPr algn="r">
-                        <a:defRPr sz="700"/>
-                      </a:pPr>
-                      <a:r>
-                        <a:t>1,813,076,750</a:t>
-                      </a:r>
-                    </a:p>
-                  </a:txBody>
-                  <a:tcPr marL="25400" marR="25400" marT="12700" marB="12700"/>
-                </a:tc>
-                <a:tc>
-                  <a:txBody>
-                    <a:bodyPr/>
-                    <a:lstStyle/>
-                    <a:p>
-                      <a:pPr algn="r">
-                        <a:defRPr sz="700"/>
-                      </a:pPr>
-                      <a:r>
-                        <a:t>1,715,607,960</a:t>
-                      </a:r>
-                    </a:p>
-                  </a:txBody>
-                  <a:tcPr marL="25400" marR="25400" marT="12700" marB="12700"/>
-                </a:tc>
-                <a:tc>
-                  <a:txBody>
-                    <a:bodyPr/>
-                    <a:lstStyle/>
-                    <a:p>
-                      <a:pPr algn="ctr">
-                        <a:defRPr sz="700"/>
-                      </a:pPr>
-                      <a:r>
-                        <a:t>94.6%</a:t>
-                      </a:r>
-                    </a:p>
-                  </a:txBody>
-                  <a:tcPr marL="25400" marR="25400" marT="12700" marB="12700"/>
-                </a:tc>
-                <a:tc>
-                  <a:txBody>
-                    <a:bodyPr/>
-                    <a:lstStyle/>
-                    <a:p>
-                      <a:pPr algn="ctr">
-                        <a:defRPr sz="700"/>
-                      </a:pPr>
-                      <a:r>
-                        <a:t>94.3%</a:t>
-                      </a:r>
-                    </a:p>
-                  </a:txBody>
-                  <a:tcPr marL="25400" marR="25400" marT="12700" marB="12700"/>
-                </a:tc>
-                <a:tc>
-                  <a:txBody>
-                    <a:bodyPr/>
-                    <a:lstStyle/>
-                    <a:p>
-                      <a:pPr algn="ctr">
-                        <a:defRPr sz="700" b="1">
-                          <a:solidFill>
-                            <a:srgbClr val="DC2626"/>
-                          </a:solidFill>
-                        </a:defRPr>
-                      </a:pPr>
-                      <a:r>
-                        <a:t>-0.3%</a:t>
-                      </a:r>
-                    </a:p>
-                  </a:txBody>
-                  <a:tcPr marL="25400" marR="25400" marT="12700" marB="12700"/>
-                </a:tc>
-              </a:tr>
-              <a:tr h="405765">
-                <a:tc>
-                  <a:txBody>
-                    <a:bodyPr/>
-                    <a:lstStyle/>
-                    <a:p>
-                      <a:pPr algn="ctr">
-                        <a:defRPr sz="700"/>
-                      </a:pPr>
-                      <a:r>
-                        <a:t>GB 2</a:t>
-                      </a:r>
-                    </a:p>
-                  </a:txBody>
-                  <a:tcPr marL="25400" marR="25400" marT="12700" marB="12700"/>
-                </a:tc>
-                <a:tc>
-                  <a:txBody>
-                    <a:bodyPr/>
-                    <a:lstStyle/>
-                    <a:p>
-                      <a:pPr algn="r">
-                        <a:defRPr sz="700"/>
-                      </a:pPr>
-                      <a:r>
-                        <a:t>7,895,205,508</a:t>
-                      </a:r>
-                    </a:p>
-                  </a:txBody>
-                  <a:tcPr marL="25400" marR="25400" marT="12700" marB="12700"/>
-                </a:tc>
-                <a:tc>
-                  <a:txBody>
-                    <a:bodyPr/>
-                    <a:lstStyle/>
-                    <a:p>
-                      <a:pPr algn="r">
-                        <a:defRPr sz="700"/>
-                      </a:pPr>
-                      <a:r>
-                        <a:t>7,134,192,718</a:t>
-                      </a:r>
-                    </a:p>
-                  </a:txBody>
-                  <a:tcPr marL="25400" marR="25400" marT="12700" marB="12700"/>
-                </a:tc>
-                <a:tc>
-                  <a:txBody>
-                    <a:bodyPr/>
-                    <a:lstStyle/>
-                    <a:p>
-                      <a:pPr algn="ctr">
-                        <a:defRPr sz="700"/>
-                      </a:pPr>
-                      <a:r>
-                        <a:t>90.4%</a:t>
-                      </a:r>
-                    </a:p>
-                  </a:txBody>
-                  <a:tcPr marL="25400" marR="25400" marT="12700" marB="12700"/>
-                </a:tc>
-                <a:tc>
-                  <a:txBody>
-                    <a:bodyPr/>
-                    <a:lstStyle/>
-                    <a:p>
-                      <a:pPr algn="ctr">
-                        <a:defRPr sz="700"/>
-                      </a:pPr>
-                      <a:r>
-                        <a:t>89.9%</a:t>
-                      </a:r>
-                    </a:p>
-                  </a:txBody>
-                  <a:tcPr marL="25400" marR="25400" marT="12700" marB="12700"/>
-                </a:tc>
-                <a:tc>
-                  <a:txBody>
-                    <a:bodyPr/>
-                    <a:lstStyle/>
-                    <a:p>
-                      <a:pPr algn="ctr">
-                        <a:defRPr sz="700" b="1">
-                          <a:solidFill>
-                            <a:srgbClr val="DC2626"/>
-                          </a:solidFill>
-                        </a:defRPr>
-                      </a:pPr>
-                      <a:r>
-                        <a:t>-0.4%</a:t>
-                      </a:r>
-                    </a:p>
-                  </a:txBody>
-                  <a:tcPr marL="25400" marR="25400" marT="12700" marB="12700"/>
-                </a:tc>
-              </a:tr>
-              <a:tr h="405765">
-                <a:tc>
-                  <a:txBody>
-                    <a:bodyPr/>
-                    <a:lstStyle/>
-                    <a:p>
-                      <a:pPr algn="ctr">
-                        <a:defRPr sz="700"/>
-                      </a:pPr>
-                      <a:r>
-                        <a:t>GB 3</a:t>
-                      </a:r>
-                    </a:p>
-                  </a:txBody>
-                  <a:tcPr marL="25400" marR="25400" marT="12700" marB="12700"/>
-                </a:tc>
-                <a:tc>
-                  <a:txBody>
-                    <a:bodyPr/>
-                    <a:lstStyle/>
-                    <a:p>
-                      <a:pPr algn="r">
-                        <a:defRPr sz="700"/>
-                      </a:pPr>
-                      <a:r>
-                        <a:t>1,389,719,660</a:t>
-                      </a:r>
-                    </a:p>
-                  </a:txBody>
-                  <a:tcPr marL="25400" marR="25400" marT="12700" marB="12700"/>
-                </a:tc>
-                <a:tc>
-                  <a:txBody>
-                    <a:bodyPr/>
-                    <a:lstStyle/>
-                    <a:p>
-                      <a:pPr algn="r">
-                        <a:defRPr sz="700"/>
-                      </a:pPr>
-                      <a:r>
-                        <a:t>1,202,327,230</a:t>
-                      </a:r>
-                    </a:p>
-                  </a:txBody>
-                  <a:tcPr marL="25400" marR="25400" marT="12700" marB="12700"/>
-                </a:tc>
-                <a:tc>
-                  <a:txBody>
-                    <a:bodyPr/>
-                    <a:lstStyle/>
-                    <a:p>
-                      <a:pPr algn="ctr">
-                        <a:defRPr sz="700"/>
-                      </a:pPr>
-                      <a:r>
-                        <a:t>86.5%</a:t>
-                      </a:r>
-                    </a:p>
-                  </a:txBody>
-                  <a:tcPr marL="25400" marR="25400" marT="12700" marB="12700"/>
-                </a:tc>
-                <a:tc>
-                  <a:txBody>
-                    <a:bodyPr/>
-                    <a:lstStyle/>
-                    <a:p>
-                      <a:pPr algn="ctr">
-                        <a:defRPr sz="700"/>
-                      </a:pPr>
-                      <a:r>
-                        <a:t>85.8%</a:t>
-                      </a:r>
-                    </a:p>
-                  </a:txBody>
-                  <a:tcPr marL="25400" marR="25400" marT="12700" marB="12700"/>
-                </a:tc>
-                <a:tc>
-                  <a:txBody>
-                    <a:bodyPr/>
-                    <a:lstStyle/>
-                    <a:p>
-                      <a:pPr algn="ctr">
-                        <a:defRPr sz="700" b="1">
-                          <a:solidFill>
-                            <a:srgbClr val="DC2626"/>
-                          </a:solidFill>
-                        </a:defRPr>
-                      </a:pPr>
-                      <a:r>
-                        <a:t>-0.8%</a:t>
-                      </a:r>
-                    </a:p>
-                  </a:txBody>
-                  <a:tcPr marL="25400" marR="25400" marT="12700" marB="12700"/>
-                </a:tc>
-              </a:tr>
-              <a:tr h="405765">
-                <a:tc>
-                  <a:txBody>
-                    <a:bodyPr/>
-                    <a:lstStyle/>
-                    <a:p>
-                      <a:pPr algn="ctr">
-                        <a:defRPr sz="700"/>
-                      </a:pPr>
-                      <a:r>
-                        <a:t>GB 4</a:t>
-                      </a:r>
-                    </a:p>
-                  </a:txBody>
-                  <a:tcPr marL="25400" marR="25400" marT="12700" marB="12700"/>
-                </a:tc>
-                <a:tc>
-                  <a:txBody>
-                    <a:bodyPr/>
-                    <a:lstStyle/>
-                    <a:p>
-                      <a:pPr algn="r">
-                        <a:defRPr sz="700"/>
-                      </a:pPr>
-                      <a:r>
-                        <a:t>3,243,563,020</a:t>
-                      </a:r>
-                    </a:p>
-                  </a:txBody>
-                  <a:tcPr marL="25400" marR="25400" marT="12700" marB="12700"/>
-                </a:tc>
-                <a:tc>
-                  <a:txBody>
-                    <a:bodyPr/>
-                    <a:lstStyle/>
-                    <a:p>
-                      <a:pPr algn="r">
-                        <a:defRPr sz="700"/>
-                      </a:pPr>
-                      <a:r>
-                        <a:t>2,940,846,220</a:t>
-                      </a:r>
-                    </a:p>
-                  </a:txBody>
-                  <a:tcPr marL="25400" marR="25400" marT="12700" marB="12700"/>
-                </a:tc>
-                <a:tc>
-                  <a:txBody>
-                    <a:bodyPr/>
-                    <a:lstStyle/>
-                    <a:p>
-                      <a:pPr algn="ctr">
-                        <a:defRPr sz="700"/>
-                      </a:pPr>
-                      <a:r>
-                        <a:t>90.7%</a:t>
-                      </a:r>
-                    </a:p>
-                  </a:txBody>
-                  <a:tcPr marL="25400" marR="25400" marT="12700" marB="12700"/>
-                </a:tc>
-                <a:tc>
-                  <a:txBody>
-                    <a:bodyPr/>
-                    <a:lstStyle/>
-                    <a:p>
-                      <a:pPr algn="ctr">
-                        <a:defRPr sz="700"/>
-                      </a:pPr>
-                      <a:r>
-                        <a:t>90.2%</a:t>
-                      </a:r>
-                    </a:p>
-                  </a:txBody>
-                  <a:tcPr marL="25400" marR="25400" marT="12700" marB="12700"/>
-                </a:tc>
-                <a:tc>
-                  <a:txBody>
-                    <a:bodyPr/>
-                    <a:lstStyle/>
-                    <a:p>
-                      <a:pPr algn="ctr">
-                        <a:defRPr sz="700" b="1">
-                          <a:solidFill>
-                            <a:srgbClr val="DC2626"/>
-                          </a:solidFill>
-                        </a:defRPr>
-                      </a:pPr>
-                      <a:r>
-                        <a:t>-0.5%</a:t>
-                      </a:r>
-                    </a:p>
-                  </a:txBody>
-                  <a:tcPr marL="25400" marR="25400" marT="12700" marB="12700"/>
-                </a:tc>
-              </a:tr>
-              <a:tr h="405765">
-                <a:tc>
-                  <a:txBody>
-                    <a:bodyPr/>
-                    <a:lstStyle/>
-                    <a:p>
-                      <a:pPr algn="ctr">
-                        <a:defRPr sz="700"/>
-                      </a:pPr>
-                      <a:r>
-                        <a:t>GB 5</a:t>
-                      </a:r>
-                    </a:p>
-                  </a:txBody>
-                  <a:tcPr marL="25400" marR="25400" marT="12700" marB="12700"/>
-                </a:tc>
-                <a:tc>
-                  <a:txBody>
-                    <a:bodyPr/>
-                    <a:lstStyle/>
-                    <a:p>
-                      <a:pPr algn="r">
-                        <a:defRPr sz="700"/>
-                      </a:pPr>
-                      <a:r>
-                        <a:t>5,735,865,938</a:t>
-                      </a:r>
-                    </a:p>
-                  </a:txBody>
-                  <a:tcPr marL="25400" marR="25400" marT="12700" marB="12700"/>
-                </a:tc>
-                <a:tc>
-                  <a:txBody>
-                    <a:bodyPr/>
-                    <a:lstStyle/>
-                    <a:p>
-                      <a:pPr algn="r">
-                        <a:defRPr sz="700"/>
-                      </a:pPr>
-                      <a:r>
-                        <a:t>4,762,043,730</a:t>
-                      </a:r>
-                    </a:p>
-                  </a:txBody>
-                  <a:tcPr marL="25400" marR="25400" marT="12700" marB="12700"/>
-                </a:tc>
-                <a:tc>
-                  <a:txBody>
-                    <a:bodyPr/>
-                    <a:lstStyle/>
-                    <a:p>
-                      <a:pPr algn="ctr">
-                        <a:defRPr sz="700"/>
-                      </a:pPr>
-                      <a:r>
-                        <a:t>83.0%</a:t>
-                      </a:r>
-                    </a:p>
-                  </a:txBody>
-                  <a:tcPr marL="25400" marR="25400" marT="12700" marB="12700"/>
-                </a:tc>
-                <a:tc>
-                  <a:txBody>
-                    <a:bodyPr/>
-                    <a:lstStyle/>
-                    <a:p>
-                      <a:pPr algn="ctr">
-                        <a:defRPr sz="700"/>
-                      </a:pPr>
-                      <a:r>
-                        <a:t>82.2%</a:t>
-                      </a:r>
-                    </a:p>
-                  </a:txBody>
-                  <a:tcPr marL="25400" marR="25400" marT="12700" marB="12700"/>
-                </a:tc>
-                <a:tc>
-                  <a:txBody>
-                    <a:bodyPr/>
-                    <a:lstStyle/>
-                    <a:p>
-                      <a:pPr algn="ctr">
-                        <a:defRPr sz="700" b="1">
-                          <a:solidFill>
-                            <a:srgbClr val="DC2626"/>
-                          </a:solidFill>
-                        </a:defRPr>
-                      </a:pPr>
-                      <a:r>
-                        <a:t>-0.8%</a:t>
-                      </a:r>
-                    </a:p>
-                  </a:txBody>
-                  <a:tcPr marL="25400" marR="25400" marT="12700" marB="12700"/>
-                </a:tc>
-              </a:tr>
-              <a:tr h="405765">
-                <a:tc>
-                  <a:txBody>
-                    <a:bodyPr/>
-                    <a:lstStyle/>
-                    <a:p>
-                      <a:pPr algn="ctr">
-                        <a:defRPr sz="700"/>
-                      </a:pPr>
-                      <a:r>
-                        <a:t>GB 6</a:t>
-                      </a:r>
-                    </a:p>
-                  </a:txBody>
-                  <a:tcPr marL="25400" marR="25400" marT="12700" marB="12700"/>
-                </a:tc>
-                <a:tc>
-                  <a:txBody>
-                    <a:bodyPr/>
-                    <a:lstStyle/>
-                    <a:p>
-                      <a:pPr algn="r">
-                        <a:defRPr sz="700"/>
-                      </a:pPr>
-                      <a:r>
-                        <a:t>5,053,507,178</a:t>
-                      </a:r>
-                    </a:p>
-                  </a:txBody>
-                  <a:tcPr marL="25400" marR="25400" marT="12700" marB="12700"/>
-                </a:tc>
-                <a:tc>
-                  <a:txBody>
-                    <a:bodyPr/>
-                    <a:lstStyle/>
-                    <a:p>
-                      <a:pPr algn="r">
-                        <a:defRPr sz="700"/>
-                      </a:pPr>
-                      <a:r>
-                        <a:t>4,894,161,572</a:t>
-                      </a:r>
-                    </a:p>
-                  </a:txBody>
-                  <a:tcPr marL="25400" marR="25400" marT="12700" marB="12700"/>
-                </a:tc>
-                <a:tc>
-                  <a:txBody>
-                    <a:bodyPr/>
-                    <a:lstStyle/>
-                    <a:p>
-                      <a:pPr algn="ctr">
-                        <a:defRPr sz="700"/>
-                      </a:pPr>
-                      <a:r>
-                        <a:t>96.8%</a:t>
-                      </a:r>
-                    </a:p>
-                  </a:txBody>
-                  <a:tcPr marL="25400" marR="25400" marT="12700" marB="12700"/>
-                </a:tc>
-                <a:tc>
-                  <a:txBody>
-                    <a:bodyPr/>
-                    <a:lstStyle/>
-                    <a:p>
-                      <a:pPr algn="ctr">
-                        <a:defRPr sz="700"/>
-                      </a:pPr>
-                      <a:r>
-                        <a:t>96.4%</a:t>
-                      </a:r>
-                    </a:p>
-                  </a:txBody>
-                  <a:tcPr marL="25400" marR="25400" marT="12700" marB="12700"/>
-                </a:tc>
-                <a:tc>
-                  <a:txBody>
-                    <a:bodyPr/>
-                    <a:lstStyle/>
-                    <a:p>
-                      <a:pPr algn="ctr">
-                        <a:defRPr sz="700" b="1">
-                          <a:solidFill>
-                            <a:srgbClr val="DC2626"/>
-                          </a:solidFill>
-                        </a:defRPr>
-                      </a:pPr>
-                      <a:r>
-                        <a:t>-0.4%</a:t>
-                      </a:r>
-                    </a:p>
-                  </a:txBody>
-                  <a:tcPr marL="25400" marR="25400" marT="12700" marB="12700"/>
-                </a:tc>
-              </a:tr>
-              <a:tr h="405765">
-                <a:tc>
-                  <a:txBody>
-                    <a:bodyPr/>
-                    <a:lstStyle/>
-                    <a:p>
-                      <a:pPr algn="ctr">
-                        <a:defRPr sz="700"/>
-                      </a:pPr>
-                      <a:r>
-                        <a:t>GB ET</a:t>
-                      </a:r>
-                    </a:p>
-                  </a:txBody>
-                  <a:tcPr marL="25400" marR="25400" marT="12700" marB="12700"/>
-                </a:tc>
-                <a:tc>
-                  <a:txBody>
-                    <a:bodyPr/>
-                    <a:lstStyle/>
-                    <a:p>
-                      <a:pPr algn="r">
-                        <a:defRPr sz="700"/>
-                      </a:pPr>
-                      <a:r>
-                        <a:t>351,842,500</a:t>
-                      </a:r>
-                    </a:p>
-                  </a:txBody>
-                  <a:tcPr marL="25400" marR="25400" marT="12700" marB="12700"/>
-                </a:tc>
-                <a:tc>
-                  <a:txBody>
-                    <a:bodyPr/>
-                    <a:lstStyle/>
-                    <a:p>
-                      <a:pPr algn="r">
-                        <a:defRPr sz="700"/>
-                      </a:pPr>
-                      <a:r>
-                        <a:t>341,985,000</a:t>
-                      </a:r>
-                    </a:p>
-                  </a:txBody>
-                  <a:tcPr marL="25400" marR="25400" marT="12700" marB="12700"/>
-                </a:tc>
-                <a:tc>
-                  <a:txBody>
-                    <a:bodyPr/>
-                    <a:lstStyle/>
-                    <a:p>
-                      <a:pPr algn="ctr">
-                        <a:defRPr sz="700"/>
-                      </a:pPr>
-                      <a:r>
-                        <a:t>97.2%</a:t>
-                      </a:r>
-                    </a:p>
-                  </a:txBody>
-                  <a:tcPr marL="25400" marR="25400" marT="12700" marB="12700"/>
-                </a:tc>
-                <a:tc>
-                  <a:txBody>
-                    <a:bodyPr/>
-                    <a:lstStyle/>
-                    <a:p>
-                      <a:pPr algn="ctr">
-                        <a:defRPr sz="700"/>
-                      </a:pPr>
-                      <a:r>
-                        <a:t>84.4%</a:t>
-                      </a:r>
-                    </a:p>
-                  </a:txBody>
-                  <a:tcPr marL="25400" marR="25400" marT="12700" marB="12700"/>
-                </a:tc>
-                <a:tc>
-                  <a:txBody>
-                    <a:bodyPr/>
-                    <a:lstStyle/>
-                    <a:p>
-                      <a:pPr algn="ctr">
-                        <a:defRPr sz="700" b="1">
-                          <a:solidFill>
-                            <a:srgbClr val="DC2626"/>
-                          </a:solidFill>
-                        </a:defRPr>
-                      </a:pPr>
-                      <a:r>
-                        <a:t>-12.8%</a:t>
-                      </a:r>
-                    </a:p>
-                  </a:txBody>
-                  <a:tcPr marL="25400" marR="25400" marT="12700" marB="12700"/>
-                </a:tc>
-              </a:tr>
-            </a:tbl>
-          </a:graphicData>
-        </a:graphic>
-      </p:graphicFrame>
     </p:spTree>
     <p:extLst>
       <p:ext uri="{BB962C8B-B14F-4D97-AF65-F5344CB8AC3E}">
@@ -8296,75 +7670,31 @@
       </p:grpSpPr>
       <p:sp>
         <p:nvSpPr>
-          <p:cNvPr id="2" name="TextBox 1"/>
-          <p:cNvSpPr txBox="1"/>
-          <p:nvPr/>
+          <p:cNvPr id="5" name="Title 4">
+            <a:extLst>
+              <a:ext uri="{FF2B5EF4-FFF2-40B4-BE49-F238E27FC236}">
+                <a16:creationId xmlns:a16="http://schemas.microsoft.com/office/drawing/2014/main" id="{C8A016C2-E174-111C-A356-59D7154367C8}"/>
+              </a:ext>
+            </a:extLst>
+          </p:cNvPr>
+          <p:cNvSpPr>
+            <a:spLocks noGrp="1"/>
+          </p:cNvSpPr>
+          <p:nvPr>
+            <p:ph type="title"/>
+          </p:nvPr>
         </p:nvSpPr>
-        <p:spPr>
-          <a:xfrm>
-            <a:off x="411480" y="365760"/>
-            <a:ext cx="6858000" cy="594360"/>
-          </a:xfrm>
-          <a:prstGeom prst="rect">
-            <a:avLst/>
-          </a:prstGeom>
-          <a:noFill/>
-        </p:spPr>
+        <p:spPr/>
         <p:txBody>
-          <a:bodyPr wrap="square">
-            <a:spAutoFit/>
+          <a:bodyPr>
+            <a:normAutofit fontScale="90000"/>
           </a:bodyPr>
           <a:lstStyle/>
           <a:p>
-            <a:pPr>
-              <a:defRPr sz="1600" b="1">
-                <a:solidFill>
-                  <a:srgbClr val="C00000"/>
-                </a:solidFill>
-              </a:defRPr>
-            </a:pPr>
-            <a:r>
-              <a:t>2.1 ANALISIS PARETO UNFULLFILL - ALASAN KETERLAMBATAN (AGU-2026)</a:t>
-            </a:r>
-          </a:p>
-          <a:p>
-            <a:pPr>
-              <a:defRPr sz="850" b="1">
-                <a:solidFill>
-                  <a:srgbClr val="646464"/>
-                </a:solidFill>
-              </a:defRPr>
-            </a:pPr>
-            <a:r>
-              <a:t>📌 Filter Aktif: Bulan = AGU-2026 | MTM = KA | Pareto 80% (1 - 4 dari 4 Alasan)</a:t>
-            </a:r>
+            <a:endParaRPr lang="en-ID"/>
           </a:p>
         </p:txBody>
       </p:sp>
-      <p:pic>
-        <p:nvPicPr>
-          <p:cNvPr id="3" name="Picture 2" descr="treemap_img_jdclackd.png"/>
-          <p:cNvPicPr>
-            <a:picLocks noChangeAspect="1"/>
-          </p:cNvPicPr>
-          <p:nvPr/>
-        </p:nvPicPr>
-        <p:blipFill>
-          <a:blip r:embed="rId4"/>
-          <a:stretch>
-            <a:fillRect/>
-          </a:stretch>
-        </p:blipFill>
-        <p:spPr>
-          <a:xfrm>
-            <a:off x="411480" y="1005840"/>
-            <a:ext cx="8183879" cy="3520440"/>
-          </a:xfrm>
-          <a:prstGeom prst="rect">
-            <a:avLst/>
-          </a:prstGeom>
-        </p:spPr>
-      </p:pic>
     </p:spTree>
     <p:extLst>
       <p:ext uri="{BB962C8B-B14F-4D97-AF65-F5344CB8AC3E}">
@@ -8414,75 +7744,31 @@
       </p:grpSpPr>
       <p:sp>
         <p:nvSpPr>
-          <p:cNvPr id="2" name="TextBox 1"/>
-          <p:cNvSpPr txBox="1"/>
-          <p:nvPr/>
+          <p:cNvPr id="5" name="Title 4">
+            <a:extLst>
+              <a:ext uri="{FF2B5EF4-FFF2-40B4-BE49-F238E27FC236}">
+                <a16:creationId xmlns:a16="http://schemas.microsoft.com/office/drawing/2014/main" id="{E196858A-4023-B6DB-00AB-50C0755CDF35}"/>
+              </a:ext>
+            </a:extLst>
+          </p:cNvPr>
+          <p:cNvSpPr>
+            <a:spLocks noGrp="1"/>
+          </p:cNvSpPr>
+          <p:nvPr>
+            <p:ph type="title"/>
+          </p:nvPr>
         </p:nvSpPr>
-        <p:spPr>
-          <a:xfrm>
-            <a:off x="411480" y="365760"/>
-            <a:ext cx="6858000" cy="594360"/>
-          </a:xfrm>
-          <a:prstGeom prst="rect">
-            <a:avLst/>
-          </a:prstGeom>
-          <a:noFill/>
-        </p:spPr>
+        <p:spPr/>
         <p:txBody>
-          <a:bodyPr wrap="square">
-            <a:spAutoFit/>
+          <a:bodyPr>
+            <a:normAutofit fontScale="90000"/>
           </a:bodyPr>
           <a:lstStyle/>
           <a:p>
-            <a:pPr>
-              <a:defRPr sz="1600" b="1">
-                <a:solidFill>
-                  <a:srgbClr val="C00000"/>
-                </a:solidFill>
-              </a:defRPr>
-            </a:pPr>
-            <a:r>
-              <a:t>3.1 ANALISIS PARETO UNFULLFILL - AKUN MTM ALIAS (AGU-2026)</a:t>
-            </a:r>
-          </a:p>
-          <a:p>
-            <a:pPr>
-              <a:defRPr sz="850" b="1">
-                <a:solidFill>
-                  <a:srgbClr val="646464"/>
-                </a:solidFill>
-              </a:defRPr>
-            </a:pPr>
-            <a:r>
-              <a:t>📌 Filter Aktif: Bulan = AGU-2026 | MTM = KA | Pareto 80% (1 - 8 dari 8 Akun MTM)</a:t>
-            </a:r>
+            <a:endParaRPr lang="en-ID"/>
           </a:p>
         </p:txBody>
       </p:sp>
-      <p:pic>
-        <p:nvPicPr>
-          <p:cNvPr id="3" name="Picture 2" descr="treemap_img_bwexl7db.png"/>
-          <p:cNvPicPr>
-            <a:picLocks noChangeAspect="1"/>
-          </p:cNvPicPr>
-          <p:nvPr/>
-        </p:nvPicPr>
-        <p:blipFill>
-          <a:blip r:embed="rId4"/>
-          <a:stretch>
-            <a:fillRect/>
-          </a:stretch>
-        </p:blipFill>
-        <p:spPr>
-          <a:xfrm>
-            <a:off x="411480" y="1005840"/>
-            <a:ext cx="8183879" cy="3520440"/>
-          </a:xfrm>
-          <a:prstGeom prst="rect">
-            <a:avLst/>
-          </a:prstGeom>
-        </p:spPr>
-      </p:pic>
     </p:spTree>
     <p:extLst>
       <p:ext uri="{BB962C8B-B14F-4D97-AF65-F5344CB8AC3E}">
@@ -8532,75 +7818,31 @@
       </p:grpSpPr>
       <p:sp>
         <p:nvSpPr>
-          <p:cNvPr id="2" name="TextBox 1"/>
-          <p:cNvSpPr txBox="1"/>
-          <p:nvPr/>
+          <p:cNvPr id="5" name="Title 4">
+            <a:extLst>
+              <a:ext uri="{FF2B5EF4-FFF2-40B4-BE49-F238E27FC236}">
+                <a16:creationId xmlns:a16="http://schemas.microsoft.com/office/drawing/2014/main" id="{69DF9688-34DB-E4BC-A280-3B02F34F36AB}"/>
+              </a:ext>
+            </a:extLst>
+          </p:cNvPr>
+          <p:cNvSpPr>
+            <a:spLocks noGrp="1"/>
+          </p:cNvSpPr>
+          <p:nvPr>
+            <p:ph type="title"/>
+          </p:nvPr>
         </p:nvSpPr>
-        <p:spPr>
-          <a:xfrm>
-            <a:off x="411480" y="365760"/>
-            <a:ext cx="6858000" cy="594360"/>
-          </a:xfrm>
-          <a:prstGeom prst="rect">
-            <a:avLst/>
-          </a:prstGeom>
-          <a:noFill/>
-        </p:spPr>
+        <p:spPr/>
         <p:txBody>
-          <a:bodyPr wrap="square">
-            <a:spAutoFit/>
+          <a:bodyPr>
+            <a:normAutofit fontScale="90000"/>
           </a:bodyPr>
           <a:lstStyle/>
           <a:p>
-            <a:pPr>
-              <a:defRPr sz="1600" b="1">
-                <a:solidFill>
-                  <a:srgbClr val="C00000"/>
-                </a:solidFill>
-              </a:defRPr>
-            </a:pPr>
-            <a:r>
-              <a:t>4.1 ANALISIS PARETO UNFULLFILL - NAMA CABANG (AGU-2026)</a:t>
-            </a:r>
-          </a:p>
-          <a:p>
-            <a:pPr>
-              <a:defRPr sz="850" b="1">
-                <a:solidFill>
-                  <a:srgbClr val="646464"/>
-                </a:solidFill>
-              </a:defRPr>
-            </a:pPr>
-            <a:r>
-              <a:t>📌 Filter Aktif: Bulan = AGU-2026 | MTM = KA | Pareto 80% (1 - 16 dari 16 Cabang)</a:t>
-            </a:r>
+            <a:endParaRPr lang="en-ID"/>
           </a:p>
         </p:txBody>
       </p:sp>
-      <p:pic>
-        <p:nvPicPr>
-          <p:cNvPr id="3" name="Picture 2" descr="treemap_img_5_jnvfv1.png"/>
-          <p:cNvPicPr>
-            <a:picLocks noChangeAspect="1"/>
-          </p:cNvPicPr>
-          <p:nvPr/>
-        </p:nvPicPr>
-        <p:blipFill>
-          <a:blip r:embed="rId4"/>
-          <a:stretch>
-            <a:fillRect/>
-          </a:stretch>
-        </p:blipFill>
-        <p:spPr>
-          <a:xfrm>
-            <a:off x="411480" y="1005840"/>
-            <a:ext cx="8183879" cy="3520440"/>
-          </a:xfrm>
-          <a:prstGeom prst="rect">
-            <a:avLst/>
-          </a:prstGeom>
-        </p:spPr>
-      </p:pic>
     </p:spTree>
     <p:extLst>
       <p:ext uri="{BB962C8B-B14F-4D97-AF65-F5344CB8AC3E}">
@@ -8650,75 +7892,31 @@
       </p:grpSpPr>
       <p:sp>
         <p:nvSpPr>
-          <p:cNvPr id="2" name="TextBox 1"/>
-          <p:cNvSpPr txBox="1"/>
-          <p:nvPr/>
+          <p:cNvPr id="5" name="Title 4">
+            <a:extLst>
+              <a:ext uri="{FF2B5EF4-FFF2-40B4-BE49-F238E27FC236}">
+                <a16:creationId xmlns:a16="http://schemas.microsoft.com/office/drawing/2014/main" id="{7BD5FA52-ACF5-861A-3BC7-5496629EAA8D}"/>
+              </a:ext>
+            </a:extLst>
+          </p:cNvPr>
+          <p:cNvSpPr>
+            <a:spLocks noGrp="1"/>
+          </p:cNvSpPr>
+          <p:nvPr>
+            <p:ph type="title"/>
+          </p:nvPr>
         </p:nvSpPr>
-        <p:spPr>
-          <a:xfrm>
-            <a:off x="411480" y="365760"/>
-            <a:ext cx="6858000" cy="594360"/>
-          </a:xfrm>
-          <a:prstGeom prst="rect">
-            <a:avLst/>
-          </a:prstGeom>
-          <a:noFill/>
-        </p:spPr>
+        <p:spPr/>
         <p:txBody>
-          <a:bodyPr wrap="square">
-            <a:spAutoFit/>
+          <a:bodyPr>
+            <a:normAutofit fontScale="90000"/>
           </a:bodyPr>
           <a:lstStyle/>
           <a:p>
-            <a:pPr>
-              <a:defRPr sz="1600" b="1">
-                <a:solidFill>
-                  <a:srgbClr val="C00000"/>
-                </a:solidFill>
-              </a:defRPr>
-            </a:pPr>
-            <a:r>
-              <a:t>5.1 ANALISIS PARETO UNFULLFILL - GRUP BRAND (AGU-2026)</a:t>
-            </a:r>
-          </a:p>
-          <a:p>
-            <a:pPr>
-              <a:defRPr sz="850" b="1">
-                <a:solidFill>
-                  <a:srgbClr val="646464"/>
-                </a:solidFill>
-              </a:defRPr>
-            </a:pPr>
-            <a:r>
-              <a:t>📌 Filter Aktif: Bulan = AGU-2026 | MTM = KA | Pareto 80% (1 - 3 dari 3 Grup Brand)</a:t>
-            </a:r>
+            <a:endParaRPr lang="en-ID"/>
           </a:p>
         </p:txBody>
       </p:sp>
-      <p:pic>
-        <p:nvPicPr>
-          <p:cNvPr id="3" name="Picture 2" descr="treemap_img_i9pt5cdl.png"/>
-          <p:cNvPicPr>
-            <a:picLocks noChangeAspect="1"/>
-          </p:cNvPicPr>
-          <p:nvPr/>
-        </p:nvPicPr>
-        <p:blipFill>
-          <a:blip r:embed="rId4"/>
-          <a:stretch>
-            <a:fillRect/>
-          </a:stretch>
-        </p:blipFill>
-        <p:spPr>
-          <a:xfrm>
-            <a:off x="411480" y="1005840"/>
-            <a:ext cx="8183879" cy="3520440"/>
-          </a:xfrm>
-          <a:prstGeom prst="rect">
-            <a:avLst/>
-          </a:prstGeom>
-        </p:spPr>
-      </p:pic>
     </p:spTree>
     <p:extLst>
       <p:ext uri="{BB962C8B-B14F-4D97-AF65-F5344CB8AC3E}">
@@ -8768,79 +7966,109 @@
       </p:grpSpPr>
       <p:sp>
         <p:nvSpPr>
-          <p:cNvPr id="2" name="TextBox 1"/>
-          <p:cNvSpPr txBox="1"/>
-          <p:nvPr/>
+          <p:cNvPr id="5" name="Title 4">
+            <a:extLst>
+              <a:ext uri="{FF2B5EF4-FFF2-40B4-BE49-F238E27FC236}">
+                <a16:creationId xmlns:a16="http://schemas.microsoft.com/office/drawing/2014/main" id="{3CA01E7A-A4B2-825F-EFCB-B17EEF593A53}"/>
+              </a:ext>
+            </a:extLst>
+          </p:cNvPr>
+          <p:cNvSpPr>
+            <a:spLocks noGrp="1"/>
+          </p:cNvSpPr>
+          <p:nvPr>
+            <p:ph type="title"/>
+          </p:nvPr>
         </p:nvSpPr>
-        <p:spPr>
-          <a:xfrm>
-            <a:off x="411480" y="365760"/>
-            <a:ext cx="6858000" cy="594360"/>
-          </a:xfrm>
-          <a:prstGeom prst="rect">
-            <a:avLst/>
-          </a:prstGeom>
-          <a:noFill/>
-        </p:spPr>
+        <p:spPr/>
         <p:txBody>
-          <a:bodyPr wrap="square">
-            <a:spAutoFit/>
+          <a:bodyPr>
+            <a:normAutofit fontScale="90000"/>
           </a:bodyPr>
           <a:lstStyle/>
           <a:p>
-            <a:pPr>
-              <a:defRPr sz="1600" b="1">
-                <a:solidFill>
-                  <a:srgbClr val="C00000"/>
-                </a:solidFill>
-              </a:defRPr>
-            </a:pPr>
-            <a:r>
-              <a:t>6.1 ANALISIS PARETO UNFULLFILL - ITEM / PRODUK SKU (AGU-2026)</a:t>
-            </a:r>
-          </a:p>
-          <a:p>
-            <a:pPr>
-              <a:defRPr sz="850" b="1">
-                <a:solidFill>
-                  <a:srgbClr val="646464"/>
-                </a:solidFill>
-              </a:defRPr>
-            </a:pPr>
-            <a:r>
-              <a:t>📌 Filter Aktif: Bulan = AGU-2026 | MTM = KA | Pareto 80% (1 - 34 dari 34 Item SKU)</a:t>
-            </a:r>
+            <a:endParaRPr lang="en-ID"/>
           </a:p>
         </p:txBody>
       </p:sp>
-      <p:pic>
-        <p:nvPicPr>
-          <p:cNvPr id="3" name="Picture 2" descr="treemap_img_4hg09q00.png"/>
-          <p:cNvPicPr>
-            <a:picLocks noChangeAspect="1"/>
-          </p:cNvPicPr>
-          <p:nvPr/>
-        </p:nvPicPr>
-        <p:blipFill>
-          <a:blip r:embed="rId4"/>
-          <a:stretch>
-            <a:fillRect/>
-          </a:stretch>
-        </p:blipFill>
-        <p:spPr>
-          <a:xfrm>
-            <a:off x="411480" y="1005840"/>
-            <a:ext cx="8183879" cy="3520440"/>
-          </a:xfrm>
-          <a:prstGeom prst="rect">
-            <a:avLst/>
-          </a:prstGeom>
-        </p:spPr>
-      </p:pic>
     </p:spTree>
     <p:extLst>
       <p:ext uri="{BB962C8B-B14F-4D97-AF65-F5344CB8AC3E}">
         <p14:creationId xmlns:p14="http://schemas.microsoft.com/office/powerpoint/2010/main" val="2003159494"/>
+      </p:ext>
+    </p:extLst>
+  </p:cSld>
+  <p:clrMapOvr>
+    <a:masterClrMapping/>
+  </p:clrMapOvr>
+</p:sld>
+</file>
+
+<file path=ppt/slides/slide9.xml><?xml version="1.0" encoding="utf-8"?>
+<p:sld xmlns:a="http://schemas.openxmlformats.org/drawingml/2006/main" xmlns:r="http://schemas.openxmlformats.org/officeDocument/2006/relationships" xmlns:p="http://schemas.openxmlformats.org/presentationml/2006/main">
+  <p:cSld>
+    <p:bg>
+      <p:bgPr>
+        <a:blipFill>
+          <a:blip r:embed="rId3"/>
+          <a:stretch>
+            <a:fillRect/>
+          </a:stretch>
+        </a:blipFill>
+        <a:effectLst/>
+      </p:bgPr>
+    </p:bg>
+    <p:spTree>
+      <p:nvGrpSpPr>
+        <p:cNvPr id="1" name="Shape 65">
+          <a:extLst>
+            <a:ext uri="{FF2B5EF4-FFF2-40B4-BE49-F238E27FC236}">
+              <a16:creationId xmlns:a16="http://schemas.microsoft.com/office/drawing/2014/main" id="{8ECD8376-EC0C-5273-1D07-26C8C70BD0BF}"/>
+            </a:ext>
+          </a:extLst>
+        </p:cNvPr>
+        <p:cNvGrpSpPr/>
+        <p:nvPr/>
+      </p:nvGrpSpPr>
+      <p:grpSpPr>
+        <a:xfrm>
+          <a:off x="0" y="0"/>
+          <a:ext cx="0" cy="0"/>
+          <a:chOff x="0" y="0"/>
+          <a:chExt cx="0" cy="0"/>
+        </a:xfrm>
+      </p:grpSpPr>
+      <p:sp>
+        <p:nvSpPr>
+          <p:cNvPr id="5" name="Title 4">
+            <a:extLst>
+              <a:ext uri="{FF2B5EF4-FFF2-40B4-BE49-F238E27FC236}">
+                <a16:creationId xmlns:a16="http://schemas.microsoft.com/office/drawing/2014/main" id="{1BC8AB82-0014-868E-AB71-45EC83BCCB7E}"/>
+              </a:ext>
+            </a:extLst>
+          </p:cNvPr>
+          <p:cNvSpPr>
+            <a:spLocks noGrp="1"/>
+          </p:cNvSpPr>
+          <p:nvPr>
+            <p:ph type="title"/>
+          </p:nvPr>
+        </p:nvSpPr>
+        <p:spPr/>
+        <p:txBody>
+          <a:bodyPr>
+            <a:normAutofit fontScale="90000"/>
+          </a:bodyPr>
+          <a:lstStyle/>
+          <a:p>
+            <a:endParaRPr lang="en-ID"/>
+          </a:p>
+        </p:txBody>
+      </p:sp>
+    </p:spTree>
+    <p:extLst>
+      <p:ext uri="{BB962C8B-B14F-4D97-AF65-F5344CB8AC3E}">
+        <p14:creationId xmlns:p14="http://schemas.microsoft.com/office/powerpoint/2010/main" val="2060672620"/>
       </p:ext>
     </p:extLst>
   </p:cSld>

</xml_diff>